<commit_message>
Add slide backgrounds and design accents
Agent-Logs-Url: https://github.com/aniket-kanani-3107/aniket-kanani-3107.github.io/sessions/8b56a0f3-da14-44cc-93d3-26a566bcaf5e

Co-authored-by: aniket-kanani-3107 <268387354+aniket-kanani-3107@users.noreply.github.com>
</commit_message>
<xml_diff>
--- a/transfer-pricing-methods.pptx
+++ b/transfer-pricing-methods.pptx
@@ -3294,6 +3294,14 @@
 <file path=ppt/slides/slide1.xml><?xml version="1.0" encoding="utf-8"?>
 <p:sld xmlns:a="http://schemas.openxmlformats.org/drawingml/2006/main" xmlns:p="http://schemas.openxmlformats.org/presentationml/2006/main" xmlns:r="http://schemas.openxmlformats.org/officeDocument/2006/relationships">
   <p:cSld>
+    <p:bg>
+      <p:bgPr>
+        <a:solidFill>
+          <a:srgbClr val="F5F8FC"/>
+        </a:solidFill>
+        <a:effectLst/>
+      </p:bgPr>
+    </p:bg>
     <p:spTree>
       <p:nvGrpSpPr>
         <p:cNvPr id="1" name=""/>
@@ -3301,6 +3309,135 @@
         <p:nvPr/>
       </p:nvGrpSpPr>
       <p:grpSpPr/>
+      <p:sp>
+        <p:nvSpPr>
+          <p:cNvPr id="6" name="Oval 5"/>
+          <p:cNvSpPr/>
+          <p:nvPr/>
+        </p:nvSpPr>
+        <p:spPr>
+          <a:xfrm>
+            <a:off x="-1280160" y="4572000"/>
+            <a:ext cx="2926080" cy="2926080"/>
+          </a:xfrm>
+          <a:prstGeom prst="ellipse">
+            <a:avLst/>
+          </a:prstGeom>
+          <a:solidFill>
+            <a:srgbClr val="8CAAC8"/>
+          </a:solidFill>
+          <a:ln>
+            <a:noFill/>
+          </a:ln>
+        </p:spPr>
+        <p:style>
+          <a:lnRef idx="1">
+            <a:schemeClr val="accent1"/>
+          </a:lnRef>
+          <a:fillRef idx="3">
+            <a:schemeClr val="accent1"/>
+          </a:fillRef>
+          <a:effectRef idx="2">
+            <a:schemeClr val="accent1"/>
+          </a:effectRef>
+          <a:fontRef idx="minor">
+            <a:schemeClr val="lt1"/>
+          </a:fontRef>
+        </p:style>
+        <p:txBody>
+          <a:bodyPr rtlCol="0" anchor="ctr"/>
+          <a:lstStyle/>
+          <a:p>
+            <a:pPr algn="ctr"/>
+          </a:p>
+        </p:txBody>
+      </p:sp>
+      <p:sp>
+        <p:nvSpPr>
+          <p:cNvPr id="5" name="Oval 4"/>
+          <p:cNvSpPr/>
+          <p:nvPr/>
+        </p:nvSpPr>
+        <p:spPr>
+          <a:xfrm>
+            <a:off x="9722815" y="-822960"/>
+            <a:ext cx="3291840" cy="3291840"/>
+          </a:xfrm>
+          <a:prstGeom prst="ellipse">
+            <a:avLst/>
+          </a:prstGeom>
+          <a:solidFill>
+            <a:srgbClr val="005CA0"/>
+          </a:solidFill>
+          <a:ln>
+            <a:noFill/>
+          </a:ln>
+        </p:spPr>
+        <p:style>
+          <a:lnRef idx="1">
+            <a:schemeClr val="accent1"/>
+          </a:lnRef>
+          <a:fillRef idx="3">
+            <a:schemeClr val="accent1"/>
+          </a:fillRef>
+          <a:effectRef idx="2">
+            <a:schemeClr val="accent1"/>
+          </a:effectRef>
+          <a:fontRef idx="minor">
+            <a:schemeClr val="lt1"/>
+          </a:fontRef>
+        </p:style>
+        <p:txBody>
+          <a:bodyPr rtlCol="0" anchor="ctr"/>
+          <a:lstStyle/>
+          <a:p>
+            <a:pPr algn="ctr"/>
+          </a:p>
+        </p:txBody>
+      </p:sp>
+      <p:sp>
+        <p:nvSpPr>
+          <p:cNvPr id="4" name="Rectangle 3"/>
+          <p:cNvSpPr/>
+          <p:nvPr/>
+        </p:nvSpPr>
+        <p:spPr>
+          <a:xfrm>
+            <a:off x="0" y="0"/>
+            <a:ext cx="12191695" cy="256032"/>
+          </a:xfrm>
+          <a:prstGeom prst="rect">
+            <a:avLst/>
+          </a:prstGeom>
+          <a:solidFill>
+            <a:srgbClr val="005CA0"/>
+          </a:solidFill>
+          <a:ln>
+            <a:noFill/>
+          </a:ln>
+        </p:spPr>
+        <p:style>
+          <a:lnRef idx="1">
+            <a:schemeClr val="accent1"/>
+          </a:lnRef>
+          <a:fillRef idx="3">
+            <a:schemeClr val="accent1"/>
+          </a:fillRef>
+          <a:effectRef idx="2">
+            <a:schemeClr val="accent1"/>
+          </a:effectRef>
+          <a:fontRef idx="minor">
+            <a:schemeClr val="lt1"/>
+          </a:fontRef>
+        </p:style>
+        <p:txBody>
+          <a:bodyPr rtlCol="0" anchor="ctr"/>
+          <a:lstStyle/>
+          <a:p>
+            <a:pPr algn="ctr"/>
+          </a:p>
+        </p:txBody>
+      </p:sp>
       <p:sp>
         <p:nvSpPr>
           <p:cNvPr id="2" name="Title 1"/>
@@ -3384,6 +3521,14 @@
 <file path=ppt/slides/slide10.xml><?xml version="1.0" encoding="utf-8"?>
 <p:sld xmlns:a="http://schemas.openxmlformats.org/drawingml/2006/main" xmlns:p="http://schemas.openxmlformats.org/presentationml/2006/main" xmlns:r="http://schemas.openxmlformats.org/officeDocument/2006/relationships">
   <p:cSld>
+    <p:bg>
+      <p:bgPr>
+        <a:solidFill>
+          <a:srgbClr val="F5F8FC"/>
+        </a:solidFill>
+        <a:effectLst/>
+      </p:bgPr>
+    </p:bg>
     <p:spTree>
       <p:nvGrpSpPr>
         <p:cNvPr id="1" name=""/>
@@ -3391,6 +3536,135 @@
         <p:nvPr/>
       </p:nvGrpSpPr>
       <p:grpSpPr/>
+      <p:sp>
+        <p:nvSpPr>
+          <p:cNvPr id="6" name="Oval 5"/>
+          <p:cNvSpPr/>
+          <p:nvPr/>
+        </p:nvSpPr>
+        <p:spPr>
+          <a:xfrm>
+            <a:off x="-1280160" y="4572000"/>
+            <a:ext cx="2926080" cy="2926080"/>
+          </a:xfrm>
+          <a:prstGeom prst="ellipse">
+            <a:avLst/>
+          </a:prstGeom>
+          <a:solidFill>
+            <a:srgbClr val="8CAAC8"/>
+          </a:solidFill>
+          <a:ln>
+            <a:noFill/>
+          </a:ln>
+        </p:spPr>
+        <p:style>
+          <a:lnRef idx="1">
+            <a:schemeClr val="accent1"/>
+          </a:lnRef>
+          <a:fillRef idx="3">
+            <a:schemeClr val="accent1"/>
+          </a:fillRef>
+          <a:effectRef idx="2">
+            <a:schemeClr val="accent1"/>
+          </a:effectRef>
+          <a:fontRef idx="minor">
+            <a:schemeClr val="lt1"/>
+          </a:fontRef>
+        </p:style>
+        <p:txBody>
+          <a:bodyPr rtlCol="0" anchor="ctr"/>
+          <a:lstStyle/>
+          <a:p>
+            <a:pPr algn="ctr"/>
+          </a:p>
+        </p:txBody>
+      </p:sp>
+      <p:sp>
+        <p:nvSpPr>
+          <p:cNvPr id="5" name="Oval 4"/>
+          <p:cNvSpPr/>
+          <p:nvPr/>
+        </p:nvSpPr>
+        <p:spPr>
+          <a:xfrm>
+            <a:off x="9722815" y="-822960"/>
+            <a:ext cx="3291840" cy="3291840"/>
+          </a:xfrm>
+          <a:prstGeom prst="ellipse">
+            <a:avLst/>
+          </a:prstGeom>
+          <a:solidFill>
+            <a:srgbClr val="005CA0"/>
+          </a:solidFill>
+          <a:ln>
+            <a:noFill/>
+          </a:ln>
+        </p:spPr>
+        <p:style>
+          <a:lnRef idx="1">
+            <a:schemeClr val="accent1"/>
+          </a:lnRef>
+          <a:fillRef idx="3">
+            <a:schemeClr val="accent1"/>
+          </a:fillRef>
+          <a:effectRef idx="2">
+            <a:schemeClr val="accent1"/>
+          </a:effectRef>
+          <a:fontRef idx="minor">
+            <a:schemeClr val="lt1"/>
+          </a:fontRef>
+        </p:style>
+        <p:txBody>
+          <a:bodyPr rtlCol="0" anchor="ctr"/>
+          <a:lstStyle/>
+          <a:p>
+            <a:pPr algn="ctr"/>
+          </a:p>
+        </p:txBody>
+      </p:sp>
+      <p:sp>
+        <p:nvSpPr>
+          <p:cNvPr id="4" name="Rectangle 3"/>
+          <p:cNvSpPr/>
+          <p:nvPr/>
+        </p:nvSpPr>
+        <p:spPr>
+          <a:xfrm>
+            <a:off x="0" y="0"/>
+            <a:ext cx="12191695" cy="256032"/>
+          </a:xfrm>
+          <a:prstGeom prst="rect">
+            <a:avLst/>
+          </a:prstGeom>
+          <a:solidFill>
+            <a:srgbClr val="005CA0"/>
+          </a:solidFill>
+          <a:ln>
+            <a:noFill/>
+          </a:ln>
+        </p:spPr>
+        <p:style>
+          <a:lnRef idx="1">
+            <a:schemeClr val="accent1"/>
+          </a:lnRef>
+          <a:fillRef idx="3">
+            <a:schemeClr val="accent1"/>
+          </a:fillRef>
+          <a:effectRef idx="2">
+            <a:schemeClr val="accent1"/>
+          </a:effectRef>
+          <a:fontRef idx="minor">
+            <a:schemeClr val="lt1"/>
+          </a:fontRef>
+        </p:style>
+        <p:txBody>
+          <a:bodyPr rtlCol="0" anchor="ctr"/>
+          <a:lstStyle/>
+          <a:p>
+            <a:pPr algn="ctr"/>
+          </a:p>
+        </p:txBody>
+      </p:sp>
       <p:sp>
         <p:nvSpPr>
           <p:cNvPr id="2" name="Title 1"/>
@@ -3488,6 +3762,14 @@
 <file path=ppt/slides/slide11.xml><?xml version="1.0" encoding="utf-8"?>
 <p:sld xmlns:a="http://schemas.openxmlformats.org/drawingml/2006/main" xmlns:p="http://schemas.openxmlformats.org/presentationml/2006/main" xmlns:r="http://schemas.openxmlformats.org/officeDocument/2006/relationships">
   <p:cSld>
+    <p:bg>
+      <p:bgPr>
+        <a:solidFill>
+          <a:srgbClr val="F5F8FC"/>
+        </a:solidFill>
+        <a:effectLst/>
+      </p:bgPr>
+    </p:bg>
     <p:spTree>
       <p:nvGrpSpPr>
         <p:cNvPr id="1" name=""/>
@@ -3495,6 +3777,135 @@
         <p:nvPr/>
       </p:nvGrpSpPr>
       <p:grpSpPr/>
+      <p:sp>
+        <p:nvSpPr>
+          <p:cNvPr id="7" name="Oval 6"/>
+          <p:cNvSpPr/>
+          <p:nvPr/>
+        </p:nvSpPr>
+        <p:spPr>
+          <a:xfrm>
+            <a:off x="-1280160" y="4572000"/>
+            <a:ext cx="2926080" cy="2926080"/>
+          </a:xfrm>
+          <a:prstGeom prst="ellipse">
+            <a:avLst/>
+          </a:prstGeom>
+          <a:solidFill>
+            <a:srgbClr val="8CAAC8"/>
+          </a:solidFill>
+          <a:ln>
+            <a:noFill/>
+          </a:ln>
+        </p:spPr>
+        <p:style>
+          <a:lnRef idx="1">
+            <a:schemeClr val="accent1"/>
+          </a:lnRef>
+          <a:fillRef idx="3">
+            <a:schemeClr val="accent1"/>
+          </a:fillRef>
+          <a:effectRef idx="2">
+            <a:schemeClr val="accent1"/>
+          </a:effectRef>
+          <a:fontRef idx="minor">
+            <a:schemeClr val="lt1"/>
+          </a:fontRef>
+        </p:style>
+        <p:txBody>
+          <a:bodyPr rtlCol="0" anchor="ctr"/>
+          <a:lstStyle/>
+          <a:p>
+            <a:pPr algn="ctr"/>
+          </a:p>
+        </p:txBody>
+      </p:sp>
+      <p:sp>
+        <p:nvSpPr>
+          <p:cNvPr id="6" name="Oval 5"/>
+          <p:cNvSpPr/>
+          <p:nvPr/>
+        </p:nvSpPr>
+        <p:spPr>
+          <a:xfrm>
+            <a:off x="9722815" y="-822960"/>
+            <a:ext cx="3291840" cy="3291840"/>
+          </a:xfrm>
+          <a:prstGeom prst="ellipse">
+            <a:avLst/>
+          </a:prstGeom>
+          <a:solidFill>
+            <a:srgbClr val="005CA0"/>
+          </a:solidFill>
+          <a:ln>
+            <a:noFill/>
+          </a:ln>
+        </p:spPr>
+        <p:style>
+          <a:lnRef idx="1">
+            <a:schemeClr val="accent1"/>
+          </a:lnRef>
+          <a:fillRef idx="3">
+            <a:schemeClr val="accent1"/>
+          </a:fillRef>
+          <a:effectRef idx="2">
+            <a:schemeClr val="accent1"/>
+          </a:effectRef>
+          <a:fontRef idx="minor">
+            <a:schemeClr val="lt1"/>
+          </a:fontRef>
+        </p:style>
+        <p:txBody>
+          <a:bodyPr rtlCol="0" anchor="ctr"/>
+          <a:lstStyle/>
+          <a:p>
+            <a:pPr algn="ctr"/>
+          </a:p>
+        </p:txBody>
+      </p:sp>
+      <p:sp>
+        <p:nvSpPr>
+          <p:cNvPr id="5" name="Rectangle 4"/>
+          <p:cNvSpPr/>
+          <p:nvPr/>
+        </p:nvSpPr>
+        <p:spPr>
+          <a:xfrm>
+            <a:off x="0" y="0"/>
+            <a:ext cx="12191695" cy="256032"/>
+          </a:xfrm>
+          <a:prstGeom prst="rect">
+            <a:avLst/>
+          </a:prstGeom>
+          <a:solidFill>
+            <a:srgbClr val="005CA0"/>
+          </a:solidFill>
+          <a:ln>
+            <a:noFill/>
+          </a:ln>
+        </p:spPr>
+        <p:style>
+          <a:lnRef idx="1">
+            <a:schemeClr val="accent1"/>
+          </a:lnRef>
+          <a:fillRef idx="3">
+            <a:schemeClr val="accent1"/>
+          </a:fillRef>
+          <a:effectRef idx="2">
+            <a:schemeClr val="accent1"/>
+          </a:effectRef>
+          <a:fontRef idx="minor">
+            <a:schemeClr val="lt1"/>
+          </a:fontRef>
+        </p:style>
+        <p:txBody>
+          <a:bodyPr rtlCol="0" anchor="ctr"/>
+          <a:lstStyle/>
+          <a:p>
+            <a:pPr algn="ctr"/>
+          </a:p>
+        </p:txBody>
+      </p:sp>
       <p:sp>
         <p:nvSpPr>
           <p:cNvPr id="2" name="Title 1"/>
@@ -3615,6 +4026,14 @@
 <file path=ppt/slides/slide12.xml><?xml version="1.0" encoding="utf-8"?>
 <p:sld xmlns:a="http://schemas.openxmlformats.org/drawingml/2006/main" xmlns:p="http://schemas.openxmlformats.org/presentationml/2006/main" xmlns:r="http://schemas.openxmlformats.org/officeDocument/2006/relationships">
   <p:cSld>
+    <p:bg>
+      <p:bgPr>
+        <a:solidFill>
+          <a:srgbClr val="F5F8FC"/>
+        </a:solidFill>
+        <a:effectLst/>
+      </p:bgPr>
+    </p:bg>
     <p:spTree>
       <p:nvGrpSpPr>
         <p:cNvPr id="1" name=""/>
@@ -3622,6 +4041,135 @@
         <p:nvPr/>
       </p:nvGrpSpPr>
       <p:grpSpPr/>
+      <p:sp>
+        <p:nvSpPr>
+          <p:cNvPr id="7" name="Oval 6"/>
+          <p:cNvSpPr/>
+          <p:nvPr/>
+        </p:nvSpPr>
+        <p:spPr>
+          <a:xfrm>
+            <a:off x="-1280160" y="4572000"/>
+            <a:ext cx="2926080" cy="2926080"/>
+          </a:xfrm>
+          <a:prstGeom prst="ellipse">
+            <a:avLst/>
+          </a:prstGeom>
+          <a:solidFill>
+            <a:srgbClr val="8CAAC8"/>
+          </a:solidFill>
+          <a:ln>
+            <a:noFill/>
+          </a:ln>
+        </p:spPr>
+        <p:style>
+          <a:lnRef idx="1">
+            <a:schemeClr val="accent1"/>
+          </a:lnRef>
+          <a:fillRef idx="3">
+            <a:schemeClr val="accent1"/>
+          </a:fillRef>
+          <a:effectRef idx="2">
+            <a:schemeClr val="accent1"/>
+          </a:effectRef>
+          <a:fontRef idx="minor">
+            <a:schemeClr val="lt1"/>
+          </a:fontRef>
+        </p:style>
+        <p:txBody>
+          <a:bodyPr rtlCol="0" anchor="ctr"/>
+          <a:lstStyle/>
+          <a:p>
+            <a:pPr algn="ctr"/>
+          </a:p>
+        </p:txBody>
+      </p:sp>
+      <p:sp>
+        <p:nvSpPr>
+          <p:cNvPr id="6" name="Oval 5"/>
+          <p:cNvSpPr/>
+          <p:nvPr/>
+        </p:nvSpPr>
+        <p:spPr>
+          <a:xfrm>
+            <a:off x="9722815" y="-822960"/>
+            <a:ext cx="3291840" cy="3291840"/>
+          </a:xfrm>
+          <a:prstGeom prst="ellipse">
+            <a:avLst/>
+          </a:prstGeom>
+          <a:solidFill>
+            <a:srgbClr val="005CA0"/>
+          </a:solidFill>
+          <a:ln>
+            <a:noFill/>
+          </a:ln>
+        </p:spPr>
+        <p:style>
+          <a:lnRef idx="1">
+            <a:schemeClr val="accent1"/>
+          </a:lnRef>
+          <a:fillRef idx="3">
+            <a:schemeClr val="accent1"/>
+          </a:fillRef>
+          <a:effectRef idx="2">
+            <a:schemeClr val="accent1"/>
+          </a:effectRef>
+          <a:fontRef idx="minor">
+            <a:schemeClr val="lt1"/>
+          </a:fontRef>
+        </p:style>
+        <p:txBody>
+          <a:bodyPr rtlCol="0" anchor="ctr"/>
+          <a:lstStyle/>
+          <a:p>
+            <a:pPr algn="ctr"/>
+          </a:p>
+        </p:txBody>
+      </p:sp>
+      <p:sp>
+        <p:nvSpPr>
+          <p:cNvPr id="5" name="Rectangle 4"/>
+          <p:cNvSpPr/>
+          <p:nvPr/>
+        </p:nvSpPr>
+        <p:spPr>
+          <a:xfrm>
+            <a:off x="0" y="0"/>
+            <a:ext cx="12191695" cy="256032"/>
+          </a:xfrm>
+          <a:prstGeom prst="rect">
+            <a:avLst/>
+          </a:prstGeom>
+          <a:solidFill>
+            <a:srgbClr val="005CA0"/>
+          </a:solidFill>
+          <a:ln>
+            <a:noFill/>
+          </a:ln>
+        </p:spPr>
+        <p:style>
+          <a:lnRef idx="1">
+            <a:schemeClr val="accent1"/>
+          </a:lnRef>
+          <a:fillRef idx="3">
+            <a:schemeClr val="accent1"/>
+          </a:fillRef>
+          <a:effectRef idx="2">
+            <a:schemeClr val="accent1"/>
+          </a:effectRef>
+          <a:fontRef idx="minor">
+            <a:schemeClr val="lt1"/>
+          </a:fontRef>
+        </p:style>
+        <p:txBody>
+          <a:bodyPr rtlCol="0" anchor="ctr"/>
+          <a:lstStyle/>
+          <a:p>
+            <a:pPr algn="ctr"/>
+          </a:p>
+        </p:txBody>
+      </p:sp>
       <p:sp>
         <p:nvSpPr>
           <p:cNvPr id="2" name="Title 1"/>
@@ -3742,6 +4290,14 @@
 <file path=ppt/slides/slide13.xml><?xml version="1.0" encoding="utf-8"?>
 <p:sld xmlns:a="http://schemas.openxmlformats.org/drawingml/2006/main" xmlns:p="http://schemas.openxmlformats.org/presentationml/2006/main" xmlns:r="http://schemas.openxmlformats.org/officeDocument/2006/relationships">
   <p:cSld>
+    <p:bg>
+      <p:bgPr>
+        <a:solidFill>
+          <a:srgbClr val="F5F8FC"/>
+        </a:solidFill>
+        <a:effectLst/>
+      </p:bgPr>
+    </p:bg>
     <p:spTree>
       <p:nvGrpSpPr>
         <p:cNvPr id="1" name=""/>
@@ -3749,6 +4305,135 @@
         <p:nvPr/>
       </p:nvGrpSpPr>
       <p:grpSpPr/>
+      <p:sp>
+        <p:nvSpPr>
+          <p:cNvPr id="6" name="Oval 5"/>
+          <p:cNvSpPr/>
+          <p:nvPr/>
+        </p:nvSpPr>
+        <p:spPr>
+          <a:xfrm>
+            <a:off x="-1280160" y="4572000"/>
+            <a:ext cx="2926080" cy="2926080"/>
+          </a:xfrm>
+          <a:prstGeom prst="ellipse">
+            <a:avLst/>
+          </a:prstGeom>
+          <a:solidFill>
+            <a:srgbClr val="8CAAC8"/>
+          </a:solidFill>
+          <a:ln>
+            <a:noFill/>
+          </a:ln>
+        </p:spPr>
+        <p:style>
+          <a:lnRef idx="1">
+            <a:schemeClr val="accent1"/>
+          </a:lnRef>
+          <a:fillRef idx="3">
+            <a:schemeClr val="accent1"/>
+          </a:fillRef>
+          <a:effectRef idx="2">
+            <a:schemeClr val="accent1"/>
+          </a:effectRef>
+          <a:fontRef idx="minor">
+            <a:schemeClr val="lt1"/>
+          </a:fontRef>
+        </p:style>
+        <p:txBody>
+          <a:bodyPr rtlCol="0" anchor="ctr"/>
+          <a:lstStyle/>
+          <a:p>
+            <a:pPr algn="ctr"/>
+          </a:p>
+        </p:txBody>
+      </p:sp>
+      <p:sp>
+        <p:nvSpPr>
+          <p:cNvPr id="5" name="Oval 4"/>
+          <p:cNvSpPr/>
+          <p:nvPr/>
+        </p:nvSpPr>
+        <p:spPr>
+          <a:xfrm>
+            <a:off x="9722815" y="-822960"/>
+            <a:ext cx="3291840" cy="3291840"/>
+          </a:xfrm>
+          <a:prstGeom prst="ellipse">
+            <a:avLst/>
+          </a:prstGeom>
+          <a:solidFill>
+            <a:srgbClr val="005CA0"/>
+          </a:solidFill>
+          <a:ln>
+            <a:noFill/>
+          </a:ln>
+        </p:spPr>
+        <p:style>
+          <a:lnRef idx="1">
+            <a:schemeClr val="accent1"/>
+          </a:lnRef>
+          <a:fillRef idx="3">
+            <a:schemeClr val="accent1"/>
+          </a:fillRef>
+          <a:effectRef idx="2">
+            <a:schemeClr val="accent1"/>
+          </a:effectRef>
+          <a:fontRef idx="minor">
+            <a:schemeClr val="lt1"/>
+          </a:fontRef>
+        </p:style>
+        <p:txBody>
+          <a:bodyPr rtlCol="0" anchor="ctr"/>
+          <a:lstStyle/>
+          <a:p>
+            <a:pPr algn="ctr"/>
+          </a:p>
+        </p:txBody>
+      </p:sp>
+      <p:sp>
+        <p:nvSpPr>
+          <p:cNvPr id="4" name="Rectangle 3"/>
+          <p:cNvSpPr/>
+          <p:nvPr/>
+        </p:nvSpPr>
+        <p:spPr>
+          <a:xfrm>
+            <a:off x="0" y="0"/>
+            <a:ext cx="12191695" cy="256032"/>
+          </a:xfrm>
+          <a:prstGeom prst="rect">
+            <a:avLst/>
+          </a:prstGeom>
+          <a:solidFill>
+            <a:srgbClr val="005CA0"/>
+          </a:solidFill>
+          <a:ln>
+            <a:noFill/>
+          </a:ln>
+        </p:spPr>
+        <p:style>
+          <a:lnRef idx="1">
+            <a:schemeClr val="accent1"/>
+          </a:lnRef>
+          <a:fillRef idx="3">
+            <a:schemeClr val="accent1"/>
+          </a:fillRef>
+          <a:effectRef idx="2">
+            <a:schemeClr val="accent1"/>
+          </a:effectRef>
+          <a:fontRef idx="minor">
+            <a:schemeClr val="lt1"/>
+          </a:fontRef>
+        </p:style>
+        <p:txBody>
+          <a:bodyPr rtlCol="0" anchor="ctr"/>
+          <a:lstStyle/>
+          <a:p>
+            <a:pPr algn="ctr"/>
+          </a:p>
+        </p:txBody>
+      </p:sp>
       <p:sp>
         <p:nvSpPr>
           <p:cNvPr id="2" name="Title 1"/>
@@ -3846,6 +4531,14 @@
 <file path=ppt/slides/slide14.xml><?xml version="1.0" encoding="utf-8"?>
 <p:sld xmlns:a="http://schemas.openxmlformats.org/drawingml/2006/main" xmlns:p="http://schemas.openxmlformats.org/presentationml/2006/main" xmlns:r="http://schemas.openxmlformats.org/officeDocument/2006/relationships">
   <p:cSld>
+    <p:bg>
+      <p:bgPr>
+        <a:solidFill>
+          <a:srgbClr val="F5F8FC"/>
+        </a:solidFill>
+        <a:effectLst/>
+      </p:bgPr>
+    </p:bg>
     <p:spTree>
       <p:nvGrpSpPr>
         <p:cNvPr id="1" name=""/>
@@ -3853,6 +4546,135 @@
         <p:nvPr/>
       </p:nvGrpSpPr>
       <p:grpSpPr/>
+      <p:sp>
+        <p:nvSpPr>
+          <p:cNvPr id="7" name="Oval 6"/>
+          <p:cNvSpPr/>
+          <p:nvPr/>
+        </p:nvSpPr>
+        <p:spPr>
+          <a:xfrm>
+            <a:off x="-1280160" y="4572000"/>
+            <a:ext cx="2926080" cy="2926080"/>
+          </a:xfrm>
+          <a:prstGeom prst="ellipse">
+            <a:avLst/>
+          </a:prstGeom>
+          <a:solidFill>
+            <a:srgbClr val="8CAAC8"/>
+          </a:solidFill>
+          <a:ln>
+            <a:noFill/>
+          </a:ln>
+        </p:spPr>
+        <p:style>
+          <a:lnRef idx="1">
+            <a:schemeClr val="accent1"/>
+          </a:lnRef>
+          <a:fillRef idx="3">
+            <a:schemeClr val="accent1"/>
+          </a:fillRef>
+          <a:effectRef idx="2">
+            <a:schemeClr val="accent1"/>
+          </a:effectRef>
+          <a:fontRef idx="minor">
+            <a:schemeClr val="lt1"/>
+          </a:fontRef>
+        </p:style>
+        <p:txBody>
+          <a:bodyPr rtlCol="0" anchor="ctr"/>
+          <a:lstStyle/>
+          <a:p>
+            <a:pPr algn="ctr"/>
+          </a:p>
+        </p:txBody>
+      </p:sp>
+      <p:sp>
+        <p:nvSpPr>
+          <p:cNvPr id="6" name="Oval 5"/>
+          <p:cNvSpPr/>
+          <p:nvPr/>
+        </p:nvSpPr>
+        <p:spPr>
+          <a:xfrm>
+            <a:off x="9722815" y="-822960"/>
+            <a:ext cx="3291840" cy="3291840"/>
+          </a:xfrm>
+          <a:prstGeom prst="ellipse">
+            <a:avLst/>
+          </a:prstGeom>
+          <a:solidFill>
+            <a:srgbClr val="005CA0"/>
+          </a:solidFill>
+          <a:ln>
+            <a:noFill/>
+          </a:ln>
+        </p:spPr>
+        <p:style>
+          <a:lnRef idx="1">
+            <a:schemeClr val="accent1"/>
+          </a:lnRef>
+          <a:fillRef idx="3">
+            <a:schemeClr val="accent1"/>
+          </a:fillRef>
+          <a:effectRef idx="2">
+            <a:schemeClr val="accent1"/>
+          </a:effectRef>
+          <a:fontRef idx="minor">
+            <a:schemeClr val="lt1"/>
+          </a:fontRef>
+        </p:style>
+        <p:txBody>
+          <a:bodyPr rtlCol="0" anchor="ctr"/>
+          <a:lstStyle/>
+          <a:p>
+            <a:pPr algn="ctr"/>
+          </a:p>
+        </p:txBody>
+      </p:sp>
+      <p:sp>
+        <p:nvSpPr>
+          <p:cNvPr id="5" name="Rectangle 4"/>
+          <p:cNvSpPr/>
+          <p:nvPr/>
+        </p:nvSpPr>
+        <p:spPr>
+          <a:xfrm>
+            <a:off x="0" y="0"/>
+            <a:ext cx="12191695" cy="256032"/>
+          </a:xfrm>
+          <a:prstGeom prst="rect">
+            <a:avLst/>
+          </a:prstGeom>
+          <a:solidFill>
+            <a:srgbClr val="005CA0"/>
+          </a:solidFill>
+          <a:ln>
+            <a:noFill/>
+          </a:ln>
+        </p:spPr>
+        <p:style>
+          <a:lnRef idx="1">
+            <a:schemeClr val="accent1"/>
+          </a:lnRef>
+          <a:fillRef idx="3">
+            <a:schemeClr val="accent1"/>
+          </a:fillRef>
+          <a:effectRef idx="2">
+            <a:schemeClr val="accent1"/>
+          </a:effectRef>
+          <a:fontRef idx="minor">
+            <a:schemeClr val="lt1"/>
+          </a:fontRef>
+        </p:style>
+        <p:txBody>
+          <a:bodyPr rtlCol="0" anchor="ctr"/>
+          <a:lstStyle/>
+          <a:p>
+            <a:pPr algn="ctr"/>
+          </a:p>
+        </p:txBody>
+      </p:sp>
       <p:sp>
         <p:nvSpPr>
           <p:cNvPr id="2" name="Title 1"/>
@@ -3979,6 +4801,14 @@
 <file path=ppt/slides/slide15.xml><?xml version="1.0" encoding="utf-8"?>
 <p:sld xmlns:a="http://schemas.openxmlformats.org/drawingml/2006/main" xmlns:p="http://schemas.openxmlformats.org/presentationml/2006/main" xmlns:r="http://schemas.openxmlformats.org/officeDocument/2006/relationships">
   <p:cSld>
+    <p:bg>
+      <p:bgPr>
+        <a:solidFill>
+          <a:srgbClr val="F5F8FC"/>
+        </a:solidFill>
+        <a:effectLst/>
+      </p:bgPr>
+    </p:bg>
     <p:spTree>
       <p:nvGrpSpPr>
         <p:cNvPr id="1" name=""/>
@@ -3986,6 +4816,135 @@
         <p:nvPr/>
       </p:nvGrpSpPr>
       <p:grpSpPr/>
+      <p:sp>
+        <p:nvSpPr>
+          <p:cNvPr id="6" name="Oval 5"/>
+          <p:cNvSpPr/>
+          <p:nvPr/>
+        </p:nvSpPr>
+        <p:spPr>
+          <a:xfrm>
+            <a:off x="-1280160" y="4572000"/>
+            <a:ext cx="2926080" cy="2926080"/>
+          </a:xfrm>
+          <a:prstGeom prst="ellipse">
+            <a:avLst/>
+          </a:prstGeom>
+          <a:solidFill>
+            <a:srgbClr val="8CAAC8"/>
+          </a:solidFill>
+          <a:ln>
+            <a:noFill/>
+          </a:ln>
+        </p:spPr>
+        <p:style>
+          <a:lnRef idx="1">
+            <a:schemeClr val="accent1"/>
+          </a:lnRef>
+          <a:fillRef idx="3">
+            <a:schemeClr val="accent1"/>
+          </a:fillRef>
+          <a:effectRef idx="2">
+            <a:schemeClr val="accent1"/>
+          </a:effectRef>
+          <a:fontRef idx="minor">
+            <a:schemeClr val="lt1"/>
+          </a:fontRef>
+        </p:style>
+        <p:txBody>
+          <a:bodyPr rtlCol="0" anchor="ctr"/>
+          <a:lstStyle/>
+          <a:p>
+            <a:pPr algn="ctr"/>
+          </a:p>
+        </p:txBody>
+      </p:sp>
+      <p:sp>
+        <p:nvSpPr>
+          <p:cNvPr id="5" name="Oval 4"/>
+          <p:cNvSpPr/>
+          <p:nvPr/>
+        </p:nvSpPr>
+        <p:spPr>
+          <a:xfrm>
+            <a:off x="9722815" y="-822960"/>
+            <a:ext cx="3291840" cy="3291840"/>
+          </a:xfrm>
+          <a:prstGeom prst="ellipse">
+            <a:avLst/>
+          </a:prstGeom>
+          <a:solidFill>
+            <a:srgbClr val="005CA0"/>
+          </a:solidFill>
+          <a:ln>
+            <a:noFill/>
+          </a:ln>
+        </p:spPr>
+        <p:style>
+          <a:lnRef idx="1">
+            <a:schemeClr val="accent1"/>
+          </a:lnRef>
+          <a:fillRef idx="3">
+            <a:schemeClr val="accent1"/>
+          </a:fillRef>
+          <a:effectRef idx="2">
+            <a:schemeClr val="accent1"/>
+          </a:effectRef>
+          <a:fontRef idx="minor">
+            <a:schemeClr val="lt1"/>
+          </a:fontRef>
+        </p:style>
+        <p:txBody>
+          <a:bodyPr rtlCol="0" anchor="ctr"/>
+          <a:lstStyle/>
+          <a:p>
+            <a:pPr algn="ctr"/>
+          </a:p>
+        </p:txBody>
+      </p:sp>
+      <p:sp>
+        <p:nvSpPr>
+          <p:cNvPr id="4" name="Rectangle 3"/>
+          <p:cNvSpPr/>
+          <p:nvPr/>
+        </p:nvSpPr>
+        <p:spPr>
+          <a:xfrm>
+            <a:off x="0" y="0"/>
+            <a:ext cx="12191695" cy="256032"/>
+          </a:xfrm>
+          <a:prstGeom prst="rect">
+            <a:avLst/>
+          </a:prstGeom>
+          <a:solidFill>
+            <a:srgbClr val="005CA0"/>
+          </a:solidFill>
+          <a:ln>
+            <a:noFill/>
+          </a:ln>
+        </p:spPr>
+        <p:style>
+          <a:lnRef idx="1">
+            <a:schemeClr val="accent1"/>
+          </a:lnRef>
+          <a:fillRef idx="3">
+            <a:schemeClr val="accent1"/>
+          </a:fillRef>
+          <a:effectRef idx="2">
+            <a:schemeClr val="accent1"/>
+          </a:effectRef>
+          <a:fontRef idx="minor">
+            <a:schemeClr val="lt1"/>
+          </a:fontRef>
+        </p:style>
+        <p:txBody>
+          <a:bodyPr rtlCol="0" anchor="ctr"/>
+          <a:lstStyle/>
+          <a:p>
+            <a:pPr algn="ctr"/>
+          </a:p>
+        </p:txBody>
+      </p:sp>
       <p:sp>
         <p:nvSpPr>
           <p:cNvPr id="2" name="Title 1"/>
@@ -4094,6 +5053,14 @@
 <file path=ppt/slides/slide2.xml><?xml version="1.0" encoding="utf-8"?>
 <p:sld xmlns:a="http://schemas.openxmlformats.org/drawingml/2006/main" xmlns:p="http://schemas.openxmlformats.org/presentationml/2006/main" xmlns:r="http://schemas.openxmlformats.org/officeDocument/2006/relationships">
   <p:cSld>
+    <p:bg>
+      <p:bgPr>
+        <a:solidFill>
+          <a:srgbClr val="F5F8FC"/>
+        </a:solidFill>
+        <a:effectLst/>
+      </p:bgPr>
+    </p:bg>
     <p:spTree>
       <p:nvGrpSpPr>
         <p:cNvPr id="1" name=""/>
@@ -4101,6 +5068,135 @@
         <p:nvPr/>
       </p:nvGrpSpPr>
       <p:grpSpPr/>
+      <p:sp>
+        <p:nvSpPr>
+          <p:cNvPr id="6" name="Oval 5"/>
+          <p:cNvSpPr/>
+          <p:nvPr/>
+        </p:nvSpPr>
+        <p:spPr>
+          <a:xfrm>
+            <a:off x="-1280160" y="4572000"/>
+            <a:ext cx="2926080" cy="2926080"/>
+          </a:xfrm>
+          <a:prstGeom prst="ellipse">
+            <a:avLst/>
+          </a:prstGeom>
+          <a:solidFill>
+            <a:srgbClr val="8CAAC8"/>
+          </a:solidFill>
+          <a:ln>
+            <a:noFill/>
+          </a:ln>
+        </p:spPr>
+        <p:style>
+          <a:lnRef idx="1">
+            <a:schemeClr val="accent1"/>
+          </a:lnRef>
+          <a:fillRef idx="3">
+            <a:schemeClr val="accent1"/>
+          </a:fillRef>
+          <a:effectRef idx="2">
+            <a:schemeClr val="accent1"/>
+          </a:effectRef>
+          <a:fontRef idx="minor">
+            <a:schemeClr val="lt1"/>
+          </a:fontRef>
+        </p:style>
+        <p:txBody>
+          <a:bodyPr rtlCol="0" anchor="ctr"/>
+          <a:lstStyle/>
+          <a:p>
+            <a:pPr algn="ctr"/>
+          </a:p>
+        </p:txBody>
+      </p:sp>
+      <p:sp>
+        <p:nvSpPr>
+          <p:cNvPr id="5" name="Oval 4"/>
+          <p:cNvSpPr/>
+          <p:nvPr/>
+        </p:nvSpPr>
+        <p:spPr>
+          <a:xfrm>
+            <a:off x="9722815" y="-822960"/>
+            <a:ext cx="3291840" cy="3291840"/>
+          </a:xfrm>
+          <a:prstGeom prst="ellipse">
+            <a:avLst/>
+          </a:prstGeom>
+          <a:solidFill>
+            <a:srgbClr val="005CA0"/>
+          </a:solidFill>
+          <a:ln>
+            <a:noFill/>
+          </a:ln>
+        </p:spPr>
+        <p:style>
+          <a:lnRef idx="1">
+            <a:schemeClr val="accent1"/>
+          </a:lnRef>
+          <a:fillRef idx="3">
+            <a:schemeClr val="accent1"/>
+          </a:fillRef>
+          <a:effectRef idx="2">
+            <a:schemeClr val="accent1"/>
+          </a:effectRef>
+          <a:fontRef idx="minor">
+            <a:schemeClr val="lt1"/>
+          </a:fontRef>
+        </p:style>
+        <p:txBody>
+          <a:bodyPr rtlCol="0" anchor="ctr"/>
+          <a:lstStyle/>
+          <a:p>
+            <a:pPr algn="ctr"/>
+          </a:p>
+        </p:txBody>
+      </p:sp>
+      <p:sp>
+        <p:nvSpPr>
+          <p:cNvPr id="4" name="Rectangle 3"/>
+          <p:cNvSpPr/>
+          <p:nvPr/>
+        </p:nvSpPr>
+        <p:spPr>
+          <a:xfrm>
+            <a:off x="0" y="0"/>
+            <a:ext cx="12191695" cy="256032"/>
+          </a:xfrm>
+          <a:prstGeom prst="rect">
+            <a:avLst/>
+          </a:prstGeom>
+          <a:solidFill>
+            <a:srgbClr val="005CA0"/>
+          </a:solidFill>
+          <a:ln>
+            <a:noFill/>
+          </a:ln>
+        </p:spPr>
+        <p:style>
+          <a:lnRef idx="1">
+            <a:schemeClr val="accent1"/>
+          </a:lnRef>
+          <a:fillRef idx="3">
+            <a:schemeClr val="accent1"/>
+          </a:fillRef>
+          <a:effectRef idx="2">
+            <a:schemeClr val="accent1"/>
+          </a:effectRef>
+          <a:fontRef idx="minor">
+            <a:schemeClr val="lt1"/>
+          </a:fontRef>
+        </p:style>
+        <p:txBody>
+          <a:bodyPr rtlCol="0" anchor="ctr"/>
+          <a:lstStyle/>
+          <a:p>
+            <a:pPr algn="ctr"/>
+          </a:p>
+        </p:txBody>
+      </p:sp>
       <p:sp>
         <p:nvSpPr>
           <p:cNvPr id="2" name="Title 1"/>
@@ -4209,6 +5305,14 @@
 <file path=ppt/slides/slide3.xml><?xml version="1.0" encoding="utf-8"?>
 <p:sld xmlns:a="http://schemas.openxmlformats.org/drawingml/2006/main" xmlns:p="http://schemas.openxmlformats.org/presentationml/2006/main" xmlns:r="http://schemas.openxmlformats.org/officeDocument/2006/relationships">
   <p:cSld>
+    <p:bg>
+      <p:bgPr>
+        <a:solidFill>
+          <a:srgbClr val="F5F8FC"/>
+        </a:solidFill>
+        <a:effectLst/>
+      </p:bgPr>
+    </p:bg>
     <p:spTree>
       <p:nvGrpSpPr>
         <p:cNvPr id="1" name=""/>
@@ -4216,6 +5320,135 @@
         <p:nvPr/>
       </p:nvGrpSpPr>
       <p:grpSpPr/>
+      <p:sp>
+        <p:nvSpPr>
+          <p:cNvPr id="9" name="Oval 8"/>
+          <p:cNvSpPr/>
+          <p:nvPr/>
+        </p:nvSpPr>
+        <p:spPr>
+          <a:xfrm>
+            <a:off x="-1280160" y="4572000"/>
+            <a:ext cx="2926080" cy="2926080"/>
+          </a:xfrm>
+          <a:prstGeom prst="ellipse">
+            <a:avLst/>
+          </a:prstGeom>
+          <a:solidFill>
+            <a:srgbClr val="8CAAC8"/>
+          </a:solidFill>
+          <a:ln>
+            <a:noFill/>
+          </a:ln>
+        </p:spPr>
+        <p:style>
+          <a:lnRef idx="1">
+            <a:schemeClr val="accent1"/>
+          </a:lnRef>
+          <a:fillRef idx="3">
+            <a:schemeClr val="accent1"/>
+          </a:fillRef>
+          <a:effectRef idx="2">
+            <a:schemeClr val="accent1"/>
+          </a:effectRef>
+          <a:fontRef idx="minor">
+            <a:schemeClr val="lt1"/>
+          </a:fontRef>
+        </p:style>
+        <p:txBody>
+          <a:bodyPr rtlCol="0" anchor="ctr"/>
+          <a:lstStyle/>
+          <a:p>
+            <a:pPr algn="ctr"/>
+          </a:p>
+        </p:txBody>
+      </p:sp>
+      <p:sp>
+        <p:nvSpPr>
+          <p:cNvPr id="8" name="Oval 7"/>
+          <p:cNvSpPr/>
+          <p:nvPr/>
+        </p:nvSpPr>
+        <p:spPr>
+          <a:xfrm>
+            <a:off x="9722815" y="-822960"/>
+            <a:ext cx="3291840" cy="3291840"/>
+          </a:xfrm>
+          <a:prstGeom prst="ellipse">
+            <a:avLst/>
+          </a:prstGeom>
+          <a:solidFill>
+            <a:srgbClr val="005CA0"/>
+          </a:solidFill>
+          <a:ln>
+            <a:noFill/>
+          </a:ln>
+        </p:spPr>
+        <p:style>
+          <a:lnRef idx="1">
+            <a:schemeClr val="accent1"/>
+          </a:lnRef>
+          <a:fillRef idx="3">
+            <a:schemeClr val="accent1"/>
+          </a:fillRef>
+          <a:effectRef idx="2">
+            <a:schemeClr val="accent1"/>
+          </a:effectRef>
+          <a:fontRef idx="minor">
+            <a:schemeClr val="lt1"/>
+          </a:fontRef>
+        </p:style>
+        <p:txBody>
+          <a:bodyPr rtlCol="0" anchor="ctr"/>
+          <a:lstStyle/>
+          <a:p>
+            <a:pPr algn="ctr"/>
+          </a:p>
+        </p:txBody>
+      </p:sp>
+      <p:sp>
+        <p:nvSpPr>
+          <p:cNvPr id="7" name="Rectangle 6"/>
+          <p:cNvSpPr/>
+          <p:nvPr/>
+        </p:nvSpPr>
+        <p:spPr>
+          <a:xfrm>
+            <a:off x="0" y="0"/>
+            <a:ext cx="12191695" cy="256032"/>
+          </a:xfrm>
+          <a:prstGeom prst="rect">
+            <a:avLst/>
+          </a:prstGeom>
+          <a:solidFill>
+            <a:srgbClr val="005CA0"/>
+          </a:solidFill>
+          <a:ln>
+            <a:noFill/>
+          </a:ln>
+        </p:spPr>
+        <p:style>
+          <a:lnRef idx="1">
+            <a:schemeClr val="accent1"/>
+          </a:lnRef>
+          <a:fillRef idx="3">
+            <a:schemeClr val="accent1"/>
+          </a:fillRef>
+          <a:effectRef idx="2">
+            <a:schemeClr val="accent1"/>
+          </a:effectRef>
+          <a:fontRef idx="minor">
+            <a:schemeClr val="lt1"/>
+          </a:fontRef>
+        </p:style>
+        <p:txBody>
+          <a:bodyPr rtlCol="0" anchor="ctr"/>
+          <a:lstStyle/>
+          <a:p>
+            <a:pPr algn="ctr"/>
+          </a:p>
+        </p:txBody>
+      </p:sp>
       <p:sp>
         <p:nvSpPr>
           <p:cNvPr id="2" name="Title 1"/>
@@ -4457,6 +5690,14 @@
 <file path=ppt/slides/slide4.xml><?xml version="1.0" encoding="utf-8"?>
 <p:sld xmlns:a="http://schemas.openxmlformats.org/drawingml/2006/main" xmlns:p="http://schemas.openxmlformats.org/presentationml/2006/main" xmlns:r="http://schemas.openxmlformats.org/officeDocument/2006/relationships">
   <p:cSld>
+    <p:bg>
+      <p:bgPr>
+        <a:solidFill>
+          <a:srgbClr val="F5F8FC"/>
+        </a:solidFill>
+        <a:effectLst/>
+      </p:bgPr>
+    </p:bg>
     <p:spTree>
       <p:nvGrpSpPr>
         <p:cNvPr id="1" name=""/>
@@ -4464,6 +5705,135 @@
         <p:nvPr/>
       </p:nvGrpSpPr>
       <p:grpSpPr/>
+      <p:sp>
+        <p:nvSpPr>
+          <p:cNvPr id="6" name="Oval 5"/>
+          <p:cNvSpPr/>
+          <p:nvPr/>
+        </p:nvSpPr>
+        <p:spPr>
+          <a:xfrm>
+            <a:off x="-1280160" y="4572000"/>
+            <a:ext cx="2926080" cy="2926080"/>
+          </a:xfrm>
+          <a:prstGeom prst="ellipse">
+            <a:avLst/>
+          </a:prstGeom>
+          <a:solidFill>
+            <a:srgbClr val="8CAAC8"/>
+          </a:solidFill>
+          <a:ln>
+            <a:noFill/>
+          </a:ln>
+        </p:spPr>
+        <p:style>
+          <a:lnRef idx="1">
+            <a:schemeClr val="accent1"/>
+          </a:lnRef>
+          <a:fillRef idx="3">
+            <a:schemeClr val="accent1"/>
+          </a:fillRef>
+          <a:effectRef idx="2">
+            <a:schemeClr val="accent1"/>
+          </a:effectRef>
+          <a:fontRef idx="minor">
+            <a:schemeClr val="lt1"/>
+          </a:fontRef>
+        </p:style>
+        <p:txBody>
+          <a:bodyPr rtlCol="0" anchor="ctr"/>
+          <a:lstStyle/>
+          <a:p>
+            <a:pPr algn="ctr"/>
+          </a:p>
+        </p:txBody>
+      </p:sp>
+      <p:sp>
+        <p:nvSpPr>
+          <p:cNvPr id="5" name="Oval 4"/>
+          <p:cNvSpPr/>
+          <p:nvPr/>
+        </p:nvSpPr>
+        <p:spPr>
+          <a:xfrm>
+            <a:off x="9722815" y="-822960"/>
+            <a:ext cx="3291840" cy="3291840"/>
+          </a:xfrm>
+          <a:prstGeom prst="ellipse">
+            <a:avLst/>
+          </a:prstGeom>
+          <a:solidFill>
+            <a:srgbClr val="005CA0"/>
+          </a:solidFill>
+          <a:ln>
+            <a:noFill/>
+          </a:ln>
+        </p:spPr>
+        <p:style>
+          <a:lnRef idx="1">
+            <a:schemeClr val="accent1"/>
+          </a:lnRef>
+          <a:fillRef idx="3">
+            <a:schemeClr val="accent1"/>
+          </a:fillRef>
+          <a:effectRef idx="2">
+            <a:schemeClr val="accent1"/>
+          </a:effectRef>
+          <a:fontRef idx="minor">
+            <a:schemeClr val="lt1"/>
+          </a:fontRef>
+        </p:style>
+        <p:txBody>
+          <a:bodyPr rtlCol="0" anchor="ctr"/>
+          <a:lstStyle/>
+          <a:p>
+            <a:pPr algn="ctr"/>
+          </a:p>
+        </p:txBody>
+      </p:sp>
+      <p:sp>
+        <p:nvSpPr>
+          <p:cNvPr id="4" name="Rectangle 3"/>
+          <p:cNvSpPr/>
+          <p:nvPr/>
+        </p:nvSpPr>
+        <p:spPr>
+          <a:xfrm>
+            <a:off x="0" y="0"/>
+            <a:ext cx="12191695" cy="256032"/>
+          </a:xfrm>
+          <a:prstGeom prst="rect">
+            <a:avLst/>
+          </a:prstGeom>
+          <a:solidFill>
+            <a:srgbClr val="005CA0"/>
+          </a:solidFill>
+          <a:ln>
+            <a:noFill/>
+          </a:ln>
+        </p:spPr>
+        <p:style>
+          <a:lnRef idx="1">
+            <a:schemeClr val="accent1"/>
+          </a:lnRef>
+          <a:fillRef idx="3">
+            <a:schemeClr val="accent1"/>
+          </a:fillRef>
+          <a:effectRef idx="2">
+            <a:schemeClr val="accent1"/>
+          </a:effectRef>
+          <a:fontRef idx="minor">
+            <a:schemeClr val="lt1"/>
+          </a:fontRef>
+        </p:style>
+        <p:txBody>
+          <a:bodyPr rtlCol="0" anchor="ctr"/>
+          <a:lstStyle/>
+          <a:p>
+            <a:pPr algn="ctr"/>
+          </a:p>
+        </p:txBody>
+      </p:sp>
       <p:sp>
         <p:nvSpPr>
           <p:cNvPr id="2" name="Title 1"/>
@@ -4572,6 +5942,14 @@
 <file path=ppt/slides/slide5.xml><?xml version="1.0" encoding="utf-8"?>
 <p:sld xmlns:a="http://schemas.openxmlformats.org/drawingml/2006/main" xmlns:p="http://schemas.openxmlformats.org/presentationml/2006/main" xmlns:r="http://schemas.openxmlformats.org/officeDocument/2006/relationships">
   <p:cSld>
+    <p:bg>
+      <p:bgPr>
+        <a:solidFill>
+          <a:srgbClr val="F5F8FC"/>
+        </a:solidFill>
+        <a:effectLst/>
+      </p:bgPr>
+    </p:bg>
     <p:spTree>
       <p:nvGrpSpPr>
         <p:cNvPr id="1" name=""/>
@@ -4579,6 +5957,135 @@
         <p:nvPr/>
       </p:nvGrpSpPr>
       <p:grpSpPr/>
+      <p:sp>
+        <p:nvSpPr>
+          <p:cNvPr id="6" name="Oval 5"/>
+          <p:cNvSpPr/>
+          <p:nvPr/>
+        </p:nvSpPr>
+        <p:spPr>
+          <a:xfrm>
+            <a:off x="-1280160" y="4572000"/>
+            <a:ext cx="2926080" cy="2926080"/>
+          </a:xfrm>
+          <a:prstGeom prst="ellipse">
+            <a:avLst/>
+          </a:prstGeom>
+          <a:solidFill>
+            <a:srgbClr val="8CAAC8"/>
+          </a:solidFill>
+          <a:ln>
+            <a:noFill/>
+          </a:ln>
+        </p:spPr>
+        <p:style>
+          <a:lnRef idx="1">
+            <a:schemeClr val="accent1"/>
+          </a:lnRef>
+          <a:fillRef idx="3">
+            <a:schemeClr val="accent1"/>
+          </a:fillRef>
+          <a:effectRef idx="2">
+            <a:schemeClr val="accent1"/>
+          </a:effectRef>
+          <a:fontRef idx="minor">
+            <a:schemeClr val="lt1"/>
+          </a:fontRef>
+        </p:style>
+        <p:txBody>
+          <a:bodyPr rtlCol="0" anchor="ctr"/>
+          <a:lstStyle/>
+          <a:p>
+            <a:pPr algn="ctr"/>
+          </a:p>
+        </p:txBody>
+      </p:sp>
+      <p:sp>
+        <p:nvSpPr>
+          <p:cNvPr id="5" name="Oval 4"/>
+          <p:cNvSpPr/>
+          <p:nvPr/>
+        </p:nvSpPr>
+        <p:spPr>
+          <a:xfrm>
+            <a:off x="9722815" y="-822960"/>
+            <a:ext cx="3291840" cy="3291840"/>
+          </a:xfrm>
+          <a:prstGeom prst="ellipse">
+            <a:avLst/>
+          </a:prstGeom>
+          <a:solidFill>
+            <a:srgbClr val="005CA0"/>
+          </a:solidFill>
+          <a:ln>
+            <a:noFill/>
+          </a:ln>
+        </p:spPr>
+        <p:style>
+          <a:lnRef idx="1">
+            <a:schemeClr val="accent1"/>
+          </a:lnRef>
+          <a:fillRef idx="3">
+            <a:schemeClr val="accent1"/>
+          </a:fillRef>
+          <a:effectRef idx="2">
+            <a:schemeClr val="accent1"/>
+          </a:effectRef>
+          <a:fontRef idx="minor">
+            <a:schemeClr val="lt1"/>
+          </a:fontRef>
+        </p:style>
+        <p:txBody>
+          <a:bodyPr rtlCol="0" anchor="ctr"/>
+          <a:lstStyle/>
+          <a:p>
+            <a:pPr algn="ctr"/>
+          </a:p>
+        </p:txBody>
+      </p:sp>
+      <p:sp>
+        <p:nvSpPr>
+          <p:cNvPr id="4" name="Rectangle 3"/>
+          <p:cNvSpPr/>
+          <p:nvPr/>
+        </p:nvSpPr>
+        <p:spPr>
+          <a:xfrm>
+            <a:off x="0" y="0"/>
+            <a:ext cx="12191695" cy="256032"/>
+          </a:xfrm>
+          <a:prstGeom prst="rect">
+            <a:avLst/>
+          </a:prstGeom>
+          <a:solidFill>
+            <a:srgbClr val="005CA0"/>
+          </a:solidFill>
+          <a:ln>
+            <a:noFill/>
+          </a:ln>
+        </p:spPr>
+        <p:style>
+          <a:lnRef idx="1">
+            <a:schemeClr val="accent1"/>
+          </a:lnRef>
+          <a:fillRef idx="3">
+            <a:schemeClr val="accent1"/>
+          </a:fillRef>
+          <a:effectRef idx="2">
+            <a:schemeClr val="accent1"/>
+          </a:effectRef>
+          <a:fontRef idx="minor">
+            <a:schemeClr val="lt1"/>
+          </a:fontRef>
+        </p:style>
+        <p:txBody>
+          <a:bodyPr rtlCol="0" anchor="ctr"/>
+          <a:lstStyle/>
+          <a:p>
+            <a:pPr algn="ctr"/>
+          </a:p>
+        </p:txBody>
+      </p:sp>
       <p:sp>
         <p:nvSpPr>
           <p:cNvPr id="2" name="Title 1"/>
@@ -4676,6 +6183,14 @@
 <file path=ppt/slides/slide6.xml><?xml version="1.0" encoding="utf-8"?>
 <p:sld xmlns:a="http://schemas.openxmlformats.org/drawingml/2006/main" xmlns:p="http://schemas.openxmlformats.org/presentationml/2006/main" xmlns:r="http://schemas.openxmlformats.org/officeDocument/2006/relationships">
   <p:cSld>
+    <p:bg>
+      <p:bgPr>
+        <a:solidFill>
+          <a:srgbClr val="F5F8FC"/>
+        </a:solidFill>
+        <a:effectLst/>
+      </p:bgPr>
+    </p:bg>
     <p:spTree>
       <p:nvGrpSpPr>
         <p:cNvPr id="1" name=""/>
@@ -4683,6 +6198,135 @@
         <p:nvPr/>
       </p:nvGrpSpPr>
       <p:grpSpPr/>
+      <p:sp>
+        <p:nvSpPr>
+          <p:cNvPr id="6" name="Oval 5"/>
+          <p:cNvSpPr/>
+          <p:nvPr/>
+        </p:nvSpPr>
+        <p:spPr>
+          <a:xfrm>
+            <a:off x="-1280160" y="4572000"/>
+            <a:ext cx="2926080" cy="2926080"/>
+          </a:xfrm>
+          <a:prstGeom prst="ellipse">
+            <a:avLst/>
+          </a:prstGeom>
+          <a:solidFill>
+            <a:srgbClr val="8CAAC8"/>
+          </a:solidFill>
+          <a:ln>
+            <a:noFill/>
+          </a:ln>
+        </p:spPr>
+        <p:style>
+          <a:lnRef idx="1">
+            <a:schemeClr val="accent1"/>
+          </a:lnRef>
+          <a:fillRef idx="3">
+            <a:schemeClr val="accent1"/>
+          </a:fillRef>
+          <a:effectRef idx="2">
+            <a:schemeClr val="accent1"/>
+          </a:effectRef>
+          <a:fontRef idx="minor">
+            <a:schemeClr val="lt1"/>
+          </a:fontRef>
+        </p:style>
+        <p:txBody>
+          <a:bodyPr rtlCol="0" anchor="ctr"/>
+          <a:lstStyle/>
+          <a:p>
+            <a:pPr algn="ctr"/>
+          </a:p>
+        </p:txBody>
+      </p:sp>
+      <p:sp>
+        <p:nvSpPr>
+          <p:cNvPr id="5" name="Oval 4"/>
+          <p:cNvSpPr/>
+          <p:nvPr/>
+        </p:nvSpPr>
+        <p:spPr>
+          <a:xfrm>
+            <a:off x="9722815" y="-822960"/>
+            <a:ext cx="3291840" cy="3291840"/>
+          </a:xfrm>
+          <a:prstGeom prst="ellipse">
+            <a:avLst/>
+          </a:prstGeom>
+          <a:solidFill>
+            <a:srgbClr val="005CA0"/>
+          </a:solidFill>
+          <a:ln>
+            <a:noFill/>
+          </a:ln>
+        </p:spPr>
+        <p:style>
+          <a:lnRef idx="1">
+            <a:schemeClr val="accent1"/>
+          </a:lnRef>
+          <a:fillRef idx="3">
+            <a:schemeClr val="accent1"/>
+          </a:fillRef>
+          <a:effectRef idx="2">
+            <a:schemeClr val="accent1"/>
+          </a:effectRef>
+          <a:fontRef idx="minor">
+            <a:schemeClr val="lt1"/>
+          </a:fontRef>
+        </p:style>
+        <p:txBody>
+          <a:bodyPr rtlCol="0" anchor="ctr"/>
+          <a:lstStyle/>
+          <a:p>
+            <a:pPr algn="ctr"/>
+          </a:p>
+        </p:txBody>
+      </p:sp>
+      <p:sp>
+        <p:nvSpPr>
+          <p:cNvPr id="4" name="Rectangle 3"/>
+          <p:cNvSpPr/>
+          <p:nvPr/>
+        </p:nvSpPr>
+        <p:spPr>
+          <a:xfrm>
+            <a:off x="0" y="0"/>
+            <a:ext cx="12191695" cy="256032"/>
+          </a:xfrm>
+          <a:prstGeom prst="rect">
+            <a:avLst/>
+          </a:prstGeom>
+          <a:solidFill>
+            <a:srgbClr val="005CA0"/>
+          </a:solidFill>
+          <a:ln>
+            <a:noFill/>
+          </a:ln>
+        </p:spPr>
+        <p:style>
+          <a:lnRef idx="1">
+            <a:schemeClr val="accent1"/>
+          </a:lnRef>
+          <a:fillRef idx="3">
+            <a:schemeClr val="accent1"/>
+          </a:fillRef>
+          <a:effectRef idx="2">
+            <a:schemeClr val="accent1"/>
+          </a:effectRef>
+          <a:fontRef idx="minor">
+            <a:schemeClr val="lt1"/>
+          </a:fontRef>
+        </p:style>
+        <p:txBody>
+          <a:bodyPr rtlCol="0" anchor="ctr"/>
+          <a:lstStyle/>
+          <a:p>
+            <a:pPr algn="ctr"/>
+          </a:p>
+        </p:txBody>
+      </p:sp>
       <p:sp>
         <p:nvSpPr>
           <p:cNvPr id="2" name="Title 1"/>
@@ -4791,6 +6435,14 @@
 <file path=ppt/slides/slide7.xml><?xml version="1.0" encoding="utf-8"?>
 <p:sld xmlns:a="http://schemas.openxmlformats.org/drawingml/2006/main" xmlns:p="http://schemas.openxmlformats.org/presentationml/2006/main" xmlns:r="http://schemas.openxmlformats.org/officeDocument/2006/relationships">
   <p:cSld>
+    <p:bg>
+      <p:bgPr>
+        <a:solidFill>
+          <a:srgbClr val="F5F8FC"/>
+        </a:solidFill>
+        <a:effectLst/>
+      </p:bgPr>
+    </p:bg>
     <p:spTree>
       <p:nvGrpSpPr>
         <p:cNvPr id="1" name=""/>
@@ -4798,6 +6450,135 @@
         <p:nvPr/>
       </p:nvGrpSpPr>
       <p:grpSpPr/>
+      <p:sp>
+        <p:nvSpPr>
+          <p:cNvPr id="11" name="Oval 10"/>
+          <p:cNvSpPr/>
+          <p:nvPr/>
+        </p:nvSpPr>
+        <p:spPr>
+          <a:xfrm>
+            <a:off x="-1280160" y="4572000"/>
+            <a:ext cx="2926080" cy="2926080"/>
+          </a:xfrm>
+          <a:prstGeom prst="ellipse">
+            <a:avLst/>
+          </a:prstGeom>
+          <a:solidFill>
+            <a:srgbClr val="8CAAC8"/>
+          </a:solidFill>
+          <a:ln>
+            <a:noFill/>
+          </a:ln>
+        </p:spPr>
+        <p:style>
+          <a:lnRef idx="1">
+            <a:schemeClr val="accent1"/>
+          </a:lnRef>
+          <a:fillRef idx="3">
+            <a:schemeClr val="accent1"/>
+          </a:fillRef>
+          <a:effectRef idx="2">
+            <a:schemeClr val="accent1"/>
+          </a:effectRef>
+          <a:fontRef idx="minor">
+            <a:schemeClr val="lt1"/>
+          </a:fontRef>
+        </p:style>
+        <p:txBody>
+          <a:bodyPr rtlCol="0" anchor="ctr"/>
+          <a:lstStyle/>
+          <a:p>
+            <a:pPr algn="ctr"/>
+          </a:p>
+        </p:txBody>
+      </p:sp>
+      <p:sp>
+        <p:nvSpPr>
+          <p:cNvPr id="10" name="Oval 9"/>
+          <p:cNvSpPr/>
+          <p:nvPr/>
+        </p:nvSpPr>
+        <p:spPr>
+          <a:xfrm>
+            <a:off x="9722815" y="-822960"/>
+            <a:ext cx="3291840" cy="3291840"/>
+          </a:xfrm>
+          <a:prstGeom prst="ellipse">
+            <a:avLst/>
+          </a:prstGeom>
+          <a:solidFill>
+            <a:srgbClr val="005CA0"/>
+          </a:solidFill>
+          <a:ln>
+            <a:noFill/>
+          </a:ln>
+        </p:spPr>
+        <p:style>
+          <a:lnRef idx="1">
+            <a:schemeClr val="accent1"/>
+          </a:lnRef>
+          <a:fillRef idx="3">
+            <a:schemeClr val="accent1"/>
+          </a:fillRef>
+          <a:effectRef idx="2">
+            <a:schemeClr val="accent1"/>
+          </a:effectRef>
+          <a:fontRef idx="minor">
+            <a:schemeClr val="lt1"/>
+          </a:fontRef>
+        </p:style>
+        <p:txBody>
+          <a:bodyPr rtlCol="0" anchor="ctr"/>
+          <a:lstStyle/>
+          <a:p>
+            <a:pPr algn="ctr"/>
+          </a:p>
+        </p:txBody>
+      </p:sp>
+      <p:sp>
+        <p:nvSpPr>
+          <p:cNvPr id="9" name="Rectangle 8"/>
+          <p:cNvSpPr/>
+          <p:nvPr/>
+        </p:nvSpPr>
+        <p:spPr>
+          <a:xfrm>
+            <a:off x="0" y="0"/>
+            <a:ext cx="12191695" cy="256032"/>
+          </a:xfrm>
+          <a:prstGeom prst="rect">
+            <a:avLst/>
+          </a:prstGeom>
+          <a:solidFill>
+            <a:srgbClr val="005CA0"/>
+          </a:solidFill>
+          <a:ln>
+            <a:noFill/>
+          </a:ln>
+        </p:spPr>
+        <p:style>
+          <a:lnRef idx="1">
+            <a:schemeClr val="accent1"/>
+          </a:lnRef>
+          <a:fillRef idx="3">
+            <a:schemeClr val="accent1"/>
+          </a:fillRef>
+          <a:effectRef idx="2">
+            <a:schemeClr val="accent1"/>
+          </a:effectRef>
+          <a:fontRef idx="minor">
+            <a:schemeClr val="lt1"/>
+          </a:fontRef>
+        </p:style>
+        <p:txBody>
+          <a:bodyPr rtlCol="0" anchor="ctr"/>
+          <a:lstStyle/>
+          <a:p>
+            <a:pPr algn="ctr"/>
+          </a:p>
+        </p:txBody>
+      </p:sp>
       <p:sp>
         <p:nvSpPr>
           <p:cNvPr id="2" name="Title 1"/>
@@ -5137,6 +6918,14 @@
 <file path=ppt/slides/slide8.xml><?xml version="1.0" encoding="utf-8"?>
 <p:sld xmlns:a="http://schemas.openxmlformats.org/drawingml/2006/main" xmlns:p="http://schemas.openxmlformats.org/presentationml/2006/main" xmlns:r="http://schemas.openxmlformats.org/officeDocument/2006/relationships">
   <p:cSld>
+    <p:bg>
+      <p:bgPr>
+        <a:solidFill>
+          <a:srgbClr val="F5F8FC"/>
+        </a:solidFill>
+        <a:effectLst/>
+      </p:bgPr>
+    </p:bg>
     <p:spTree>
       <p:nvGrpSpPr>
         <p:cNvPr id="1" name=""/>
@@ -5144,6 +6933,135 @@
         <p:nvPr/>
       </p:nvGrpSpPr>
       <p:grpSpPr/>
+      <p:sp>
+        <p:nvSpPr>
+          <p:cNvPr id="6" name="Oval 5"/>
+          <p:cNvSpPr/>
+          <p:nvPr/>
+        </p:nvSpPr>
+        <p:spPr>
+          <a:xfrm>
+            <a:off x="-1280160" y="4572000"/>
+            <a:ext cx="2926080" cy="2926080"/>
+          </a:xfrm>
+          <a:prstGeom prst="ellipse">
+            <a:avLst/>
+          </a:prstGeom>
+          <a:solidFill>
+            <a:srgbClr val="8CAAC8"/>
+          </a:solidFill>
+          <a:ln>
+            <a:noFill/>
+          </a:ln>
+        </p:spPr>
+        <p:style>
+          <a:lnRef idx="1">
+            <a:schemeClr val="accent1"/>
+          </a:lnRef>
+          <a:fillRef idx="3">
+            <a:schemeClr val="accent1"/>
+          </a:fillRef>
+          <a:effectRef idx="2">
+            <a:schemeClr val="accent1"/>
+          </a:effectRef>
+          <a:fontRef idx="minor">
+            <a:schemeClr val="lt1"/>
+          </a:fontRef>
+        </p:style>
+        <p:txBody>
+          <a:bodyPr rtlCol="0" anchor="ctr"/>
+          <a:lstStyle/>
+          <a:p>
+            <a:pPr algn="ctr"/>
+          </a:p>
+        </p:txBody>
+      </p:sp>
+      <p:sp>
+        <p:nvSpPr>
+          <p:cNvPr id="5" name="Oval 4"/>
+          <p:cNvSpPr/>
+          <p:nvPr/>
+        </p:nvSpPr>
+        <p:spPr>
+          <a:xfrm>
+            <a:off x="9722815" y="-822960"/>
+            <a:ext cx="3291840" cy="3291840"/>
+          </a:xfrm>
+          <a:prstGeom prst="ellipse">
+            <a:avLst/>
+          </a:prstGeom>
+          <a:solidFill>
+            <a:srgbClr val="005CA0"/>
+          </a:solidFill>
+          <a:ln>
+            <a:noFill/>
+          </a:ln>
+        </p:spPr>
+        <p:style>
+          <a:lnRef idx="1">
+            <a:schemeClr val="accent1"/>
+          </a:lnRef>
+          <a:fillRef idx="3">
+            <a:schemeClr val="accent1"/>
+          </a:fillRef>
+          <a:effectRef idx="2">
+            <a:schemeClr val="accent1"/>
+          </a:effectRef>
+          <a:fontRef idx="minor">
+            <a:schemeClr val="lt1"/>
+          </a:fontRef>
+        </p:style>
+        <p:txBody>
+          <a:bodyPr rtlCol="0" anchor="ctr"/>
+          <a:lstStyle/>
+          <a:p>
+            <a:pPr algn="ctr"/>
+          </a:p>
+        </p:txBody>
+      </p:sp>
+      <p:sp>
+        <p:nvSpPr>
+          <p:cNvPr id="4" name="Rectangle 3"/>
+          <p:cNvSpPr/>
+          <p:nvPr/>
+        </p:nvSpPr>
+        <p:spPr>
+          <a:xfrm>
+            <a:off x="0" y="0"/>
+            <a:ext cx="12191695" cy="256032"/>
+          </a:xfrm>
+          <a:prstGeom prst="rect">
+            <a:avLst/>
+          </a:prstGeom>
+          <a:solidFill>
+            <a:srgbClr val="005CA0"/>
+          </a:solidFill>
+          <a:ln>
+            <a:noFill/>
+          </a:ln>
+        </p:spPr>
+        <p:style>
+          <a:lnRef idx="1">
+            <a:schemeClr val="accent1"/>
+          </a:lnRef>
+          <a:fillRef idx="3">
+            <a:schemeClr val="accent1"/>
+          </a:fillRef>
+          <a:effectRef idx="2">
+            <a:schemeClr val="accent1"/>
+          </a:effectRef>
+          <a:fontRef idx="minor">
+            <a:schemeClr val="lt1"/>
+          </a:fontRef>
+        </p:style>
+        <p:txBody>
+          <a:bodyPr rtlCol="0" anchor="ctr"/>
+          <a:lstStyle/>
+          <a:p>
+            <a:pPr algn="ctr"/>
+          </a:p>
+        </p:txBody>
+      </p:sp>
       <p:sp>
         <p:nvSpPr>
           <p:cNvPr id="2" name="Title 1"/>
@@ -5241,6 +7159,14 @@
 <file path=ppt/slides/slide9.xml><?xml version="1.0" encoding="utf-8"?>
 <p:sld xmlns:a="http://schemas.openxmlformats.org/drawingml/2006/main" xmlns:p="http://schemas.openxmlformats.org/presentationml/2006/main" xmlns:r="http://schemas.openxmlformats.org/officeDocument/2006/relationships">
   <p:cSld>
+    <p:bg>
+      <p:bgPr>
+        <a:solidFill>
+          <a:srgbClr val="F5F8FC"/>
+        </a:solidFill>
+        <a:effectLst/>
+      </p:bgPr>
+    </p:bg>
     <p:spTree>
       <p:nvGrpSpPr>
         <p:cNvPr id="1" name=""/>
@@ -5248,6 +7174,135 @@
         <p:nvPr/>
       </p:nvGrpSpPr>
       <p:grpSpPr/>
+      <p:sp>
+        <p:nvSpPr>
+          <p:cNvPr id="6" name="Oval 5"/>
+          <p:cNvSpPr/>
+          <p:nvPr/>
+        </p:nvSpPr>
+        <p:spPr>
+          <a:xfrm>
+            <a:off x="-1280160" y="4572000"/>
+            <a:ext cx="2926080" cy="2926080"/>
+          </a:xfrm>
+          <a:prstGeom prst="ellipse">
+            <a:avLst/>
+          </a:prstGeom>
+          <a:solidFill>
+            <a:srgbClr val="8CAAC8"/>
+          </a:solidFill>
+          <a:ln>
+            <a:noFill/>
+          </a:ln>
+        </p:spPr>
+        <p:style>
+          <a:lnRef idx="1">
+            <a:schemeClr val="accent1"/>
+          </a:lnRef>
+          <a:fillRef idx="3">
+            <a:schemeClr val="accent1"/>
+          </a:fillRef>
+          <a:effectRef idx="2">
+            <a:schemeClr val="accent1"/>
+          </a:effectRef>
+          <a:fontRef idx="minor">
+            <a:schemeClr val="lt1"/>
+          </a:fontRef>
+        </p:style>
+        <p:txBody>
+          <a:bodyPr rtlCol="0" anchor="ctr"/>
+          <a:lstStyle/>
+          <a:p>
+            <a:pPr algn="ctr"/>
+          </a:p>
+        </p:txBody>
+      </p:sp>
+      <p:sp>
+        <p:nvSpPr>
+          <p:cNvPr id="5" name="Oval 4"/>
+          <p:cNvSpPr/>
+          <p:nvPr/>
+        </p:nvSpPr>
+        <p:spPr>
+          <a:xfrm>
+            <a:off x="9722815" y="-822960"/>
+            <a:ext cx="3291840" cy="3291840"/>
+          </a:xfrm>
+          <a:prstGeom prst="ellipse">
+            <a:avLst/>
+          </a:prstGeom>
+          <a:solidFill>
+            <a:srgbClr val="005CA0"/>
+          </a:solidFill>
+          <a:ln>
+            <a:noFill/>
+          </a:ln>
+        </p:spPr>
+        <p:style>
+          <a:lnRef idx="1">
+            <a:schemeClr val="accent1"/>
+          </a:lnRef>
+          <a:fillRef idx="3">
+            <a:schemeClr val="accent1"/>
+          </a:fillRef>
+          <a:effectRef idx="2">
+            <a:schemeClr val="accent1"/>
+          </a:effectRef>
+          <a:fontRef idx="minor">
+            <a:schemeClr val="lt1"/>
+          </a:fontRef>
+        </p:style>
+        <p:txBody>
+          <a:bodyPr rtlCol="0" anchor="ctr"/>
+          <a:lstStyle/>
+          <a:p>
+            <a:pPr algn="ctr"/>
+          </a:p>
+        </p:txBody>
+      </p:sp>
+      <p:sp>
+        <p:nvSpPr>
+          <p:cNvPr id="4" name="Rectangle 3"/>
+          <p:cNvSpPr/>
+          <p:nvPr/>
+        </p:nvSpPr>
+        <p:spPr>
+          <a:xfrm>
+            <a:off x="0" y="0"/>
+            <a:ext cx="12191695" cy="256032"/>
+          </a:xfrm>
+          <a:prstGeom prst="rect">
+            <a:avLst/>
+          </a:prstGeom>
+          <a:solidFill>
+            <a:srgbClr val="005CA0"/>
+          </a:solidFill>
+          <a:ln>
+            <a:noFill/>
+          </a:ln>
+        </p:spPr>
+        <p:style>
+          <a:lnRef idx="1">
+            <a:schemeClr val="accent1"/>
+          </a:lnRef>
+          <a:fillRef idx="3">
+            <a:schemeClr val="accent1"/>
+          </a:fillRef>
+          <a:effectRef idx="2">
+            <a:schemeClr val="accent1"/>
+          </a:effectRef>
+          <a:fontRef idx="minor">
+            <a:schemeClr val="lt1"/>
+          </a:fontRef>
+        </p:style>
+        <p:txBody>
+          <a:bodyPr rtlCol="0" anchor="ctr"/>
+          <a:lstStyle/>
+          <a:p>
+            <a:pPr algn="ctr"/>
+          </a:p>
+        </p:txBody>
+      </p:sp>
       <p:sp>
         <p:nvSpPr>
           <p:cNvPr id="2" name="Title 1"/>

</xml_diff>

<commit_message>
Refine PPT visuals and title details
Agent-Logs-Url: https://github.com/aniket-kanani-3107/aniket-kanani-3107.github.io/sessions/a7438d69-3f6c-4257-b01a-be06262ead44

Co-authored-by: aniket-kanani-3107 <268387354+aniket-kanani-3107@users.noreply.github.com>
</commit_message>
<xml_diff>
--- a/transfer-pricing-methods.pptx
+++ b/transfer-pricing-methods.pptx
@@ -3297,7 +3297,7 @@
     <p:bg>
       <p:bgPr>
         <a:solidFill>
-          <a:srgbClr val="F5F8FC"/>
+          <a:srgbClr val="F8FAFC"/>
         </a:solidFill>
         <a:effectLst/>
       </p:bgPr>
@@ -3311,20 +3311,20 @@
       <p:grpSpPr/>
       <p:sp>
         <p:nvSpPr>
-          <p:cNvPr id="6" name="Oval 5"/>
+          <p:cNvPr id="7" name="Oval 6"/>
           <p:cNvSpPr/>
           <p:nvPr/>
         </p:nvSpPr>
         <p:spPr>
           <a:xfrm>
-            <a:off x="-1280160" y="4572000"/>
-            <a:ext cx="2926080" cy="2926080"/>
+            <a:off x="-1097280" y="4846320"/>
+            <a:ext cx="2743200" cy="2743200"/>
           </a:xfrm>
           <a:prstGeom prst="ellipse">
             <a:avLst/>
           </a:prstGeom>
           <a:solidFill>
-            <a:srgbClr val="8CAAC8"/>
+            <a:srgbClr val="CAD8E8"/>
           </a:solidFill>
           <a:ln>
             <a:noFill/>
@@ -3354,20 +3354,20 @@
       </p:sp>
       <p:sp>
         <p:nvSpPr>
-          <p:cNvPr id="5" name="Oval 4"/>
+          <p:cNvPr id="6" name="Oval 5"/>
           <p:cNvSpPr/>
           <p:nvPr/>
         </p:nvSpPr>
         <p:spPr>
           <a:xfrm>
-            <a:off x="9722815" y="-822960"/>
-            <a:ext cx="3291840" cy="3291840"/>
+            <a:off x="9631375" y="-914400"/>
+            <a:ext cx="2926080" cy="2926080"/>
           </a:xfrm>
           <a:prstGeom prst="ellipse">
             <a:avLst/>
           </a:prstGeom>
           <a:solidFill>
-            <a:srgbClr val="005CA0"/>
+            <a:srgbClr val="CAD8E8"/>
           </a:solidFill>
           <a:ln>
             <a:noFill/>
@@ -3397,6 +3397,49 @@
       </p:sp>
       <p:sp>
         <p:nvSpPr>
+          <p:cNvPr id="5" name="Rectangle 4"/>
+          <p:cNvSpPr/>
+          <p:nvPr/>
+        </p:nvSpPr>
+        <p:spPr>
+          <a:xfrm>
+            <a:off x="0" y="0"/>
+            <a:ext cx="12191695" cy="54864"/>
+          </a:xfrm>
+          <a:prstGeom prst="rect">
+            <a:avLst/>
+          </a:prstGeom>
+          <a:solidFill>
+            <a:srgbClr val="0B5394"/>
+          </a:solidFill>
+          <a:ln>
+            <a:noFill/>
+          </a:ln>
+        </p:spPr>
+        <p:style>
+          <a:lnRef idx="1">
+            <a:schemeClr val="accent1"/>
+          </a:lnRef>
+          <a:fillRef idx="3">
+            <a:schemeClr val="accent1"/>
+          </a:fillRef>
+          <a:effectRef idx="2">
+            <a:schemeClr val="accent1"/>
+          </a:effectRef>
+          <a:fontRef idx="minor">
+            <a:schemeClr val="lt1"/>
+          </a:fontRef>
+        </p:style>
+        <p:txBody>
+          <a:bodyPr rtlCol="0" anchor="ctr"/>
+          <a:lstStyle/>
+          <a:p>
+            <a:pPr algn="ctr"/>
+          </a:p>
+        </p:txBody>
+      </p:sp>
+      <p:sp>
+        <p:nvSpPr>
           <p:cNvPr id="4" name="Rectangle 3"/>
           <p:cNvSpPr/>
           <p:nvPr/>
@@ -3404,13 +3447,13 @@
         <p:spPr>
           <a:xfrm>
             <a:off x="0" y="0"/>
-            <a:ext cx="12191695" cy="256032"/>
+            <a:ext cx="256032" cy="6858000"/>
           </a:xfrm>
           <a:prstGeom prst="rect">
             <a:avLst/>
           </a:prstGeom>
           <a:solidFill>
-            <a:srgbClr val="005CA0"/>
+            <a:srgbClr val="0B5394"/>
           </a:solidFill>
           <a:ln>
             <a:noFill/>
@@ -3456,8 +3499,9 @@
             <a:r>
               <a:rPr sz="4400" b="1">
                 <a:solidFill>
-                  <a:srgbClr val="00467F"/>
-                </a:solidFill>
+                  <a:srgbClr val="0F3154"/>
+                </a:solidFill>
+                <a:latin typeface="Calibri"/>
               </a:rPr>
               <a:t>Introduction to International Tax Management</a:t>
             </a:r>
@@ -3480,32 +3524,46 @@
           <a:lstStyle/>
           <a:p>
             <a:r>
-              <a:rPr sz="2000" b="0">
-                <a:solidFill>
-                  <a:srgbClr val="5A5A5A"/>
-                </a:solidFill>
+              <a:rPr>
+                <a:solidFill>
+                  <a:srgbClr val="1F2937"/>
+                </a:solidFill>
+                <a:latin typeface="Calibri"/>
               </a:rPr>
               <a:t>Transfer Pricing Methods Acceptable by Tax Authorities</a:t>
             </a:r>
           </a:p>
           <a:p>
             <a:r>
-              <a:rPr sz="2000" b="0">
-                <a:solidFill>
-                  <a:srgbClr val="5A5A5A"/>
-                </a:solidFill>
-              </a:rPr>
-              <a:t>Course: Introduction to International Tax Management  |  Presenter: [Your Name]</a:t>
-            </a:r>
-          </a:p>
-          <a:p>
-            <a:r>
-              <a:rPr sz="2000" b="0">
-                <a:solidFill>
-                  <a:srgbClr val="5A5A5A"/>
-                </a:solidFill>
-              </a:rPr>
-              <a:t>University: [Your University]  |  Date: [Date]</a:t>
+              <a:rPr>
+                <a:solidFill>
+                  <a:srgbClr val="1F2937"/>
+                </a:solidFill>
+                <a:latin typeface="Calibri"/>
+              </a:rPr>
+              <a:t>Presenter: Aniket Kanani</a:t>
+            </a:r>
+          </a:p>
+          <a:p>
+            <a:r>
+              <a:rPr>
+                <a:solidFill>
+                  <a:srgbClr val="1F2937"/>
+                </a:solidFill>
+                <a:latin typeface="Calibri"/>
+              </a:rPr>
+              <a:t>Course: Introduction to International Tax Management</a:t>
+            </a:r>
+          </a:p>
+          <a:p>
+            <a:r>
+              <a:rPr>
+                <a:solidFill>
+                  <a:srgbClr val="1F2937"/>
+                </a:solidFill>
+                <a:latin typeface="Calibri"/>
+              </a:rPr>
+              <a:t>Date: April 29, 2026</a:t>
             </a:r>
           </a:p>
         </p:txBody>
@@ -3524,7 +3582,7 @@
     <p:bg>
       <p:bgPr>
         <a:solidFill>
-          <a:srgbClr val="F5F8FC"/>
+          <a:srgbClr val="F8FAFC"/>
         </a:solidFill>
         <a:effectLst/>
       </p:bgPr>
@@ -3538,20 +3596,20 @@
       <p:grpSpPr/>
       <p:sp>
         <p:nvSpPr>
-          <p:cNvPr id="6" name="Oval 5"/>
+          <p:cNvPr id="7" name="Oval 6"/>
           <p:cNvSpPr/>
           <p:nvPr/>
         </p:nvSpPr>
         <p:spPr>
           <a:xfrm>
-            <a:off x="-1280160" y="4572000"/>
-            <a:ext cx="2926080" cy="2926080"/>
+            <a:off x="-1097280" y="4846320"/>
+            <a:ext cx="2743200" cy="2743200"/>
           </a:xfrm>
           <a:prstGeom prst="ellipse">
             <a:avLst/>
           </a:prstGeom>
           <a:solidFill>
-            <a:srgbClr val="8CAAC8"/>
+            <a:srgbClr val="CAD8E8"/>
           </a:solidFill>
           <a:ln>
             <a:noFill/>
@@ -3581,20 +3639,20 @@
       </p:sp>
       <p:sp>
         <p:nvSpPr>
-          <p:cNvPr id="5" name="Oval 4"/>
+          <p:cNvPr id="6" name="Oval 5"/>
           <p:cNvSpPr/>
           <p:nvPr/>
         </p:nvSpPr>
         <p:spPr>
           <a:xfrm>
-            <a:off x="9722815" y="-822960"/>
-            <a:ext cx="3291840" cy="3291840"/>
+            <a:off x="9631375" y="-914400"/>
+            <a:ext cx="2926080" cy="2926080"/>
           </a:xfrm>
           <a:prstGeom prst="ellipse">
             <a:avLst/>
           </a:prstGeom>
           <a:solidFill>
-            <a:srgbClr val="005CA0"/>
+            <a:srgbClr val="CAD8E8"/>
           </a:solidFill>
           <a:ln>
             <a:noFill/>
@@ -3624,6 +3682,49 @@
       </p:sp>
       <p:sp>
         <p:nvSpPr>
+          <p:cNvPr id="5" name="Rectangle 4"/>
+          <p:cNvSpPr/>
+          <p:nvPr/>
+        </p:nvSpPr>
+        <p:spPr>
+          <a:xfrm>
+            <a:off x="0" y="0"/>
+            <a:ext cx="12191695" cy="54864"/>
+          </a:xfrm>
+          <a:prstGeom prst="rect">
+            <a:avLst/>
+          </a:prstGeom>
+          <a:solidFill>
+            <a:srgbClr val="0B5394"/>
+          </a:solidFill>
+          <a:ln>
+            <a:noFill/>
+          </a:ln>
+        </p:spPr>
+        <p:style>
+          <a:lnRef idx="1">
+            <a:schemeClr val="accent1"/>
+          </a:lnRef>
+          <a:fillRef idx="3">
+            <a:schemeClr val="accent1"/>
+          </a:fillRef>
+          <a:effectRef idx="2">
+            <a:schemeClr val="accent1"/>
+          </a:effectRef>
+          <a:fontRef idx="minor">
+            <a:schemeClr val="lt1"/>
+          </a:fontRef>
+        </p:style>
+        <p:txBody>
+          <a:bodyPr rtlCol="0" anchor="ctr"/>
+          <a:lstStyle/>
+          <a:p>
+            <a:pPr algn="ctr"/>
+          </a:p>
+        </p:txBody>
+      </p:sp>
+      <p:sp>
+        <p:nvSpPr>
           <p:cNvPr id="4" name="Rectangle 3"/>
           <p:cNvSpPr/>
           <p:nvPr/>
@@ -3631,13 +3732,13 @@
         <p:spPr>
           <a:xfrm>
             <a:off x="0" y="0"/>
-            <a:ext cx="12191695" cy="256032"/>
+            <a:ext cx="256032" cy="6858000"/>
           </a:xfrm>
           <a:prstGeom prst="rect">
             <a:avLst/>
           </a:prstGeom>
           <a:solidFill>
-            <a:srgbClr val="005CA0"/>
+            <a:srgbClr val="0B5394"/>
           </a:solidFill>
           <a:ln>
             <a:noFill/>
@@ -3683,8 +3784,9 @@
             <a:r>
               <a:rPr sz="3200" b="1">
                 <a:solidFill>
-                  <a:srgbClr val="00467F"/>
-                </a:solidFill>
+                  <a:srgbClr val="0F3154"/>
+                </a:solidFill>
+                <a:latin typeface="Calibri"/>
               </a:rPr>
               <a:t>Cost Plus Method</a:t>
             </a:r>
@@ -3712,6 +3814,7 @@
                 <a:solidFill>
                   <a:srgbClr val="282828"/>
                 </a:solidFill>
+                <a:latin typeface="Calibri"/>
               </a:rPr>
               <a:t>Adds an arm’s length mark-up to the supplier’s costs</a:t>
             </a:r>
@@ -3723,6 +3826,7 @@
                 <a:solidFill>
                   <a:srgbClr val="282828"/>
                 </a:solidFill>
+                <a:latin typeface="Calibri"/>
               </a:rPr>
               <a:t>Suitable for contract manufacturing or service providers</a:t>
             </a:r>
@@ -3734,6 +3838,7 @@
                 <a:solidFill>
                   <a:srgbClr val="282828"/>
                 </a:solidFill>
+                <a:latin typeface="Calibri"/>
               </a:rPr>
               <a:t>Critical to define the cost base consistently</a:t>
             </a:r>
@@ -3745,8 +3850,121 @@
                 <a:solidFill>
                   <a:srgbClr val="282828"/>
                 </a:solidFill>
+                <a:latin typeface="Calibri"/>
               </a:rPr>
               <a:t>Mark-up benchmarked against comparable independent firms</a:t>
+            </a:r>
+          </a:p>
+        </p:txBody>
+      </p:sp>
+      <p:sp>
+        <p:nvSpPr>
+          <p:cNvPr id="8" name="Rectangle 7"/>
+          <p:cNvSpPr/>
+          <p:nvPr/>
+        </p:nvSpPr>
+        <p:spPr>
+          <a:xfrm>
+            <a:off x="256032" y="6382512"/>
+            <a:ext cx="11935663" cy="18288"/>
+          </a:xfrm>
+          <a:prstGeom prst="rect">
+            <a:avLst/>
+          </a:prstGeom>
+          <a:solidFill>
+            <a:srgbClr val="CAD8E8"/>
+          </a:solidFill>
+          <a:ln>
+            <a:noFill/>
+          </a:ln>
+        </p:spPr>
+        <p:style>
+          <a:lnRef idx="1">
+            <a:schemeClr val="accent1"/>
+          </a:lnRef>
+          <a:fillRef idx="3">
+            <a:schemeClr val="accent1"/>
+          </a:fillRef>
+          <a:effectRef idx="2">
+            <a:schemeClr val="accent1"/>
+          </a:effectRef>
+          <a:fontRef idx="minor">
+            <a:schemeClr val="lt1"/>
+          </a:fontRef>
+        </p:style>
+        <p:txBody>
+          <a:bodyPr rtlCol="0" anchor="ctr"/>
+          <a:lstStyle/>
+          <a:p>
+            <a:pPr algn="ctr"/>
+          </a:p>
+        </p:txBody>
+      </p:sp>
+      <p:sp>
+        <p:nvSpPr>
+          <p:cNvPr id="9" name="TextBox 8"/>
+          <p:cNvSpPr txBox="1"/>
+          <p:nvPr/>
+        </p:nvSpPr>
+        <p:spPr>
+          <a:xfrm>
+            <a:off x="365760" y="6446520"/>
+            <a:ext cx="6095847" cy="274320"/>
+          </a:xfrm>
+          <a:prstGeom prst="rect">
+            <a:avLst/>
+          </a:prstGeom>
+          <a:noFill/>
+        </p:spPr>
+        <p:txBody>
+          <a:bodyPr wrap="none">
+            <a:spAutoFit/>
+          </a:bodyPr>
+          <a:lstStyle/>
+          <a:p>
+            <a:r>
+              <a:rPr sz="900">
+                <a:solidFill>
+                  <a:srgbClr val="5B6B7C"/>
+                </a:solidFill>
+                <a:latin typeface="Calibri"/>
+              </a:rPr>
+              <a:t>Transfer Pricing Methods</a:t>
+            </a:r>
+          </a:p>
+        </p:txBody>
+      </p:sp>
+      <p:sp>
+        <p:nvSpPr>
+          <p:cNvPr id="10" name="TextBox 9"/>
+          <p:cNvSpPr txBox="1"/>
+          <p:nvPr/>
+        </p:nvSpPr>
+        <p:spPr>
+          <a:xfrm>
+            <a:off x="11185855" y="6446520"/>
+            <a:ext cx="731520" cy="274320"/>
+          </a:xfrm>
+          <a:prstGeom prst="rect">
+            <a:avLst/>
+          </a:prstGeom>
+          <a:noFill/>
+        </p:spPr>
+        <p:txBody>
+          <a:bodyPr wrap="none">
+            <a:spAutoFit/>
+          </a:bodyPr>
+          <a:lstStyle/>
+          <a:p>
+            <a:pPr algn="r"/>
+            <a:r>
+              <a:rPr sz="900">
+                <a:solidFill>
+                  <a:srgbClr val="5B6B7C"/>
+                </a:solidFill>
+                <a:latin typeface="Calibri"/>
+              </a:rPr>
+              <a:t>10</a:t>
             </a:r>
           </a:p>
         </p:txBody>
@@ -3765,7 +3983,7 @@
     <p:bg>
       <p:bgPr>
         <a:solidFill>
-          <a:srgbClr val="F5F8FC"/>
+          <a:srgbClr val="F8FAFC"/>
         </a:solidFill>
         <a:effectLst/>
       </p:bgPr>
@@ -3779,20 +3997,20 @@
       <p:grpSpPr/>
       <p:sp>
         <p:nvSpPr>
-          <p:cNvPr id="7" name="Oval 6"/>
+          <p:cNvPr id="8" name="Oval 7"/>
           <p:cNvSpPr/>
           <p:nvPr/>
         </p:nvSpPr>
         <p:spPr>
           <a:xfrm>
-            <a:off x="-1280160" y="4572000"/>
-            <a:ext cx="2926080" cy="2926080"/>
+            <a:off x="-1097280" y="4846320"/>
+            <a:ext cx="2743200" cy="2743200"/>
           </a:xfrm>
           <a:prstGeom prst="ellipse">
             <a:avLst/>
           </a:prstGeom>
           <a:solidFill>
-            <a:srgbClr val="8CAAC8"/>
+            <a:srgbClr val="CAD8E8"/>
           </a:solidFill>
           <a:ln>
             <a:noFill/>
@@ -3822,20 +4040,20 @@
       </p:sp>
       <p:sp>
         <p:nvSpPr>
-          <p:cNvPr id="6" name="Oval 5"/>
+          <p:cNvPr id="7" name="Oval 6"/>
           <p:cNvSpPr/>
           <p:nvPr/>
         </p:nvSpPr>
         <p:spPr>
           <a:xfrm>
-            <a:off x="9722815" y="-822960"/>
-            <a:ext cx="3291840" cy="3291840"/>
+            <a:off x="9631375" y="-914400"/>
+            <a:ext cx="2926080" cy="2926080"/>
           </a:xfrm>
           <a:prstGeom prst="ellipse">
             <a:avLst/>
           </a:prstGeom>
           <a:solidFill>
-            <a:srgbClr val="005CA0"/>
+            <a:srgbClr val="CAD8E8"/>
           </a:solidFill>
           <a:ln>
             <a:noFill/>
@@ -3865,6 +4083,49 @@
       </p:sp>
       <p:sp>
         <p:nvSpPr>
+          <p:cNvPr id="6" name="Rectangle 5"/>
+          <p:cNvSpPr/>
+          <p:nvPr/>
+        </p:nvSpPr>
+        <p:spPr>
+          <a:xfrm>
+            <a:off x="0" y="0"/>
+            <a:ext cx="12191695" cy="54864"/>
+          </a:xfrm>
+          <a:prstGeom prst="rect">
+            <a:avLst/>
+          </a:prstGeom>
+          <a:solidFill>
+            <a:srgbClr val="0B5394"/>
+          </a:solidFill>
+          <a:ln>
+            <a:noFill/>
+          </a:ln>
+        </p:spPr>
+        <p:style>
+          <a:lnRef idx="1">
+            <a:schemeClr val="accent1"/>
+          </a:lnRef>
+          <a:fillRef idx="3">
+            <a:schemeClr val="accent1"/>
+          </a:fillRef>
+          <a:effectRef idx="2">
+            <a:schemeClr val="accent1"/>
+          </a:effectRef>
+          <a:fontRef idx="minor">
+            <a:schemeClr val="lt1"/>
+          </a:fontRef>
+        </p:style>
+        <p:txBody>
+          <a:bodyPr rtlCol="0" anchor="ctr"/>
+          <a:lstStyle/>
+          <a:p>
+            <a:pPr algn="ctr"/>
+          </a:p>
+        </p:txBody>
+      </p:sp>
+      <p:sp>
+        <p:nvSpPr>
           <p:cNvPr id="5" name="Rectangle 4"/>
           <p:cNvSpPr/>
           <p:nvPr/>
@@ -3872,13 +4133,13 @@
         <p:spPr>
           <a:xfrm>
             <a:off x="0" y="0"/>
-            <a:ext cx="12191695" cy="256032"/>
+            <a:ext cx="256032" cy="6858000"/>
           </a:xfrm>
           <a:prstGeom prst="rect">
             <a:avLst/>
           </a:prstGeom>
           <a:solidFill>
-            <a:srgbClr val="005CA0"/>
+            <a:srgbClr val="0B5394"/>
           </a:solidFill>
           <a:ln>
             <a:noFill/>
@@ -3926,6 +4187,7 @@
                 <a:solidFill>
                   <a:srgbClr val="00467F"/>
                 </a:solidFill>
+                <a:latin typeface="Calibri"/>
               </a:rPr>
               <a:t>Transactional Net Margin Method (TNMM)</a:t>
             </a:r>
@@ -3954,10 +4216,11 @@
           <a:p>
             <a:pPr/>
             <a:r>
-              <a:rPr sz="2200" b="0">
-                <a:solidFill>
-                  <a:srgbClr val="282828"/>
-                </a:solidFill>
+              <a:rPr sz="2200" b="1">
+                <a:solidFill>
+                  <a:srgbClr val="0F3154"/>
+                </a:solidFill>
+                <a:latin typeface="Calibri"/>
               </a:rPr>
               <a:t>Tests net profit relative to an appropriate base (sales, costs, assets)</a:t>
             </a:r>
@@ -3965,10 +4228,11 @@
           <a:p>
             <a:pPr/>
             <a:r>
-              <a:rPr sz="2200" b="0">
-                <a:solidFill>
-                  <a:srgbClr val="282828"/>
-                </a:solidFill>
+              <a:rPr sz="2200" b="1">
+                <a:solidFill>
+                  <a:srgbClr val="0F3154"/>
+                </a:solidFill>
+                <a:latin typeface="Calibri"/>
               </a:rPr>
               <a:t>Widely applied due to data availability</a:t>
             </a:r>
@@ -3976,10 +4240,11 @@
           <a:p>
             <a:pPr/>
             <a:r>
-              <a:rPr sz="2200" b="0">
-                <a:solidFill>
-                  <a:srgbClr val="282828"/>
-                </a:solidFill>
+              <a:rPr sz="2200" b="1">
+                <a:solidFill>
+                  <a:srgbClr val="0F3154"/>
+                </a:solidFill>
+                <a:latin typeface="Calibri"/>
               </a:rPr>
               <a:t>Less sensitive to product differences than gross margin methods</a:t>
             </a:r>
@@ -3987,10 +4252,11 @@
           <a:p>
             <a:pPr/>
             <a:r>
-              <a:rPr sz="2200" b="0">
-                <a:solidFill>
-                  <a:srgbClr val="282828"/>
-                </a:solidFill>
+              <a:rPr sz="2200" b="1">
+                <a:solidFill>
+                  <a:srgbClr val="0F3154"/>
+                </a:solidFill>
+                <a:latin typeface="Calibri"/>
               </a:rPr>
               <a:t>Requires reliable selection of a profit level indicator (PLI)</a:t>
             </a:r>
@@ -4015,6 +4281,118 @@
           </a:graphicData>
         </a:graphic>
       </p:graphicFrame>
+      <p:sp>
+        <p:nvSpPr>
+          <p:cNvPr id="9" name="Rectangle 8"/>
+          <p:cNvSpPr/>
+          <p:nvPr/>
+        </p:nvSpPr>
+        <p:spPr>
+          <a:xfrm>
+            <a:off x="256032" y="6382512"/>
+            <a:ext cx="11935663" cy="18288"/>
+          </a:xfrm>
+          <a:prstGeom prst="rect">
+            <a:avLst/>
+          </a:prstGeom>
+          <a:solidFill>
+            <a:srgbClr val="CAD8E8"/>
+          </a:solidFill>
+          <a:ln>
+            <a:noFill/>
+          </a:ln>
+        </p:spPr>
+        <p:style>
+          <a:lnRef idx="1">
+            <a:schemeClr val="accent1"/>
+          </a:lnRef>
+          <a:fillRef idx="3">
+            <a:schemeClr val="accent1"/>
+          </a:fillRef>
+          <a:effectRef idx="2">
+            <a:schemeClr val="accent1"/>
+          </a:effectRef>
+          <a:fontRef idx="minor">
+            <a:schemeClr val="lt1"/>
+          </a:fontRef>
+        </p:style>
+        <p:txBody>
+          <a:bodyPr rtlCol="0" anchor="ctr"/>
+          <a:lstStyle/>
+          <a:p>
+            <a:pPr algn="ctr"/>
+          </a:p>
+        </p:txBody>
+      </p:sp>
+      <p:sp>
+        <p:nvSpPr>
+          <p:cNvPr id="10" name="TextBox 9"/>
+          <p:cNvSpPr txBox="1"/>
+          <p:nvPr/>
+        </p:nvSpPr>
+        <p:spPr>
+          <a:xfrm>
+            <a:off x="365760" y="6446520"/>
+            <a:ext cx="6095847" cy="274320"/>
+          </a:xfrm>
+          <a:prstGeom prst="rect">
+            <a:avLst/>
+          </a:prstGeom>
+          <a:noFill/>
+        </p:spPr>
+        <p:txBody>
+          <a:bodyPr wrap="none">
+            <a:spAutoFit/>
+          </a:bodyPr>
+          <a:lstStyle/>
+          <a:p>
+            <a:r>
+              <a:rPr sz="900">
+                <a:solidFill>
+                  <a:srgbClr val="5B6B7C"/>
+                </a:solidFill>
+                <a:latin typeface="Calibri"/>
+              </a:rPr>
+              <a:t>Transfer Pricing Methods</a:t>
+            </a:r>
+          </a:p>
+        </p:txBody>
+      </p:sp>
+      <p:sp>
+        <p:nvSpPr>
+          <p:cNvPr id="11" name="TextBox 10"/>
+          <p:cNvSpPr txBox="1"/>
+          <p:nvPr/>
+        </p:nvSpPr>
+        <p:spPr>
+          <a:xfrm>
+            <a:off x="11185855" y="6446520"/>
+            <a:ext cx="731520" cy="274320"/>
+          </a:xfrm>
+          <a:prstGeom prst="rect">
+            <a:avLst/>
+          </a:prstGeom>
+          <a:noFill/>
+        </p:spPr>
+        <p:txBody>
+          <a:bodyPr wrap="none">
+            <a:spAutoFit/>
+          </a:bodyPr>
+          <a:lstStyle/>
+          <a:p>
+            <a:pPr algn="r"/>
+            <a:r>
+              <a:rPr sz="900">
+                <a:solidFill>
+                  <a:srgbClr val="5B6B7C"/>
+                </a:solidFill>
+                <a:latin typeface="Calibri"/>
+              </a:rPr>
+              <a:t>11</a:t>
+            </a:r>
+          </a:p>
+        </p:txBody>
+      </p:sp>
     </p:spTree>
   </p:cSld>
   <p:clrMapOvr>
@@ -4029,7 +4407,7 @@
     <p:bg>
       <p:bgPr>
         <a:solidFill>
-          <a:srgbClr val="F5F8FC"/>
+          <a:srgbClr val="F8FAFC"/>
         </a:solidFill>
         <a:effectLst/>
       </p:bgPr>
@@ -4043,20 +4421,20 @@
       <p:grpSpPr/>
       <p:sp>
         <p:nvSpPr>
-          <p:cNvPr id="7" name="Oval 6"/>
+          <p:cNvPr id="8" name="Oval 7"/>
           <p:cNvSpPr/>
           <p:nvPr/>
         </p:nvSpPr>
         <p:spPr>
           <a:xfrm>
-            <a:off x="-1280160" y="4572000"/>
-            <a:ext cx="2926080" cy="2926080"/>
+            <a:off x="-1097280" y="4846320"/>
+            <a:ext cx="2743200" cy="2743200"/>
           </a:xfrm>
           <a:prstGeom prst="ellipse">
             <a:avLst/>
           </a:prstGeom>
           <a:solidFill>
-            <a:srgbClr val="8CAAC8"/>
+            <a:srgbClr val="CAD8E8"/>
           </a:solidFill>
           <a:ln>
             <a:noFill/>
@@ -4086,20 +4464,20 @@
       </p:sp>
       <p:sp>
         <p:nvSpPr>
-          <p:cNvPr id="6" name="Oval 5"/>
+          <p:cNvPr id="7" name="Oval 6"/>
           <p:cNvSpPr/>
           <p:nvPr/>
         </p:nvSpPr>
         <p:spPr>
           <a:xfrm>
-            <a:off x="9722815" y="-822960"/>
-            <a:ext cx="3291840" cy="3291840"/>
+            <a:off x="9631375" y="-914400"/>
+            <a:ext cx="2926080" cy="2926080"/>
           </a:xfrm>
           <a:prstGeom prst="ellipse">
             <a:avLst/>
           </a:prstGeom>
           <a:solidFill>
-            <a:srgbClr val="005CA0"/>
+            <a:srgbClr val="CAD8E8"/>
           </a:solidFill>
           <a:ln>
             <a:noFill/>
@@ -4129,6 +4507,49 @@
       </p:sp>
       <p:sp>
         <p:nvSpPr>
+          <p:cNvPr id="6" name="Rectangle 5"/>
+          <p:cNvSpPr/>
+          <p:nvPr/>
+        </p:nvSpPr>
+        <p:spPr>
+          <a:xfrm>
+            <a:off x="0" y="0"/>
+            <a:ext cx="12191695" cy="54864"/>
+          </a:xfrm>
+          <a:prstGeom prst="rect">
+            <a:avLst/>
+          </a:prstGeom>
+          <a:solidFill>
+            <a:srgbClr val="0B5394"/>
+          </a:solidFill>
+          <a:ln>
+            <a:noFill/>
+          </a:ln>
+        </p:spPr>
+        <p:style>
+          <a:lnRef idx="1">
+            <a:schemeClr val="accent1"/>
+          </a:lnRef>
+          <a:fillRef idx="3">
+            <a:schemeClr val="accent1"/>
+          </a:fillRef>
+          <a:effectRef idx="2">
+            <a:schemeClr val="accent1"/>
+          </a:effectRef>
+          <a:fontRef idx="minor">
+            <a:schemeClr val="lt1"/>
+          </a:fontRef>
+        </p:style>
+        <p:txBody>
+          <a:bodyPr rtlCol="0" anchor="ctr"/>
+          <a:lstStyle/>
+          <a:p>
+            <a:pPr algn="ctr"/>
+          </a:p>
+        </p:txBody>
+      </p:sp>
+      <p:sp>
+        <p:nvSpPr>
           <p:cNvPr id="5" name="Rectangle 4"/>
           <p:cNvSpPr/>
           <p:nvPr/>
@@ -4136,13 +4557,13 @@
         <p:spPr>
           <a:xfrm>
             <a:off x="0" y="0"/>
-            <a:ext cx="12191695" cy="256032"/>
+            <a:ext cx="256032" cy="6858000"/>
           </a:xfrm>
           <a:prstGeom prst="rect">
             <a:avLst/>
           </a:prstGeom>
           <a:solidFill>
-            <a:srgbClr val="005CA0"/>
+            <a:srgbClr val="0B5394"/>
           </a:solidFill>
           <a:ln>
             <a:noFill/>
@@ -4190,6 +4611,7 @@
                 <a:solidFill>
                   <a:srgbClr val="00467F"/>
                 </a:solidFill>
+                <a:latin typeface="Calibri"/>
               </a:rPr>
               <a:t>Profit Split Method</a:t>
             </a:r>
@@ -4218,10 +4640,11 @@
           <a:p>
             <a:pPr/>
             <a:r>
-              <a:rPr sz="2200" b="0">
-                <a:solidFill>
-                  <a:srgbClr val="282828"/>
-                </a:solidFill>
+              <a:rPr sz="2200" b="1">
+                <a:solidFill>
+                  <a:srgbClr val="0F3154"/>
+                </a:solidFill>
+                <a:latin typeface="Calibri"/>
               </a:rPr>
               <a:t>Allocates combined profits based on relative contributions</a:t>
             </a:r>
@@ -4229,10 +4652,11 @@
           <a:p>
             <a:pPr/>
             <a:r>
-              <a:rPr sz="2200" b="0">
-                <a:solidFill>
-                  <a:srgbClr val="282828"/>
-                </a:solidFill>
+              <a:rPr sz="2200" b="1">
+                <a:solidFill>
+                  <a:srgbClr val="0F3154"/>
+                </a:solidFill>
+                <a:latin typeface="Calibri"/>
               </a:rPr>
               <a:t>Appropriate for integrated operations or unique intangibles</a:t>
             </a:r>
@@ -4240,10 +4664,11 @@
           <a:p>
             <a:pPr/>
             <a:r>
-              <a:rPr sz="2200" b="0">
-                <a:solidFill>
-                  <a:srgbClr val="282828"/>
-                </a:solidFill>
+              <a:rPr sz="2200" b="1">
+                <a:solidFill>
+                  <a:srgbClr val="0F3154"/>
+                </a:solidFill>
+                <a:latin typeface="Calibri"/>
               </a:rPr>
               <a:t>Includes contribution and residual profit split approaches</a:t>
             </a:r>
@@ -4251,10 +4676,11 @@
           <a:p>
             <a:pPr/>
             <a:r>
-              <a:rPr sz="2200" b="0">
-                <a:solidFill>
-                  <a:srgbClr val="282828"/>
-                </a:solidFill>
+              <a:rPr sz="2200" b="1">
+                <a:solidFill>
+                  <a:srgbClr val="0F3154"/>
+                </a:solidFill>
+                <a:latin typeface="Calibri"/>
               </a:rPr>
               <a:t>Requires robust allocation keys and documentation</a:t>
             </a:r>
@@ -4279,6 +4705,118 @@
           </a:graphicData>
         </a:graphic>
       </p:graphicFrame>
+      <p:sp>
+        <p:nvSpPr>
+          <p:cNvPr id="9" name="Rectangle 8"/>
+          <p:cNvSpPr/>
+          <p:nvPr/>
+        </p:nvSpPr>
+        <p:spPr>
+          <a:xfrm>
+            <a:off x="256032" y="6382512"/>
+            <a:ext cx="11935663" cy="18288"/>
+          </a:xfrm>
+          <a:prstGeom prst="rect">
+            <a:avLst/>
+          </a:prstGeom>
+          <a:solidFill>
+            <a:srgbClr val="CAD8E8"/>
+          </a:solidFill>
+          <a:ln>
+            <a:noFill/>
+          </a:ln>
+        </p:spPr>
+        <p:style>
+          <a:lnRef idx="1">
+            <a:schemeClr val="accent1"/>
+          </a:lnRef>
+          <a:fillRef idx="3">
+            <a:schemeClr val="accent1"/>
+          </a:fillRef>
+          <a:effectRef idx="2">
+            <a:schemeClr val="accent1"/>
+          </a:effectRef>
+          <a:fontRef idx="minor">
+            <a:schemeClr val="lt1"/>
+          </a:fontRef>
+        </p:style>
+        <p:txBody>
+          <a:bodyPr rtlCol="0" anchor="ctr"/>
+          <a:lstStyle/>
+          <a:p>
+            <a:pPr algn="ctr"/>
+          </a:p>
+        </p:txBody>
+      </p:sp>
+      <p:sp>
+        <p:nvSpPr>
+          <p:cNvPr id="10" name="TextBox 9"/>
+          <p:cNvSpPr txBox="1"/>
+          <p:nvPr/>
+        </p:nvSpPr>
+        <p:spPr>
+          <a:xfrm>
+            <a:off x="365760" y="6446520"/>
+            <a:ext cx="6095847" cy="274320"/>
+          </a:xfrm>
+          <a:prstGeom prst="rect">
+            <a:avLst/>
+          </a:prstGeom>
+          <a:noFill/>
+        </p:spPr>
+        <p:txBody>
+          <a:bodyPr wrap="none">
+            <a:spAutoFit/>
+          </a:bodyPr>
+          <a:lstStyle/>
+          <a:p>
+            <a:r>
+              <a:rPr sz="900">
+                <a:solidFill>
+                  <a:srgbClr val="5B6B7C"/>
+                </a:solidFill>
+                <a:latin typeface="Calibri"/>
+              </a:rPr>
+              <a:t>Transfer Pricing Methods</a:t>
+            </a:r>
+          </a:p>
+        </p:txBody>
+      </p:sp>
+      <p:sp>
+        <p:nvSpPr>
+          <p:cNvPr id="11" name="TextBox 10"/>
+          <p:cNvSpPr txBox="1"/>
+          <p:nvPr/>
+        </p:nvSpPr>
+        <p:spPr>
+          <a:xfrm>
+            <a:off x="11185855" y="6446520"/>
+            <a:ext cx="731520" cy="274320"/>
+          </a:xfrm>
+          <a:prstGeom prst="rect">
+            <a:avLst/>
+          </a:prstGeom>
+          <a:noFill/>
+        </p:spPr>
+        <p:txBody>
+          <a:bodyPr wrap="none">
+            <a:spAutoFit/>
+          </a:bodyPr>
+          <a:lstStyle/>
+          <a:p>
+            <a:pPr algn="r"/>
+            <a:r>
+              <a:rPr sz="900">
+                <a:solidFill>
+                  <a:srgbClr val="5B6B7C"/>
+                </a:solidFill>
+                <a:latin typeface="Calibri"/>
+              </a:rPr>
+              <a:t>12</a:t>
+            </a:r>
+          </a:p>
+        </p:txBody>
+      </p:sp>
     </p:spTree>
   </p:cSld>
   <p:clrMapOvr>
@@ -4293,7 +4831,7 @@
     <p:bg>
       <p:bgPr>
         <a:solidFill>
-          <a:srgbClr val="F5F8FC"/>
+          <a:srgbClr val="F8FAFC"/>
         </a:solidFill>
         <a:effectLst/>
       </p:bgPr>
@@ -4307,20 +4845,20 @@
       <p:grpSpPr/>
       <p:sp>
         <p:nvSpPr>
-          <p:cNvPr id="6" name="Oval 5"/>
+          <p:cNvPr id="7" name="Oval 6"/>
           <p:cNvSpPr/>
           <p:nvPr/>
         </p:nvSpPr>
         <p:spPr>
           <a:xfrm>
-            <a:off x="-1280160" y="4572000"/>
-            <a:ext cx="2926080" cy="2926080"/>
+            <a:off x="-1097280" y="4846320"/>
+            <a:ext cx="2743200" cy="2743200"/>
           </a:xfrm>
           <a:prstGeom prst="ellipse">
             <a:avLst/>
           </a:prstGeom>
           <a:solidFill>
-            <a:srgbClr val="8CAAC8"/>
+            <a:srgbClr val="CAD8E8"/>
           </a:solidFill>
           <a:ln>
             <a:noFill/>
@@ -4350,20 +4888,20 @@
       </p:sp>
       <p:sp>
         <p:nvSpPr>
-          <p:cNvPr id="5" name="Oval 4"/>
+          <p:cNvPr id="6" name="Oval 5"/>
           <p:cNvSpPr/>
           <p:nvPr/>
         </p:nvSpPr>
         <p:spPr>
           <a:xfrm>
-            <a:off x="9722815" y="-822960"/>
-            <a:ext cx="3291840" cy="3291840"/>
+            <a:off x="9631375" y="-914400"/>
+            <a:ext cx="2926080" cy="2926080"/>
           </a:xfrm>
           <a:prstGeom prst="ellipse">
             <a:avLst/>
           </a:prstGeom>
           <a:solidFill>
-            <a:srgbClr val="005CA0"/>
+            <a:srgbClr val="CAD8E8"/>
           </a:solidFill>
           <a:ln>
             <a:noFill/>
@@ -4393,6 +4931,49 @@
       </p:sp>
       <p:sp>
         <p:nvSpPr>
+          <p:cNvPr id="5" name="Rectangle 4"/>
+          <p:cNvSpPr/>
+          <p:nvPr/>
+        </p:nvSpPr>
+        <p:spPr>
+          <a:xfrm>
+            <a:off x="0" y="0"/>
+            <a:ext cx="12191695" cy="54864"/>
+          </a:xfrm>
+          <a:prstGeom prst="rect">
+            <a:avLst/>
+          </a:prstGeom>
+          <a:solidFill>
+            <a:srgbClr val="0B5394"/>
+          </a:solidFill>
+          <a:ln>
+            <a:noFill/>
+          </a:ln>
+        </p:spPr>
+        <p:style>
+          <a:lnRef idx="1">
+            <a:schemeClr val="accent1"/>
+          </a:lnRef>
+          <a:fillRef idx="3">
+            <a:schemeClr val="accent1"/>
+          </a:fillRef>
+          <a:effectRef idx="2">
+            <a:schemeClr val="accent1"/>
+          </a:effectRef>
+          <a:fontRef idx="minor">
+            <a:schemeClr val="lt1"/>
+          </a:fontRef>
+        </p:style>
+        <p:txBody>
+          <a:bodyPr rtlCol="0" anchor="ctr"/>
+          <a:lstStyle/>
+          <a:p>
+            <a:pPr algn="ctr"/>
+          </a:p>
+        </p:txBody>
+      </p:sp>
+      <p:sp>
+        <p:nvSpPr>
           <p:cNvPr id="4" name="Rectangle 3"/>
           <p:cNvSpPr/>
           <p:nvPr/>
@@ -4400,13 +4981,13 @@
         <p:spPr>
           <a:xfrm>
             <a:off x="0" y="0"/>
-            <a:ext cx="12191695" cy="256032"/>
+            <a:ext cx="256032" cy="6858000"/>
           </a:xfrm>
           <a:prstGeom prst="rect">
             <a:avLst/>
           </a:prstGeom>
           <a:solidFill>
-            <a:srgbClr val="005CA0"/>
+            <a:srgbClr val="0B5394"/>
           </a:solidFill>
           <a:ln>
             <a:noFill/>
@@ -4452,8 +5033,9 @@
             <a:r>
               <a:rPr sz="3200" b="1">
                 <a:solidFill>
-                  <a:srgbClr val="00467F"/>
-                </a:solidFill>
+                  <a:srgbClr val="0F3154"/>
+                </a:solidFill>
+                <a:latin typeface="Calibri"/>
               </a:rPr>
               <a:t>Other Accepted Approaches</a:t>
             </a:r>
@@ -4481,6 +5063,7 @@
                 <a:solidFill>
                   <a:srgbClr val="282828"/>
                 </a:solidFill>
+                <a:latin typeface="Calibri"/>
               </a:rPr>
               <a:t>Other methods allowed if they yield a more reliable arm’s length result</a:t>
             </a:r>
@@ -4492,6 +5075,7 @@
                 <a:solidFill>
                   <a:srgbClr val="282828"/>
                 </a:solidFill>
+                <a:latin typeface="Calibri"/>
               </a:rPr>
               <a:t>Valuation techniques for hard-to-value intangibles</a:t>
             </a:r>
@@ -4503,6 +5087,7 @@
                 <a:solidFill>
                   <a:srgbClr val="282828"/>
                 </a:solidFill>
+                <a:latin typeface="Calibri"/>
               </a:rPr>
               <a:t>Safe harbors where available under local rules</a:t>
             </a:r>
@@ -4514,8 +5099,121 @@
                 <a:solidFill>
                   <a:srgbClr val="282828"/>
                 </a:solidFill>
+                <a:latin typeface="Calibri"/>
               </a:rPr>
               <a:t>Advance Pricing Agreements (APAs) for certainty</a:t>
+            </a:r>
+          </a:p>
+        </p:txBody>
+      </p:sp>
+      <p:sp>
+        <p:nvSpPr>
+          <p:cNvPr id="8" name="Rectangle 7"/>
+          <p:cNvSpPr/>
+          <p:nvPr/>
+        </p:nvSpPr>
+        <p:spPr>
+          <a:xfrm>
+            <a:off x="256032" y="6382512"/>
+            <a:ext cx="11935663" cy="18288"/>
+          </a:xfrm>
+          <a:prstGeom prst="rect">
+            <a:avLst/>
+          </a:prstGeom>
+          <a:solidFill>
+            <a:srgbClr val="CAD8E8"/>
+          </a:solidFill>
+          <a:ln>
+            <a:noFill/>
+          </a:ln>
+        </p:spPr>
+        <p:style>
+          <a:lnRef idx="1">
+            <a:schemeClr val="accent1"/>
+          </a:lnRef>
+          <a:fillRef idx="3">
+            <a:schemeClr val="accent1"/>
+          </a:fillRef>
+          <a:effectRef idx="2">
+            <a:schemeClr val="accent1"/>
+          </a:effectRef>
+          <a:fontRef idx="minor">
+            <a:schemeClr val="lt1"/>
+          </a:fontRef>
+        </p:style>
+        <p:txBody>
+          <a:bodyPr rtlCol="0" anchor="ctr"/>
+          <a:lstStyle/>
+          <a:p>
+            <a:pPr algn="ctr"/>
+          </a:p>
+        </p:txBody>
+      </p:sp>
+      <p:sp>
+        <p:nvSpPr>
+          <p:cNvPr id="9" name="TextBox 8"/>
+          <p:cNvSpPr txBox="1"/>
+          <p:nvPr/>
+        </p:nvSpPr>
+        <p:spPr>
+          <a:xfrm>
+            <a:off x="365760" y="6446520"/>
+            <a:ext cx="6095847" cy="274320"/>
+          </a:xfrm>
+          <a:prstGeom prst="rect">
+            <a:avLst/>
+          </a:prstGeom>
+          <a:noFill/>
+        </p:spPr>
+        <p:txBody>
+          <a:bodyPr wrap="none">
+            <a:spAutoFit/>
+          </a:bodyPr>
+          <a:lstStyle/>
+          <a:p>
+            <a:r>
+              <a:rPr sz="900">
+                <a:solidFill>
+                  <a:srgbClr val="5B6B7C"/>
+                </a:solidFill>
+                <a:latin typeface="Calibri"/>
+              </a:rPr>
+              <a:t>Transfer Pricing Methods</a:t>
+            </a:r>
+          </a:p>
+        </p:txBody>
+      </p:sp>
+      <p:sp>
+        <p:nvSpPr>
+          <p:cNvPr id="10" name="TextBox 9"/>
+          <p:cNvSpPr txBox="1"/>
+          <p:nvPr/>
+        </p:nvSpPr>
+        <p:spPr>
+          <a:xfrm>
+            <a:off x="11185855" y="6446520"/>
+            <a:ext cx="731520" cy="274320"/>
+          </a:xfrm>
+          <a:prstGeom prst="rect">
+            <a:avLst/>
+          </a:prstGeom>
+          <a:noFill/>
+        </p:spPr>
+        <p:txBody>
+          <a:bodyPr wrap="none">
+            <a:spAutoFit/>
+          </a:bodyPr>
+          <a:lstStyle/>
+          <a:p>
+            <a:pPr algn="r"/>
+            <a:r>
+              <a:rPr sz="900">
+                <a:solidFill>
+                  <a:srgbClr val="5B6B7C"/>
+                </a:solidFill>
+                <a:latin typeface="Calibri"/>
+              </a:rPr>
+              <a:t>13</a:t>
             </a:r>
           </a:p>
         </p:txBody>
@@ -4534,7 +5232,7 @@
     <p:bg>
       <p:bgPr>
         <a:solidFill>
-          <a:srgbClr val="F5F8FC"/>
+          <a:srgbClr val="F8FAFC"/>
         </a:solidFill>
         <a:effectLst/>
       </p:bgPr>
@@ -4548,20 +5246,20 @@
       <p:grpSpPr/>
       <p:sp>
         <p:nvSpPr>
-          <p:cNvPr id="7" name="Oval 6"/>
+          <p:cNvPr id="8" name="Oval 7"/>
           <p:cNvSpPr/>
           <p:nvPr/>
         </p:nvSpPr>
         <p:spPr>
           <a:xfrm>
-            <a:off x="-1280160" y="4572000"/>
-            <a:ext cx="2926080" cy="2926080"/>
+            <a:off x="-1097280" y="4846320"/>
+            <a:ext cx="2743200" cy="2743200"/>
           </a:xfrm>
           <a:prstGeom prst="ellipse">
             <a:avLst/>
           </a:prstGeom>
           <a:solidFill>
-            <a:srgbClr val="8CAAC8"/>
+            <a:srgbClr val="CAD8E8"/>
           </a:solidFill>
           <a:ln>
             <a:noFill/>
@@ -4591,20 +5289,20 @@
       </p:sp>
       <p:sp>
         <p:nvSpPr>
-          <p:cNvPr id="6" name="Oval 5"/>
+          <p:cNvPr id="7" name="Oval 6"/>
           <p:cNvSpPr/>
           <p:nvPr/>
         </p:nvSpPr>
         <p:spPr>
           <a:xfrm>
-            <a:off x="9722815" y="-822960"/>
-            <a:ext cx="3291840" cy="3291840"/>
+            <a:off x="9631375" y="-914400"/>
+            <a:ext cx="2926080" cy="2926080"/>
           </a:xfrm>
           <a:prstGeom prst="ellipse">
             <a:avLst/>
           </a:prstGeom>
           <a:solidFill>
-            <a:srgbClr val="005CA0"/>
+            <a:srgbClr val="CAD8E8"/>
           </a:solidFill>
           <a:ln>
             <a:noFill/>
@@ -4634,6 +5332,49 @@
       </p:sp>
       <p:sp>
         <p:nvSpPr>
+          <p:cNvPr id="6" name="Rectangle 5"/>
+          <p:cNvSpPr/>
+          <p:nvPr/>
+        </p:nvSpPr>
+        <p:spPr>
+          <a:xfrm>
+            <a:off x="0" y="0"/>
+            <a:ext cx="12191695" cy="54864"/>
+          </a:xfrm>
+          <a:prstGeom prst="rect">
+            <a:avLst/>
+          </a:prstGeom>
+          <a:solidFill>
+            <a:srgbClr val="0B5394"/>
+          </a:solidFill>
+          <a:ln>
+            <a:noFill/>
+          </a:ln>
+        </p:spPr>
+        <p:style>
+          <a:lnRef idx="1">
+            <a:schemeClr val="accent1"/>
+          </a:lnRef>
+          <a:fillRef idx="3">
+            <a:schemeClr val="accent1"/>
+          </a:fillRef>
+          <a:effectRef idx="2">
+            <a:schemeClr val="accent1"/>
+          </a:effectRef>
+          <a:fontRef idx="minor">
+            <a:schemeClr val="lt1"/>
+          </a:fontRef>
+        </p:style>
+        <p:txBody>
+          <a:bodyPr rtlCol="0" anchor="ctr"/>
+          <a:lstStyle/>
+          <a:p>
+            <a:pPr algn="ctr"/>
+          </a:p>
+        </p:txBody>
+      </p:sp>
+      <p:sp>
+        <p:nvSpPr>
           <p:cNvPr id="5" name="Rectangle 4"/>
           <p:cNvSpPr/>
           <p:nvPr/>
@@ -4641,13 +5382,13 @@
         <p:spPr>
           <a:xfrm>
             <a:off x="0" y="0"/>
-            <a:ext cx="12191695" cy="256032"/>
+            <a:ext cx="256032" cy="6858000"/>
           </a:xfrm>
           <a:prstGeom prst="rect">
             <a:avLst/>
           </a:prstGeom>
           <a:solidFill>
-            <a:srgbClr val="005CA0"/>
+            <a:srgbClr val="0B5394"/>
           </a:solidFill>
           <a:ln>
             <a:noFill/>
@@ -4695,6 +5436,7 @@
                 <a:solidFill>
                   <a:srgbClr val="00467F"/>
                 </a:solidFill>
+                <a:latin typeface="Calibri"/>
               </a:rPr>
               <a:t>Documentation and Compliance (BEPS Action 13)</a:t>
             </a:r>
@@ -4723,10 +5465,11 @@
           <a:p>
             <a:pPr/>
             <a:r>
-              <a:rPr sz="2200" b="0">
-                <a:solidFill>
-                  <a:srgbClr val="282828"/>
-                </a:solidFill>
+              <a:rPr sz="2200" b="1">
+                <a:solidFill>
+                  <a:srgbClr val="0F3154"/>
+                </a:solidFill>
+                <a:latin typeface="Calibri"/>
               </a:rPr>
               <a:t>Master File, Local File, and Country-by-Country Reporting</a:t>
             </a:r>
@@ -4734,10 +5477,11 @@
           <a:p>
             <a:pPr/>
             <a:r>
-              <a:rPr sz="2200" b="0">
-                <a:solidFill>
-                  <a:srgbClr val="282828"/>
-                </a:solidFill>
+              <a:rPr sz="2200" b="1">
+                <a:solidFill>
+                  <a:srgbClr val="0F3154"/>
+                </a:solidFill>
+                <a:latin typeface="Calibri"/>
               </a:rPr>
               <a:t>German thresholds, timelines, and penalty exposure</a:t>
             </a:r>
@@ -4745,10 +5489,11 @@
           <a:p>
             <a:pPr/>
             <a:r>
-              <a:rPr sz="2200" b="0">
-                <a:solidFill>
-                  <a:srgbClr val="282828"/>
-                </a:solidFill>
+              <a:rPr sz="2200" b="1">
+                <a:solidFill>
+                  <a:srgbClr val="0F3154"/>
+                </a:solidFill>
+                <a:latin typeface="Calibri"/>
               </a:rPr>
               <a:t>Contemporaneous documentation reduces audit risk</a:t>
             </a:r>
@@ -4756,10 +5501,11 @@
           <a:p>
             <a:pPr/>
             <a:r>
-              <a:rPr sz="2200" b="0">
-                <a:solidFill>
-                  <a:srgbClr val="282828"/>
-                </a:solidFill>
+              <a:rPr sz="2200" b="1">
+                <a:solidFill>
+                  <a:srgbClr val="0F3154"/>
+                </a:solidFill>
+                <a:latin typeface="Calibri"/>
               </a:rPr>
               <a:t>Use of APAs and Mutual Agreement Procedures for disputes</a:t>
             </a:r>
@@ -4790,6 +5536,118 @@
           </a:prstGeom>
         </p:spPr>
       </p:pic>
+      <p:sp>
+        <p:nvSpPr>
+          <p:cNvPr id="9" name="Rectangle 8"/>
+          <p:cNvSpPr/>
+          <p:nvPr/>
+        </p:nvSpPr>
+        <p:spPr>
+          <a:xfrm>
+            <a:off x="256032" y="6382512"/>
+            <a:ext cx="11935663" cy="18288"/>
+          </a:xfrm>
+          <a:prstGeom prst="rect">
+            <a:avLst/>
+          </a:prstGeom>
+          <a:solidFill>
+            <a:srgbClr val="CAD8E8"/>
+          </a:solidFill>
+          <a:ln>
+            <a:noFill/>
+          </a:ln>
+        </p:spPr>
+        <p:style>
+          <a:lnRef idx="1">
+            <a:schemeClr val="accent1"/>
+          </a:lnRef>
+          <a:fillRef idx="3">
+            <a:schemeClr val="accent1"/>
+          </a:fillRef>
+          <a:effectRef idx="2">
+            <a:schemeClr val="accent1"/>
+          </a:effectRef>
+          <a:fontRef idx="minor">
+            <a:schemeClr val="lt1"/>
+          </a:fontRef>
+        </p:style>
+        <p:txBody>
+          <a:bodyPr rtlCol="0" anchor="ctr"/>
+          <a:lstStyle/>
+          <a:p>
+            <a:pPr algn="ctr"/>
+          </a:p>
+        </p:txBody>
+      </p:sp>
+      <p:sp>
+        <p:nvSpPr>
+          <p:cNvPr id="10" name="TextBox 9"/>
+          <p:cNvSpPr txBox="1"/>
+          <p:nvPr/>
+        </p:nvSpPr>
+        <p:spPr>
+          <a:xfrm>
+            <a:off x="365760" y="6446520"/>
+            <a:ext cx="6095847" cy="274320"/>
+          </a:xfrm>
+          <a:prstGeom prst="rect">
+            <a:avLst/>
+          </a:prstGeom>
+          <a:noFill/>
+        </p:spPr>
+        <p:txBody>
+          <a:bodyPr wrap="none">
+            <a:spAutoFit/>
+          </a:bodyPr>
+          <a:lstStyle/>
+          <a:p>
+            <a:r>
+              <a:rPr sz="900">
+                <a:solidFill>
+                  <a:srgbClr val="5B6B7C"/>
+                </a:solidFill>
+                <a:latin typeface="Calibri"/>
+              </a:rPr>
+              <a:t>Transfer Pricing Methods</a:t>
+            </a:r>
+          </a:p>
+        </p:txBody>
+      </p:sp>
+      <p:sp>
+        <p:nvSpPr>
+          <p:cNvPr id="11" name="TextBox 10"/>
+          <p:cNvSpPr txBox="1"/>
+          <p:nvPr/>
+        </p:nvSpPr>
+        <p:spPr>
+          <a:xfrm>
+            <a:off x="11185855" y="6446520"/>
+            <a:ext cx="731520" cy="274320"/>
+          </a:xfrm>
+          <a:prstGeom prst="rect">
+            <a:avLst/>
+          </a:prstGeom>
+          <a:noFill/>
+        </p:spPr>
+        <p:txBody>
+          <a:bodyPr wrap="none">
+            <a:spAutoFit/>
+          </a:bodyPr>
+          <a:lstStyle/>
+          <a:p>
+            <a:pPr algn="r"/>
+            <a:r>
+              <a:rPr sz="900">
+                <a:solidFill>
+                  <a:srgbClr val="5B6B7C"/>
+                </a:solidFill>
+                <a:latin typeface="Calibri"/>
+              </a:rPr>
+              <a:t>14</a:t>
+            </a:r>
+          </a:p>
+        </p:txBody>
+      </p:sp>
     </p:spTree>
   </p:cSld>
   <p:clrMapOvr>
@@ -4804,7 +5662,7 @@
     <p:bg>
       <p:bgPr>
         <a:solidFill>
-          <a:srgbClr val="F5F8FC"/>
+          <a:srgbClr val="F8FAFC"/>
         </a:solidFill>
         <a:effectLst/>
       </p:bgPr>
@@ -4818,20 +5676,20 @@
       <p:grpSpPr/>
       <p:sp>
         <p:nvSpPr>
-          <p:cNvPr id="6" name="Oval 5"/>
+          <p:cNvPr id="7" name="Oval 6"/>
           <p:cNvSpPr/>
           <p:nvPr/>
         </p:nvSpPr>
         <p:spPr>
           <a:xfrm>
-            <a:off x="-1280160" y="4572000"/>
-            <a:ext cx="2926080" cy="2926080"/>
+            <a:off x="-1097280" y="4846320"/>
+            <a:ext cx="2743200" cy="2743200"/>
           </a:xfrm>
           <a:prstGeom prst="ellipse">
             <a:avLst/>
           </a:prstGeom>
           <a:solidFill>
-            <a:srgbClr val="8CAAC8"/>
+            <a:srgbClr val="CAD8E8"/>
           </a:solidFill>
           <a:ln>
             <a:noFill/>
@@ -4861,20 +5719,20 @@
       </p:sp>
       <p:sp>
         <p:nvSpPr>
-          <p:cNvPr id="5" name="Oval 4"/>
+          <p:cNvPr id="6" name="Oval 5"/>
           <p:cNvSpPr/>
           <p:nvPr/>
         </p:nvSpPr>
         <p:spPr>
           <a:xfrm>
-            <a:off x="9722815" y="-822960"/>
-            <a:ext cx="3291840" cy="3291840"/>
+            <a:off x="9631375" y="-914400"/>
+            <a:ext cx="2926080" cy="2926080"/>
           </a:xfrm>
           <a:prstGeom prst="ellipse">
             <a:avLst/>
           </a:prstGeom>
           <a:solidFill>
-            <a:srgbClr val="005CA0"/>
+            <a:srgbClr val="CAD8E8"/>
           </a:solidFill>
           <a:ln>
             <a:noFill/>
@@ -4904,6 +5762,49 @@
       </p:sp>
       <p:sp>
         <p:nvSpPr>
+          <p:cNvPr id="5" name="Rectangle 4"/>
+          <p:cNvSpPr/>
+          <p:nvPr/>
+        </p:nvSpPr>
+        <p:spPr>
+          <a:xfrm>
+            <a:off x="0" y="0"/>
+            <a:ext cx="12191695" cy="54864"/>
+          </a:xfrm>
+          <a:prstGeom prst="rect">
+            <a:avLst/>
+          </a:prstGeom>
+          <a:solidFill>
+            <a:srgbClr val="0B5394"/>
+          </a:solidFill>
+          <a:ln>
+            <a:noFill/>
+          </a:ln>
+        </p:spPr>
+        <p:style>
+          <a:lnRef idx="1">
+            <a:schemeClr val="accent1"/>
+          </a:lnRef>
+          <a:fillRef idx="3">
+            <a:schemeClr val="accent1"/>
+          </a:fillRef>
+          <a:effectRef idx="2">
+            <a:schemeClr val="accent1"/>
+          </a:effectRef>
+          <a:fontRef idx="minor">
+            <a:schemeClr val="lt1"/>
+          </a:fontRef>
+        </p:style>
+        <p:txBody>
+          <a:bodyPr rtlCol="0" anchor="ctr"/>
+          <a:lstStyle/>
+          <a:p>
+            <a:pPr algn="ctr"/>
+          </a:p>
+        </p:txBody>
+      </p:sp>
+      <p:sp>
+        <p:nvSpPr>
           <p:cNvPr id="4" name="Rectangle 3"/>
           <p:cNvSpPr/>
           <p:nvPr/>
@@ -4911,13 +5812,13 @@
         <p:spPr>
           <a:xfrm>
             <a:off x="0" y="0"/>
-            <a:ext cx="12191695" cy="256032"/>
+            <a:ext cx="256032" cy="6858000"/>
           </a:xfrm>
           <a:prstGeom prst="rect">
             <a:avLst/>
           </a:prstGeom>
           <a:solidFill>
-            <a:srgbClr val="005CA0"/>
+            <a:srgbClr val="0B5394"/>
           </a:solidFill>
           <a:ln>
             <a:noFill/>
@@ -4963,8 +5864,9 @@
             <a:r>
               <a:rPr sz="3200" b="1">
                 <a:solidFill>
-                  <a:srgbClr val="00467F"/>
-                </a:solidFill>
+                  <a:srgbClr val="0F3154"/>
+                </a:solidFill>
+                <a:latin typeface="Calibri"/>
               </a:rPr>
               <a:t>Key Takeaways</a:t>
             </a:r>
@@ -4992,6 +5894,7 @@
                 <a:solidFill>
                   <a:srgbClr val="282828"/>
                 </a:solidFill>
+                <a:latin typeface="Calibri"/>
               </a:rPr>
               <a:t>Arm’s length principle is the cornerstone of transfer pricing</a:t>
             </a:r>
@@ -5003,6 +5906,7 @@
                 <a:solidFill>
                   <a:srgbClr val="282828"/>
                 </a:solidFill>
+                <a:latin typeface="Calibri"/>
               </a:rPr>
               <a:t>Method choice depends on transaction type and data quality</a:t>
             </a:r>
@@ -5014,6 +5918,7 @@
                 <a:solidFill>
                   <a:srgbClr val="282828"/>
                 </a:solidFill>
+                <a:latin typeface="Calibri"/>
               </a:rPr>
               <a:t>Strong comparability analysis is essential</a:t>
             </a:r>
@@ -5025,6 +5930,7 @@
                 <a:solidFill>
                   <a:srgbClr val="282828"/>
                 </a:solidFill>
+                <a:latin typeface="Calibri"/>
               </a:rPr>
               <a:t>Documentation and consistency drive audit resilience</a:t>
             </a:r>
@@ -5036,8 +5942,121 @@
                 <a:solidFill>
                   <a:srgbClr val="282828"/>
                 </a:solidFill>
+                <a:latin typeface="Calibri"/>
               </a:rPr>
               <a:t>Questions?</a:t>
+            </a:r>
+          </a:p>
+        </p:txBody>
+      </p:sp>
+      <p:sp>
+        <p:nvSpPr>
+          <p:cNvPr id="8" name="Rectangle 7"/>
+          <p:cNvSpPr/>
+          <p:nvPr/>
+        </p:nvSpPr>
+        <p:spPr>
+          <a:xfrm>
+            <a:off x="256032" y="6382512"/>
+            <a:ext cx="11935663" cy="18288"/>
+          </a:xfrm>
+          <a:prstGeom prst="rect">
+            <a:avLst/>
+          </a:prstGeom>
+          <a:solidFill>
+            <a:srgbClr val="CAD8E8"/>
+          </a:solidFill>
+          <a:ln>
+            <a:noFill/>
+          </a:ln>
+        </p:spPr>
+        <p:style>
+          <a:lnRef idx="1">
+            <a:schemeClr val="accent1"/>
+          </a:lnRef>
+          <a:fillRef idx="3">
+            <a:schemeClr val="accent1"/>
+          </a:fillRef>
+          <a:effectRef idx="2">
+            <a:schemeClr val="accent1"/>
+          </a:effectRef>
+          <a:fontRef idx="minor">
+            <a:schemeClr val="lt1"/>
+          </a:fontRef>
+        </p:style>
+        <p:txBody>
+          <a:bodyPr rtlCol="0" anchor="ctr"/>
+          <a:lstStyle/>
+          <a:p>
+            <a:pPr algn="ctr"/>
+          </a:p>
+        </p:txBody>
+      </p:sp>
+      <p:sp>
+        <p:nvSpPr>
+          <p:cNvPr id="9" name="TextBox 8"/>
+          <p:cNvSpPr txBox="1"/>
+          <p:nvPr/>
+        </p:nvSpPr>
+        <p:spPr>
+          <a:xfrm>
+            <a:off x="365760" y="6446520"/>
+            <a:ext cx="6095847" cy="274320"/>
+          </a:xfrm>
+          <a:prstGeom prst="rect">
+            <a:avLst/>
+          </a:prstGeom>
+          <a:noFill/>
+        </p:spPr>
+        <p:txBody>
+          <a:bodyPr wrap="none">
+            <a:spAutoFit/>
+          </a:bodyPr>
+          <a:lstStyle/>
+          <a:p>
+            <a:r>
+              <a:rPr sz="900">
+                <a:solidFill>
+                  <a:srgbClr val="5B6B7C"/>
+                </a:solidFill>
+                <a:latin typeface="Calibri"/>
+              </a:rPr>
+              <a:t>Transfer Pricing Methods</a:t>
+            </a:r>
+          </a:p>
+        </p:txBody>
+      </p:sp>
+      <p:sp>
+        <p:nvSpPr>
+          <p:cNvPr id="10" name="TextBox 9"/>
+          <p:cNvSpPr txBox="1"/>
+          <p:nvPr/>
+        </p:nvSpPr>
+        <p:spPr>
+          <a:xfrm>
+            <a:off x="11185855" y="6446520"/>
+            <a:ext cx="731520" cy="274320"/>
+          </a:xfrm>
+          <a:prstGeom prst="rect">
+            <a:avLst/>
+          </a:prstGeom>
+          <a:noFill/>
+        </p:spPr>
+        <p:txBody>
+          <a:bodyPr wrap="none">
+            <a:spAutoFit/>
+          </a:bodyPr>
+          <a:lstStyle/>
+          <a:p>
+            <a:pPr algn="r"/>
+            <a:r>
+              <a:rPr sz="900">
+                <a:solidFill>
+                  <a:srgbClr val="5B6B7C"/>
+                </a:solidFill>
+                <a:latin typeface="Calibri"/>
+              </a:rPr>
+              <a:t>15</a:t>
             </a:r>
           </a:p>
         </p:txBody>
@@ -5056,7 +6075,7 @@
     <p:bg>
       <p:bgPr>
         <a:solidFill>
-          <a:srgbClr val="F5F8FC"/>
+          <a:srgbClr val="F8FAFC"/>
         </a:solidFill>
         <a:effectLst/>
       </p:bgPr>
@@ -5070,20 +6089,20 @@
       <p:grpSpPr/>
       <p:sp>
         <p:nvSpPr>
-          <p:cNvPr id="6" name="Oval 5"/>
+          <p:cNvPr id="7" name="Oval 6"/>
           <p:cNvSpPr/>
           <p:nvPr/>
         </p:nvSpPr>
         <p:spPr>
           <a:xfrm>
-            <a:off x="-1280160" y="4572000"/>
-            <a:ext cx="2926080" cy="2926080"/>
+            <a:off x="-1097280" y="4846320"/>
+            <a:ext cx="2743200" cy="2743200"/>
           </a:xfrm>
           <a:prstGeom prst="ellipse">
             <a:avLst/>
           </a:prstGeom>
           <a:solidFill>
-            <a:srgbClr val="8CAAC8"/>
+            <a:srgbClr val="CAD8E8"/>
           </a:solidFill>
           <a:ln>
             <a:noFill/>
@@ -5113,20 +6132,20 @@
       </p:sp>
       <p:sp>
         <p:nvSpPr>
-          <p:cNvPr id="5" name="Oval 4"/>
+          <p:cNvPr id="6" name="Oval 5"/>
           <p:cNvSpPr/>
           <p:nvPr/>
         </p:nvSpPr>
         <p:spPr>
           <a:xfrm>
-            <a:off x="9722815" y="-822960"/>
-            <a:ext cx="3291840" cy="3291840"/>
+            <a:off x="9631375" y="-914400"/>
+            <a:ext cx="2926080" cy="2926080"/>
           </a:xfrm>
           <a:prstGeom prst="ellipse">
             <a:avLst/>
           </a:prstGeom>
           <a:solidFill>
-            <a:srgbClr val="005CA0"/>
+            <a:srgbClr val="CAD8E8"/>
           </a:solidFill>
           <a:ln>
             <a:noFill/>
@@ -5156,6 +6175,49 @@
       </p:sp>
       <p:sp>
         <p:nvSpPr>
+          <p:cNvPr id="5" name="Rectangle 4"/>
+          <p:cNvSpPr/>
+          <p:nvPr/>
+        </p:nvSpPr>
+        <p:spPr>
+          <a:xfrm>
+            <a:off x="0" y="0"/>
+            <a:ext cx="12191695" cy="54864"/>
+          </a:xfrm>
+          <a:prstGeom prst="rect">
+            <a:avLst/>
+          </a:prstGeom>
+          <a:solidFill>
+            <a:srgbClr val="0B5394"/>
+          </a:solidFill>
+          <a:ln>
+            <a:noFill/>
+          </a:ln>
+        </p:spPr>
+        <p:style>
+          <a:lnRef idx="1">
+            <a:schemeClr val="accent1"/>
+          </a:lnRef>
+          <a:fillRef idx="3">
+            <a:schemeClr val="accent1"/>
+          </a:fillRef>
+          <a:effectRef idx="2">
+            <a:schemeClr val="accent1"/>
+          </a:effectRef>
+          <a:fontRef idx="minor">
+            <a:schemeClr val="lt1"/>
+          </a:fontRef>
+        </p:style>
+        <p:txBody>
+          <a:bodyPr rtlCol="0" anchor="ctr"/>
+          <a:lstStyle/>
+          <a:p>
+            <a:pPr algn="ctr"/>
+          </a:p>
+        </p:txBody>
+      </p:sp>
+      <p:sp>
+        <p:nvSpPr>
           <p:cNvPr id="4" name="Rectangle 3"/>
           <p:cNvSpPr/>
           <p:nvPr/>
@@ -5163,13 +6225,13 @@
         <p:spPr>
           <a:xfrm>
             <a:off x="0" y="0"/>
-            <a:ext cx="12191695" cy="256032"/>
+            <a:ext cx="256032" cy="6858000"/>
           </a:xfrm>
           <a:prstGeom prst="rect">
             <a:avLst/>
           </a:prstGeom>
           <a:solidFill>
-            <a:srgbClr val="005CA0"/>
+            <a:srgbClr val="0B5394"/>
           </a:solidFill>
           <a:ln>
             <a:noFill/>
@@ -5215,8 +6277,9 @@
             <a:r>
               <a:rPr sz="3200" b="1">
                 <a:solidFill>
-                  <a:srgbClr val="00467F"/>
-                </a:solidFill>
+                  <a:srgbClr val="0F3154"/>
+                </a:solidFill>
+                <a:latin typeface="Calibri"/>
               </a:rPr>
               <a:t>Agenda</a:t>
             </a:r>
@@ -5244,6 +6307,7 @@
                 <a:solidFill>
                   <a:srgbClr val="282828"/>
                 </a:solidFill>
+                <a:latin typeface="Calibri"/>
               </a:rPr>
               <a:t>Why transfer pricing matters</a:t>
             </a:r>
@@ -5255,6 +6319,7 @@
                 <a:solidFill>
                   <a:srgbClr val="282828"/>
                 </a:solidFill>
+                <a:latin typeface="Calibri"/>
               </a:rPr>
               <a:t>Regulatory framework and arm’s length principle</a:t>
             </a:r>
@@ -5266,6 +6331,7 @@
                 <a:solidFill>
                   <a:srgbClr val="282828"/>
                 </a:solidFill>
+                <a:latin typeface="Calibri"/>
               </a:rPr>
               <a:t>Comparability analysis and method selection</a:t>
             </a:r>
@@ -5277,6 +6343,7 @@
                 <a:solidFill>
                   <a:srgbClr val="282828"/>
                 </a:solidFill>
+                <a:latin typeface="Calibri"/>
               </a:rPr>
               <a:t>Accepted transfer pricing methods</a:t>
             </a:r>
@@ -5288,8 +6355,121 @@
                 <a:solidFill>
                   <a:srgbClr val="282828"/>
                 </a:solidFill>
+                <a:latin typeface="Calibri"/>
               </a:rPr>
               <a:t>Documentation, compliance, and key takeaways</a:t>
+            </a:r>
+          </a:p>
+        </p:txBody>
+      </p:sp>
+      <p:sp>
+        <p:nvSpPr>
+          <p:cNvPr id="8" name="Rectangle 7"/>
+          <p:cNvSpPr/>
+          <p:nvPr/>
+        </p:nvSpPr>
+        <p:spPr>
+          <a:xfrm>
+            <a:off x="256032" y="6382512"/>
+            <a:ext cx="11935663" cy="18288"/>
+          </a:xfrm>
+          <a:prstGeom prst="rect">
+            <a:avLst/>
+          </a:prstGeom>
+          <a:solidFill>
+            <a:srgbClr val="CAD8E8"/>
+          </a:solidFill>
+          <a:ln>
+            <a:noFill/>
+          </a:ln>
+        </p:spPr>
+        <p:style>
+          <a:lnRef idx="1">
+            <a:schemeClr val="accent1"/>
+          </a:lnRef>
+          <a:fillRef idx="3">
+            <a:schemeClr val="accent1"/>
+          </a:fillRef>
+          <a:effectRef idx="2">
+            <a:schemeClr val="accent1"/>
+          </a:effectRef>
+          <a:fontRef idx="minor">
+            <a:schemeClr val="lt1"/>
+          </a:fontRef>
+        </p:style>
+        <p:txBody>
+          <a:bodyPr rtlCol="0" anchor="ctr"/>
+          <a:lstStyle/>
+          <a:p>
+            <a:pPr algn="ctr"/>
+          </a:p>
+        </p:txBody>
+      </p:sp>
+      <p:sp>
+        <p:nvSpPr>
+          <p:cNvPr id="9" name="TextBox 8"/>
+          <p:cNvSpPr txBox="1"/>
+          <p:nvPr/>
+        </p:nvSpPr>
+        <p:spPr>
+          <a:xfrm>
+            <a:off x="365760" y="6446520"/>
+            <a:ext cx="6095847" cy="274320"/>
+          </a:xfrm>
+          <a:prstGeom prst="rect">
+            <a:avLst/>
+          </a:prstGeom>
+          <a:noFill/>
+        </p:spPr>
+        <p:txBody>
+          <a:bodyPr wrap="none">
+            <a:spAutoFit/>
+          </a:bodyPr>
+          <a:lstStyle/>
+          <a:p>
+            <a:r>
+              <a:rPr sz="900">
+                <a:solidFill>
+                  <a:srgbClr val="5B6B7C"/>
+                </a:solidFill>
+                <a:latin typeface="Calibri"/>
+              </a:rPr>
+              <a:t>Transfer Pricing Methods</a:t>
+            </a:r>
+          </a:p>
+        </p:txBody>
+      </p:sp>
+      <p:sp>
+        <p:nvSpPr>
+          <p:cNvPr id="10" name="TextBox 9"/>
+          <p:cNvSpPr txBox="1"/>
+          <p:nvPr/>
+        </p:nvSpPr>
+        <p:spPr>
+          <a:xfrm>
+            <a:off x="11185855" y="6446520"/>
+            <a:ext cx="731520" cy="274320"/>
+          </a:xfrm>
+          <a:prstGeom prst="rect">
+            <a:avLst/>
+          </a:prstGeom>
+          <a:noFill/>
+        </p:spPr>
+        <p:txBody>
+          <a:bodyPr wrap="none">
+            <a:spAutoFit/>
+          </a:bodyPr>
+          <a:lstStyle/>
+          <a:p>
+            <a:pPr algn="r"/>
+            <a:r>
+              <a:rPr sz="900">
+                <a:solidFill>
+                  <a:srgbClr val="5B6B7C"/>
+                </a:solidFill>
+                <a:latin typeface="Calibri"/>
+              </a:rPr>
+              <a:t>2</a:t>
             </a:r>
           </a:p>
         </p:txBody>
@@ -5308,7 +6488,7 @@
     <p:bg>
       <p:bgPr>
         <a:solidFill>
-          <a:srgbClr val="F5F8FC"/>
+          <a:srgbClr val="F8FAFC"/>
         </a:solidFill>
         <a:effectLst/>
       </p:bgPr>
@@ -5322,20 +6502,20 @@
       <p:grpSpPr/>
       <p:sp>
         <p:nvSpPr>
-          <p:cNvPr id="9" name="Oval 8"/>
+          <p:cNvPr id="10" name="Oval 9"/>
           <p:cNvSpPr/>
           <p:nvPr/>
         </p:nvSpPr>
         <p:spPr>
           <a:xfrm>
-            <a:off x="-1280160" y="4572000"/>
-            <a:ext cx="2926080" cy="2926080"/>
+            <a:off x="-1097280" y="4846320"/>
+            <a:ext cx="2743200" cy="2743200"/>
           </a:xfrm>
           <a:prstGeom prst="ellipse">
             <a:avLst/>
           </a:prstGeom>
           <a:solidFill>
-            <a:srgbClr val="8CAAC8"/>
+            <a:srgbClr val="CAD8E8"/>
           </a:solidFill>
           <a:ln>
             <a:noFill/>
@@ -5365,20 +6545,20 @@
       </p:sp>
       <p:sp>
         <p:nvSpPr>
-          <p:cNvPr id="8" name="Oval 7"/>
+          <p:cNvPr id="9" name="Oval 8"/>
           <p:cNvSpPr/>
           <p:nvPr/>
         </p:nvSpPr>
         <p:spPr>
           <a:xfrm>
-            <a:off x="9722815" y="-822960"/>
-            <a:ext cx="3291840" cy="3291840"/>
+            <a:off x="9631375" y="-914400"/>
+            <a:ext cx="2926080" cy="2926080"/>
           </a:xfrm>
           <a:prstGeom prst="ellipse">
             <a:avLst/>
           </a:prstGeom>
           <a:solidFill>
-            <a:srgbClr val="005CA0"/>
+            <a:srgbClr val="CAD8E8"/>
           </a:solidFill>
           <a:ln>
             <a:noFill/>
@@ -5408,6 +6588,49 @@
       </p:sp>
       <p:sp>
         <p:nvSpPr>
+          <p:cNvPr id="8" name="Rectangle 7"/>
+          <p:cNvSpPr/>
+          <p:nvPr/>
+        </p:nvSpPr>
+        <p:spPr>
+          <a:xfrm>
+            <a:off x="0" y="0"/>
+            <a:ext cx="12191695" cy="54864"/>
+          </a:xfrm>
+          <a:prstGeom prst="rect">
+            <a:avLst/>
+          </a:prstGeom>
+          <a:solidFill>
+            <a:srgbClr val="0B5394"/>
+          </a:solidFill>
+          <a:ln>
+            <a:noFill/>
+          </a:ln>
+        </p:spPr>
+        <p:style>
+          <a:lnRef idx="1">
+            <a:schemeClr val="accent1"/>
+          </a:lnRef>
+          <a:fillRef idx="3">
+            <a:schemeClr val="accent1"/>
+          </a:fillRef>
+          <a:effectRef idx="2">
+            <a:schemeClr val="accent1"/>
+          </a:effectRef>
+          <a:fontRef idx="minor">
+            <a:schemeClr val="lt1"/>
+          </a:fontRef>
+        </p:style>
+        <p:txBody>
+          <a:bodyPr rtlCol="0" anchor="ctr"/>
+          <a:lstStyle/>
+          <a:p>
+            <a:pPr algn="ctr"/>
+          </a:p>
+        </p:txBody>
+      </p:sp>
+      <p:sp>
+        <p:nvSpPr>
           <p:cNvPr id="7" name="Rectangle 6"/>
           <p:cNvSpPr/>
           <p:nvPr/>
@@ -5415,13 +6638,13 @@
         <p:spPr>
           <a:xfrm>
             <a:off x="0" y="0"/>
-            <a:ext cx="12191695" cy="256032"/>
+            <a:ext cx="256032" cy="6858000"/>
           </a:xfrm>
           <a:prstGeom prst="rect">
             <a:avLst/>
           </a:prstGeom>
           <a:solidFill>
-            <a:srgbClr val="005CA0"/>
+            <a:srgbClr val="0B5394"/>
           </a:solidFill>
           <a:ln>
             <a:noFill/>
@@ -5469,6 +6692,7 @@
                 <a:solidFill>
                   <a:srgbClr val="00467F"/>
                 </a:solidFill>
+                <a:latin typeface="Calibri"/>
               </a:rPr>
               <a:t>Transfer Pricing Overview</a:t>
             </a:r>
@@ -5497,10 +6721,11 @@
           <a:p>
             <a:pPr/>
             <a:r>
-              <a:rPr sz="2200" b="0">
-                <a:solidFill>
-                  <a:srgbClr val="282828"/>
-                </a:solidFill>
+              <a:rPr sz="2200" b="1">
+                <a:solidFill>
+                  <a:srgbClr val="0F3154"/>
+                </a:solidFill>
+                <a:latin typeface="Calibri"/>
               </a:rPr>
               <a:t>Pricing of transactions between related parties</a:t>
             </a:r>
@@ -5508,10 +6733,11 @@
           <a:p>
             <a:pPr/>
             <a:r>
-              <a:rPr sz="2200" b="0">
-                <a:solidFill>
-                  <a:srgbClr val="282828"/>
-                </a:solidFill>
+              <a:rPr sz="2200" b="1">
+                <a:solidFill>
+                  <a:srgbClr val="0F3154"/>
+                </a:solidFill>
+                <a:latin typeface="Calibri"/>
               </a:rPr>
               <a:t>Determines how profits are allocated across tax jurisdictions</a:t>
             </a:r>
@@ -5519,10 +6745,11 @@
           <a:p>
             <a:pPr/>
             <a:r>
-              <a:rPr sz="2200" b="0">
-                <a:solidFill>
-                  <a:srgbClr val="282828"/>
-                </a:solidFill>
+              <a:rPr sz="2200" b="1">
+                <a:solidFill>
+                  <a:srgbClr val="0F3154"/>
+                </a:solidFill>
+                <a:latin typeface="Calibri"/>
               </a:rPr>
               <a:t>Focus of tax authorities to prevent base erosion and profit shifting</a:t>
             </a:r>
@@ -5530,10 +6757,11 @@
           <a:p>
             <a:pPr/>
             <a:r>
-              <a:rPr sz="2200" b="0">
-                <a:solidFill>
-                  <a:srgbClr val="282828"/>
-                </a:solidFill>
+              <a:rPr sz="2200" b="1">
+                <a:solidFill>
+                  <a:srgbClr val="0F3154"/>
+                </a:solidFill>
+                <a:latin typeface="Calibri"/>
               </a:rPr>
               <a:t>Must align with economic substance and value creation</a:t>
             </a:r>
@@ -5586,6 +6814,7 @@
                 <a:solidFill>
                   <a:srgbClr val="00467F"/>
                 </a:solidFill>
+                <a:latin typeface="Calibri"/>
               </a:rPr>
               <a:t>Parent Co.</a:t>
             </a:r>
@@ -5638,6 +6867,7 @@
                 <a:solidFill>
                   <a:srgbClr val="00467F"/>
                 </a:solidFill>
+                <a:latin typeface="Calibri"/>
               </a:rPr>
               <a:t>Subsidiary</a:t>
             </a:r>
@@ -5679,6 +6909,118 @@
           </a:fontRef>
         </p:style>
       </p:cxnSp>
+      <p:sp>
+        <p:nvSpPr>
+          <p:cNvPr id="11" name="Rectangle 10"/>
+          <p:cNvSpPr/>
+          <p:nvPr/>
+        </p:nvSpPr>
+        <p:spPr>
+          <a:xfrm>
+            <a:off x="256032" y="6382512"/>
+            <a:ext cx="11935663" cy="18288"/>
+          </a:xfrm>
+          <a:prstGeom prst="rect">
+            <a:avLst/>
+          </a:prstGeom>
+          <a:solidFill>
+            <a:srgbClr val="CAD8E8"/>
+          </a:solidFill>
+          <a:ln>
+            <a:noFill/>
+          </a:ln>
+        </p:spPr>
+        <p:style>
+          <a:lnRef idx="1">
+            <a:schemeClr val="accent1"/>
+          </a:lnRef>
+          <a:fillRef idx="3">
+            <a:schemeClr val="accent1"/>
+          </a:fillRef>
+          <a:effectRef idx="2">
+            <a:schemeClr val="accent1"/>
+          </a:effectRef>
+          <a:fontRef idx="minor">
+            <a:schemeClr val="lt1"/>
+          </a:fontRef>
+        </p:style>
+        <p:txBody>
+          <a:bodyPr rtlCol="0" anchor="ctr"/>
+          <a:lstStyle/>
+          <a:p>
+            <a:pPr algn="ctr"/>
+          </a:p>
+        </p:txBody>
+      </p:sp>
+      <p:sp>
+        <p:nvSpPr>
+          <p:cNvPr id="12" name="TextBox 11"/>
+          <p:cNvSpPr txBox="1"/>
+          <p:nvPr/>
+        </p:nvSpPr>
+        <p:spPr>
+          <a:xfrm>
+            <a:off x="365760" y="6446520"/>
+            <a:ext cx="6095847" cy="274320"/>
+          </a:xfrm>
+          <a:prstGeom prst="rect">
+            <a:avLst/>
+          </a:prstGeom>
+          <a:noFill/>
+        </p:spPr>
+        <p:txBody>
+          <a:bodyPr wrap="none">
+            <a:spAutoFit/>
+          </a:bodyPr>
+          <a:lstStyle/>
+          <a:p>
+            <a:r>
+              <a:rPr sz="900">
+                <a:solidFill>
+                  <a:srgbClr val="5B6B7C"/>
+                </a:solidFill>
+                <a:latin typeface="Calibri"/>
+              </a:rPr>
+              <a:t>Transfer Pricing Methods</a:t>
+            </a:r>
+          </a:p>
+        </p:txBody>
+      </p:sp>
+      <p:sp>
+        <p:nvSpPr>
+          <p:cNvPr id="13" name="TextBox 12"/>
+          <p:cNvSpPr txBox="1"/>
+          <p:nvPr/>
+        </p:nvSpPr>
+        <p:spPr>
+          <a:xfrm>
+            <a:off x="11185855" y="6446520"/>
+            <a:ext cx="731520" cy="274320"/>
+          </a:xfrm>
+          <a:prstGeom prst="rect">
+            <a:avLst/>
+          </a:prstGeom>
+          <a:noFill/>
+        </p:spPr>
+        <p:txBody>
+          <a:bodyPr wrap="none">
+            <a:spAutoFit/>
+          </a:bodyPr>
+          <a:lstStyle/>
+          <a:p>
+            <a:pPr algn="r"/>
+            <a:r>
+              <a:rPr sz="900">
+                <a:solidFill>
+                  <a:srgbClr val="5B6B7C"/>
+                </a:solidFill>
+                <a:latin typeface="Calibri"/>
+              </a:rPr>
+              <a:t>3</a:t>
+            </a:r>
+          </a:p>
+        </p:txBody>
+      </p:sp>
     </p:spTree>
   </p:cSld>
   <p:clrMapOvr>
@@ -5693,7 +7035,7 @@
     <p:bg>
       <p:bgPr>
         <a:solidFill>
-          <a:srgbClr val="F5F8FC"/>
+          <a:srgbClr val="F8FAFC"/>
         </a:solidFill>
         <a:effectLst/>
       </p:bgPr>
@@ -5707,20 +7049,20 @@
       <p:grpSpPr/>
       <p:sp>
         <p:nvSpPr>
-          <p:cNvPr id="6" name="Oval 5"/>
+          <p:cNvPr id="7" name="Oval 6"/>
           <p:cNvSpPr/>
           <p:nvPr/>
         </p:nvSpPr>
         <p:spPr>
           <a:xfrm>
-            <a:off x="-1280160" y="4572000"/>
-            <a:ext cx="2926080" cy="2926080"/>
+            <a:off x="-1097280" y="4846320"/>
+            <a:ext cx="2743200" cy="2743200"/>
           </a:xfrm>
           <a:prstGeom prst="ellipse">
             <a:avLst/>
           </a:prstGeom>
           <a:solidFill>
-            <a:srgbClr val="8CAAC8"/>
+            <a:srgbClr val="CAD8E8"/>
           </a:solidFill>
           <a:ln>
             <a:noFill/>
@@ -5750,20 +7092,20 @@
       </p:sp>
       <p:sp>
         <p:nvSpPr>
-          <p:cNvPr id="5" name="Oval 4"/>
+          <p:cNvPr id="6" name="Oval 5"/>
           <p:cNvSpPr/>
           <p:nvPr/>
         </p:nvSpPr>
         <p:spPr>
           <a:xfrm>
-            <a:off x="9722815" y="-822960"/>
-            <a:ext cx="3291840" cy="3291840"/>
+            <a:off x="9631375" y="-914400"/>
+            <a:ext cx="2926080" cy="2926080"/>
           </a:xfrm>
           <a:prstGeom prst="ellipse">
             <a:avLst/>
           </a:prstGeom>
           <a:solidFill>
-            <a:srgbClr val="005CA0"/>
+            <a:srgbClr val="CAD8E8"/>
           </a:solidFill>
           <a:ln>
             <a:noFill/>
@@ -5793,6 +7135,49 @@
       </p:sp>
       <p:sp>
         <p:nvSpPr>
+          <p:cNvPr id="5" name="Rectangle 4"/>
+          <p:cNvSpPr/>
+          <p:nvPr/>
+        </p:nvSpPr>
+        <p:spPr>
+          <a:xfrm>
+            <a:off x="0" y="0"/>
+            <a:ext cx="12191695" cy="54864"/>
+          </a:xfrm>
+          <a:prstGeom prst="rect">
+            <a:avLst/>
+          </a:prstGeom>
+          <a:solidFill>
+            <a:srgbClr val="0B5394"/>
+          </a:solidFill>
+          <a:ln>
+            <a:noFill/>
+          </a:ln>
+        </p:spPr>
+        <p:style>
+          <a:lnRef idx="1">
+            <a:schemeClr val="accent1"/>
+          </a:lnRef>
+          <a:fillRef idx="3">
+            <a:schemeClr val="accent1"/>
+          </a:fillRef>
+          <a:effectRef idx="2">
+            <a:schemeClr val="accent1"/>
+          </a:effectRef>
+          <a:fontRef idx="minor">
+            <a:schemeClr val="lt1"/>
+          </a:fontRef>
+        </p:style>
+        <p:txBody>
+          <a:bodyPr rtlCol="0" anchor="ctr"/>
+          <a:lstStyle/>
+          <a:p>
+            <a:pPr algn="ctr"/>
+          </a:p>
+        </p:txBody>
+      </p:sp>
+      <p:sp>
+        <p:nvSpPr>
           <p:cNvPr id="4" name="Rectangle 3"/>
           <p:cNvSpPr/>
           <p:nvPr/>
@@ -5800,13 +7185,13 @@
         <p:spPr>
           <a:xfrm>
             <a:off x="0" y="0"/>
-            <a:ext cx="12191695" cy="256032"/>
+            <a:ext cx="256032" cy="6858000"/>
           </a:xfrm>
           <a:prstGeom prst="rect">
             <a:avLst/>
           </a:prstGeom>
           <a:solidFill>
-            <a:srgbClr val="005CA0"/>
+            <a:srgbClr val="0B5394"/>
           </a:solidFill>
           <a:ln>
             <a:noFill/>
@@ -5852,8 +7237,9 @@
             <a:r>
               <a:rPr sz="3200" b="1">
                 <a:solidFill>
-                  <a:srgbClr val="00467F"/>
-                </a:solidFill>
+                  <a:srgbClr val="0F3154"/>
+                </a:solidFill>
+                <a:latin typeface="Calibri"/>
               </a:rPr>
               <a:t>Regulatory Framework</a:t>
             </a:r>
@@ -5881,6 +7267,7 @@
                 <a:solidFill>
                   <a:srgbClr val="282828"/>
                 </a:solidFill>
+                <a:latin typeface="Calibri"/>
               </a:rPr>
               <a:t>OECD Transfer Pricing Guidelines (global standard)</a:t>
             </a:r>
@@ -5892,6 +7279,7 @@
                 <a:solidFill>
                   <a:srgbClr val="282828"/>
                 </a:solidFill>
+                <a:latin typeface="Calibri"/>
               </a:rPr>
               <a:t>Germany: Außensteuergesetz (AStG) and BMF administrative principles</a:t>
             </a:r>
@@ -5903,6 +7291,7 @@
                 <a:solidFill>
                   <a:srgbClr val="282828"/>
                 </a:solidFill>
+                <a:latin typeface="Calibri"/>
               </a:rPr>
               <a:t>EU Joint Transfer Pricing Forum guidance</a:t>
             </a:r>
@@ -5914,6 +7303,7 @@
                 <a:solidFill>
                   <a:srgbClr val="282828"/>
                 </a:solidFill>
+                <a:latin typeface="Calibri"/>
               </a:rPr>
               <a:t>UN Transfer Pricing Manual for developing countries</a:t>
             </a:r>
@@ -5925,8 +7315,121 @@
                 <a:solidFill>
                   <a:srgbClr val="282828"/>
                 </a:solidFill>
+                <a:latin typeface="Calibri"/>
               </a:rPr>
               <a:t>Domestic law and tax treaty obligations</a:t>
+            </a:r>
+          </a:p>
+        </p:txBody>
+      </p:sp>
+      <p:sp>
+        <p:nvSpPr>
+          <p:cNvPr id="8" name="Rectangle 7"/>
+          <p:cNvSpPr/>
+          <p:nvPr/>
+        </p:nvSpPr>
+        <p:spPr>
+          <a:xfrm>
+            <a:off x="256032" y="6382512"/>
+            <a:ext cx="11935663" cy="18288"/>
+          </a:xfrm>
+          <a:prstGeom prst="rect">
+            <a:avLst/>
+          </a:prstGeom>
+          <a:solidFill>
+            <a:srgbClr val="CAD8E8"/>
+          </a:solidFill>
+          <a:ln>
+            <a:noFill/>
+          </a:ln>
+        </p:spPr>
+        <p:style>
+          <a:lnRef idx="1">
+            <a:schemeClr val="accent1"/>
+          </a:lnRef>
+          <a:fillRef idx="3">
+            <a:schemeClr val="accent1"/>
+          </a:fillRef>
+          <a:effectRef idx="2">
+            <a:schemeClr val="accent1"/>
+          </a:effectRef>
+          <a:fontRef idx="minor">
+            <a:schemeClr val="lt1"/>
+          </a:fontRef>
+        </p:style>
+        <p:txBody>
+          <a:bodyPr rtlCol="0" anchor="ctr"/>
+          <a:lstStyle/>
+          <a:p>
+            <a:pPr algn="ctr"/>
+          </a:p>
+        </p:txBody>
+      </p:sp>
+      <p:sp>
+        <p:nvSpPr>
+          <p:cNvPr id="9" name="TextBox 8"/>
+          <p:cNvSpPr txBox="1"/>
+          <p:nvPr/>
+        </p:nvSpPr>
+        <p:spPr>
+          <a:xfrm>
+            <a:off x="365760" y="6446520"/>
+            <a:ext cx="6095847" cy="274320"/>
+          </a:xfrm>
+          <a:prstGeom prst="rect">
+            <a:avLst/>
+          </a:prstGeom>
+          <a:noFill/>
+        </p:spPr>
+        <p:txBody>
+          <a:bodyPr wrap="none">
+            <a:spAutoFit/>
+          </a:bodyPr>
+          <a:lstStyle/>
+          <a:p>
+            <a:r>
+              <a:rPr sz="900">
+                <a:solidFill>
+                  <a:srgbClr val="5B6B7C"/>
+                </a:solidFill>
+                <a:latin typeface="Calibri"/>
+              </a:rPr>
+              <a:t>Transfer Pricing Methods</a:t>
+            </a:r>
+          </a:p>
+        </p:txBody>
+      </p:sp>
+      <p:sp>
+        <p:nvSpPr>
+          <p:cNvPr id="10" name="TextBox 9"/>
+          <p:cNvSpPr txBox="1"/>
+          <p:nvPr/>
+        </p:nvSpPr>
+        <p:spPr>
+          <a:xfrm>
+            <a:off x="11185855" y="6446520"/>
+            <a:ext cx="731520" cy="274320"/>
+          </a:xfrm>
+          <a:prstGeom prst="rect">
+            <a:avLst/>
+          </a:prstGeom>
+          <a:noFill/>
+        </p:spPr>
+        <p:txBody>
+          <a:bodyPr wrap="none">
+            <a:spAutoFit/>
+          </a:bodyPr>
+          <a:lstStyle/>
+          <a:p>
+            <a:pPr algn="r"/>
+            <a:r>
+              <a:rPr sz="900">
+                <a:solidFill>
+                  <a:srgbClr val="5B6B7C"/>
+                </a:solidFill>
+                <a:latin typeface="Calibri"/>
+              </a:rPr>
+              <a:t>4</a:t>
             </a:r>
           </a:p>
         </p:txBody>
@@ -5945,7 +7448,7 @@
     <p:bg>
       <p:bgPr>
         <a:solidFill>
-          <a:srgbClr val="F5F8FC"/>
+          <a:srgbClr val="F8FAFC"/>
         </a:solidFill>
         <a:effectLst/>
       </p:bgPr>
@@ -5959,20 +7462,20 @@
       <p:grpSpPr/>
       <p:sp>
         <p:nvSpPr>
-          <p:cNvPr id="6" name="Oval 5"/>
+          <p:cNvPr id="7" name="Oval 6"/>
           <p:cNvSpPr/>
           <p:nvPr/>
         </p:nvSpPr>
         <p:spPr>
           <a:xfrm>
-            <a:off x="-1280160" y="4572000"/>
-            <a:ext cx="2926080" cy="2926080"/>
+            <a:off x="-1097280" y="4846320"/>
+            <a:ext cx="2743200" cy="2743200"/>
           </a:xfrm>
           <a:prstGeom prst="ellipse">
             <a:avLst/>
           </a:prstGeom>
           <a:solidFill>
-            <a:srgbClr val="8CAAC8"/>
+            <a:srgbClr val="CAD8E8"/>
           </a:solidFill>
           <a:ln>
             <a:noFill/>
@@ -6002,20 +7505,20 @@
       </p:sp>
       <p:sp>
         <p:nvSpPr>
-          <p:cNvPr id="5" name="Oval 4"/>
+          <p:cNvPr id="6" name="Oval 5"/>
           <p:cNvSpPr/>
           <p:nvPr/>
         </p:nvSpPr>
         <p:spPr>
           <a:xfrm>
-            <a:off x="9722815" y="-822960"/>
-            <a:ext cx="3291840" cy="3291840"/>
+            <a:off x="9631375" y="-914400"/>
+            <a:ext cx="2926080" cy="2926080"/>
           </a:xfrm>
           <a:prstGeom prst="ellipse">
             <a:avLst/>
           </a:prstGeom>
           <a:solidFill>
-            <a:srgbClr val="005CA0"/>
+            <a:srgbClr val="CAD8E8"/>
           </a:solidFill>
           <a:ln>
             <a:noFill/>
@@ -6045,6 +7548,49 @@
       </p:sp>
       <p:sp>
         <p:nvSpPr>
+          <p:cNvPr id="5" name="Rectangle 4"/>
+          <p:cNvSpPr/>
+          <p:nvPr/>
+        </p:nvSpPr>
+        <p:spPr>
+          <a:xfrm>
+            <a:off x="0" y="0"/>
+            <a:ext cx="12191695" cy="54864"/>
+          </a:xfrm>
+          <a:prstGeom prst="rect">
+            <a:avLst/>
+          </a:prstGeom>
+          <a:solidFill>
+            <a:srgbClr val="0B5394"/>
+          </a:solidFill>
+          <a:ln>
+            <a:noFill/>
+          </a:ln>
+        </p:spPr>
+        <p:style>
+          <a:lnRef idx="1">
+            <a:schemeClr val="accent1"/>
+          </a:lnRef>
+          <a:fillRef idx="3">
+            <a:schemeClr val="accent1"/>
+          </a:fillRef>
+          <a:effectRef idx="2">
+            <a:schemeClr val="accent1"/>
+          </a:effectRef>
+          <a:fontRef idx="minor">
+            <a:schemeClr val="lt1"/>
+          </a:fontRef>
+        </p:style>
+        <p:txBody>
+          <a:bodyPr rtlCol="0" anchor="ctr"/>
+          <a:lstStyle/>
+          <a:p>
+            <a:pPr algn="ctr"/>
+          </a:p>
+        </p:txBody>
+      </p:sp>
+      <p:sp>
+        <p:nvSpPr>
           <p:cNvPr id="4" name="Rectangle 3"/>
           <p:cNvSpPr/>
           <p:nvPr/>
@@ -6052,13 +7598,13 @@
         <p:spPr>
           <a:xfrm>
             <a:off x="0" y="0"/>
-            <a:ext cx="12191695" cy="256032"/>
+            <a:ext cx="256032" cy="6858000"/>
           </a:xfrm>
           <a:prstGeom prst="rect">
             <a:avLst/>
           </a:prstGeom>
           <a:solidFill>
-            <a:srgbClr val="005CA0"/>
+            <a:srgbClr val="0B5394"/>
           </a:solidFill>
           <a:ln>
             <a:noFill/>
@@ -6104,8 +7650,9 @@
             <a:r>
               <a:rPr sz="3200" b="1">
                 <a:solidFill>
-                  <a:srgbClr val="00467F"/>
-                </a:solidFill>
+                  <a:srgbClr val="0F3154"/>
+                </a:solidFill>
+                <a:latin typeface="Calibri"/>
               </a:rPr>
               <a:t>Arm’s Length Principle</a:t>
             </a:r>
@@ -6133,6 +7680,7 @@
                 <a:solidFill>
                   <a:srgbClr val="282828"/>
                 </a:solidFill>
+                <a:latin typeface="Calibri"/>
               </a:rPr>
               <a:t>Controlled transactions should mirror independent-party terms</a:t>
             </a:r>
@@ -6144,6 +7692,7 @@
                 <a:solidFill>
                   <a:srgbClr val="282828"/>
                 </a:solidFill>
+                <a:latin typeface="Calibri"/>
               </a:rPr>
               <a:t>Benchmark using reliable market comparables</a:t>
             </a:r>
@@ -6155,6 +7704,7 @@
                 <a:solidFill>
                   <a:srgbClr val="282828"/>
                 </a:solidFill>
+                <a:latin typeface="Calibri"/>
               </a:rPr>
               <a:t>Requires functional analysis: functions, assets, risks (FAR)</a:t>
             </a:r>
@@ -6166,8 +7716,121 @@
                 <a:solidFill>
                   <a:srgbClr val="282828"/>
                 </a:solidFill>
+                <a:latin typeface="Calibri"/>
               </a:rPr>
               <a:t>Consistency with value chain and commercial rationality</a:t>
+            </a:r>
+          </a:p>
+        </p:txBody>
+      </p:sp>
+      <p:sp>
+        <p:nvSpPr>
+          <p:cNvPr id="8" name="Rectangle 7"/>
+          <p:cNvSpPr/>
+          <p:nvPr/>
+        </p:nvSpPr>
+        <p:spPr>
+          <a:xfrm>
+            <a:off x="256032" y="6382512"/>
+            <a:ext cx="11935663" cy="18288"/>
+          </a:xfrm>
+          <a:prstGeom prst="rect">
+            <a:avLst/>
+          </a:prstGeom>
+          <a:solidFill>
+            <a:srgbClr val="CAD8E8"/>
+          </a:solidFill>
+          <a:ln>
+            <a:noFill/>
+          </a:ln>
+        </p:spPr>
+        <p:style>
+          <a:lnRef idx="1">
+            <a:schemeClr val="accent1"/>
+          </a:lnRef>
+          <a:fillRef idx="3">
+            <a:schemeClr val="accent1"/>
+          </a:fillRef>
+          <a:effectRef idx="2">
+            <a:schemeClr val="accent1"/>
+          </a:effectRef>
+          <a:fontRef idx="minor">
+            <a:schemeClr val="lt1"/>
+          </a:fontRef>
+        </p:style>
+        <p:txBody>
+          <a:bodyPr rtlCol="0" anchor="ctr"/>
+          <a:lstStyle/>
+          <a:p>
+            <a:pPr algn="ctr"/>
+          </a:p>
+        </p:txBody>
+      </p:sp>
+      <p:sp>
+        <p:nvSpPr>
+          <p:cNvPr id="9" name="TextBox 8"/>
+          <p:cNvSpPr txBox="1"/>
+          <p:nvPr/>
+        </p:nvSpPr>
+        <p:spPr>
+          <a:xfrm>
+            <a:off x="365760" y="6446520"/>
+            <a:ext cx="6095847" cy="274320"/>
+          </a:xfrm>
+          <a:prstGeom prst="rect">
+            <a:avLst/>
+          </a:prstGeom>
+          <a:noFill/>
+        </p:spPr>
+        <p:txBody>
+          <a:bodyPr wrap="none">
+            <a:spAutoFit/>
+          </a:bodyPr>
+          <a:lstStyle/>
+          <a:p>
+            <a:r>
+              <a:rPr sz="900">
+                <a:solidFill>
+                  <a:srgbClr val="5B6B7C"/>
+                </a:solidFill>
+                <a:latin typeface="Calibri"/>
+              </a:rPr>
+              <a:t>Transfer Pricing Methods</a:t>
+            </a:r>
+          </a:p>
+        </p:txBody>
+      </p:sp>
+      <p:sp>
+        <p:nvSpPr>
+          <p:cNvPr id="10" name="TextBox 9"/>
+          <p:cNvSpPr txBox="1"/>
+          <p:nvPr/>
+        </p:nvSpPr>
+        <p:spPr>
+          <a:xfrm>
+            <a:off x="11185855" y="6446520"/>
+            <a:ext cx="731520" cy="274320"/>
+          </a:xfrm>
+          <a:prstGeom prst="rect">
+            <a:avLst/>
+          </a:prstGeom>
+          <a:noFill/>
+        </p:spPr>
+        <p:txBody>
+          <a:bodyPr wrap="none">
+            <a:spAutoFit/>
+          </a:bodyPr>
+          <a:lstStyle/>
+          <a:p>
+            <a:pPr algn="r"/>
+            <a:r>
+              <a:rPr sz="900">
+                <a:solidFill>
+                  <a:srgbClr val="5B6B7C"/>
+                </a:solidFill>
+                <a:latin typeface="Calibri"/>
+              </a:rPr>
+              <a:t>5</a:t>
             </a:r>
           </a:p>
         </p:txBody>
@@ -6186,7 +7849,7 @@
     <p:bg>
       <p:bgPr>
         <a:solidFill>
-          <a:srgbClr val="F5F8FC"/>
+          <a:srgbClr val="F8FAFC"/>
         </a:solidFill>
         <a:effectLst/>
       </p:bgPr>
@@ -6200,20 +7863,20 @@
       <p:grpSpPr/>
       <p:sp>
         <p:nvSpPr>
-          <p:cNvPr id="6" name="Oval 5"/>
+          <p:cNvPr id="7" name="Oval 6"/>
           <p:cNvSpPr/>
           <p:nvPr/>
         </p:nvSpPr>
         <p:spPr>
           <a:xfrm>
-            <a:off x="-1280160" y="4572000"/>
-            <a:ext cx="2926080" cy="2926080"/>
+            <a:off x="-1097280" y="4846320"/>
+            <a:ext cx="2743200" cy="2743200"/>
           </a:xfrm>
           <a:prstGeom prst="ellipse">
             <a:avLst/>
           </a:prstGeom>
           <a:solidFill>
-            <a:srgbClr val="8CAAC8"/>
+            <a:srgbClr val="CAD8E8"/>
           </a:solidFill>
           <a:ln>
             <a:noFill/>
@@ -6243,20 +7906,20 @@
       </p:sp>
       <p:sp>
         <p:nvSpPr>
-          <p:cNvPr id="5" name="Oval 4"/>
+          <p:cNvPr id="6" name="Oval 5"/>
           <p:cNvSpPr/>
           <p:nvPr/>
         </p:nvSpPr>
         <p:spPr>
           <a:xfrm>
-            <a:off x="9722815" y="-822960"/>
-            <a:ext cx="3291840" cy="3291840"/>
+            <a:off x="9631375" y="-914400"/>
+            <a:ext cx="2926080" cy="2926080"/>
           </a:xfrm>
           <a:prstGeom prst="ellipse">
             <a:avLst/>
           </a:prstGeom>
           <a:solidFill>
-            <a:srgbClr val="005CA0"/>
+            <a:srgbClr val="CAD8E8"/>
           </a:solidFill>
           <a:ln>
             <a:noFill/>
@@ -6286,6 +7949,49 @@
       </p:sp>
       <p:sp>
         <p:nvSpPr>
+          <p:cNvPr id="5" name="Rectangle 4"/>
+          <p:cNvSpPr/>
+          <p:nvPr/>
+        </p:nvSpPr>
+        <p:spPr>
+          <a:xfrm>
+            <a:off x="0" y="0"/>
+            <a:ext cx="12191695" cy="54864"/>
+          </a:xfrm>
+          <a:prstGeom prst="rect">
+            <a:avLst/>
+          </a:prstGeom>
+          <a:solidFill>
+            <a:srgbClr val="0B5394"/>
+          </a:solidFill>
+          <a:ln>
+            <a:noFill/>
+          </a:ln>
+        </p:spPr>
+        <p:style>
+          <a:lnRef idx="1">
+            <a:schemeClr val="accent1"/>
+          </a:lnRef>
+          <a:fillRef idx="3">
+            <a:schemeClr val="accent1"/>
+          </a:fillRef>
+          <a:effectRef idx="2">
+            <a:schemeClr val="accent1"/>
+          </a:effectRef>
+          <a:fontRef idx="minor">
+            <a:schemeClr val="lt1"/>
+          </a:fontRef>
+        </p:style>
+        <p:txBody>
+          <a:bodyPr rtlCol="0" anchor="ctr"/>
+          <a:lstStyle/>
+          <a:p>
+            <a:pPr algn="ctr"/>
+          </a:p>
+        </p:txBody>
+      </p:sp>
+      <p:sp>
+        <p:nvSpPr>
           <p:cNvPr id="4" name="Rectangle 3"/>
           <p:cNvSpPr/>
           <p:nvPr/>
@@ -6293,13 +7999,13 @@
         <p:spPr>
           <a:xfrm>
             <a:off x="0" y="0"/>
-            <a:ext cx="12191695" cy="256032"/>
+            <a:ext cx="256032" cy="6858000"/>
           </a:xfrm>
           <a:prstGeom prst="rect">
             <a:avLst/>
           </a:prstGeom>
           <a:solidFill>
-            <a:srgbClr val="005CA0"/>
+            <a:srgbClr val="0B5394"/>
           </a:solidFill>
           <a:ln>
             <a:noFill/>
@@ -6345,8 +8051,9 @@
             <a:r>
               <a:rPr sz="3200" b="1">
                 <a:solidFill>
-                  <a:srgbClr val="00467F"/>
-                </a:solidFill>
+                  <a:srgbClr val="0F3154"/>
+                </a:solidFill>
+                <a:latin typeface="Calibri"/>
               </a:rPr>
               <a:t>Comparability Analysis</a:t>
             </a:r>
@@ -6374,6 +8081,7 @@
                 <a:solidFill>
                   <a:srgbClr val="282828"/>
                 </a:solidFill>
+                <a:latin typeface="Calibri"/>
               </a:rPr>
               <a:t>Define the controlled transaction and tested party</a:t>
             </a:r>
@@ -6385,6 +8093,7 @@
                 <a:solidFill>
                   <a:srgbClr val="282828"/>
                 </a:solidFill>
+                <a:latin typeface="Calibri"/>
               </a:rPr>
               <a:t>Identify internal or external comparables</a:t>
             </a:r>
@@ -6396,6 +8105,7 @@
                 <a:solidFill>
                   <a:srgbClr val="282828"/>
                 </a:solidFill>
+                <a:latin typeface="Calibri"/>
               </a:rPr>
               <a:t>Assess product, contractual, economic, and strategic factors</a:t>
             </a:r>
@@ -6407,6 +8117,7 @@
                 <a:solidFill>
                   <a:srgbClr val="282828"/>
                 </a:solidFill>
+                <a:latin typeface="Calibri"/>
               </a:rPr>
               <a:t>Adjust for material differences when possible</a:t>
             </a:r>
@@ -6418,8 +8129,121 @@
                 <a:solidFill>
                   <a:srgbClr val="282828"/>
                 </a:solidFill>
+                <a:latin typeface="Calibri"/>
               </a:rPr>
               <a:t>Use ranges (e.g., interquartile) where accepted</a:t>
+            </a:r>
+          </a:p>
+        </p:txBody>
+      </p:sp>
+      <p:sp>
+        <p:nvSpPr>
+          <p:cNvPr id="8" name="Rectangle 7"/>
+          <p:cNvSpPr/>
+          <p:nvPr/>
+        </p:nvSpPr>
+        <p:spPr>
+          <a:xfrm>
+            <a:off x="256032" y="6382512"/>
+            <a:ext cx="11935663" cy="18288"/>
+          </a:xfrm>
+          <a:prstGeom prst="rect">
+            <a:avLst/>
+          </a:prstGeom>
+          <a:solidFill>
+            <a:srgbClr val="CAD8E8"/>
+          </a:solidFill>
+          <a:ln>
+            <a:noFill/>
+          </a:ln>
+        </p:spPr>
+        <p:style>
+          <a:lnRef idx="1">
+            <a:schemeClr val="accent1"/>
+          </a:lnRef>
+          <a:fillRef idx="3">
+            <a:schemeClr val="accent1"/>
+          </a:fillRef>
+          <a:effectRef idx="2">
+            <a:schemeClr val="accent1"/>
+          </a:effectRef>
+          <a:fontRef idx="minor">
+            <a:schemeClr val="lt1"/>
+          </a:fontRef>
+        </p:style>
+        <p:txBody>
+          <a:bodyPr rtlCol="0" anchor="ctr"/>
+          <a:lstStyle/>
+          <a:p>
+            <a:pPr algn="ctr"/>
+          </a:p>
+        </p:txBody>
+      </p:sp>
+      <p:sp>
+        <p:nvSpPr>
+          <p:cNvPr id="9" name="TextBox 8"/>
+          <p:cNvSpPr txBox="1"/>
+          <p:nvPr/>
+        </p:nvSpPr>
+        <p:spPr>
+          <a:xfrm>
+            <a:off x="365760" y="6446520"/>
+            <a:ext cx="6095847" cy="274320"/>
+          </a:xfrm>
+          <a:prstGeom prst="rect">
+            <a:avLst/>
+          </a:prstGeom>
+          <a:noFill/>
+        </p:spPr>
+        <p:txBody>
+          <a:bodyPr wrap="none">
+            <a:spAutoFit/>
+          </a:bodyPr>
+          <a:lstStyle/>
+          <a:p>
+            <a:r>
+              <a:rPr sz="900">
+                <a:solidFill>
+                  <a:srgbClr val="5B6B7C"/>
+                </a:solidFill>
+                <a:latin typeface="Calibri"/>
+              </a:rPr>
+              <a:t>Transfer Pricing Methods</a:t>
+            </a:r>
+          </a:p>
+        </p:txBody>
+      </p:sp>
+      <p:sp>
+        <p:nvSpPr>
+          <p:cNvPr id="10" name="TextBox 9"/>
+          <p:cNvSpPr txBox="1"/>
+          <p:nvPr/>
+        </p:nvSpPr>
+        <p:spPr>
+          <a:xfrm>
+            <a:off x="11185855" y="6446520"/>
+            <a:ext cx="731520" cy="274320"/>
+          </a:xfrm>
+          <a:prstGeom prst="rect">
+            <a:avLst/>
+          </a:prstGeom>
+          <a:noFill/>
+        </p:spPr>
+        <p:txBody>
+          <a:bodyPr wrap="none">
+            <a:spAutoFit/>
+          </a:bodyPr>
+          <a:lstStyle/>
+          <a:p>
+            <a:pPr algn="r"/>
+            <a:r>
+              <a:rPr sz="900">
+                <a:solidFill>
+                  <a:srgbClr val="5B6B7C"/>
+                </a:solidFill>
+                <a:latin typeface="Calibri"/>
+              </a:rPr>
+              <a:t>6</a:t>
             </a:r>
           </a:p>
         </p:txBody>
@@ -6438,7 +8262,7 @@
     <p:bg>
       <p:bgPr>
         <a:solidFill>
-          <a:srgbClr val="F5F8FC"/>
+          <a:srgbClr val="F8FAFC"/>
         </a:solidFill>
         <a:effectLst/>
       </p:bgPr>
@@ -6452,20 +8276,20 @@
       <p:grpSpPr/>
       <p:sp>
         <p:nvSpPr>
-          <p:cNvPr id="11" name="Oval 10"/>
+          <p:cNvPr id="12" name="Oval 11"/>
           <p:cNvSpPr/>
           <p:nvPr/>
         </p:nvSpPr>
         <p:spPr>
           <a:xfrm>
-            <a:off x="-1280160" y="4572000"/>
-            <a:ext cx="2926080" cy="2926080"/>
+            <a:off x="-1097280" y="4846320"/>
+            <a:ext cx="2743200" cy="2743200"/>
           </a:xfrm>
           <a:prstGeom prst="ellipse">
             <a:avLst/>
           </a:prstGeom>
           <a:solidFill>
-            <a:srgbClr val="8CAAC8"/>
+            <a:srgbClr val="CAD8E8"/>
           </a:solidFill>
           <a:ln>
             <a:noFill/>
@@ -6495,20 +8319,20 @@
       </p:sp>
       <p:sp>
         <p:nvSpPr>
-          <p:cNvPr id="10" name="Oval 9"/>
+          <p:cNvPr id="11" name="Oval 10"/>
           <p:cNvSpPr/>
           <p:nvPr/>
         </p:nvSpPr>
         <p:spPr>
           <a:xfrm>
-            <a:off x="9722815" y="-822960"/>
-            <a:ext cx="3291840" cy="3291840"/>
+            <a:off x="9631375" y="-914400"/>
+            <a:ext cx="2926080" cy="2926080"/>
           </a:xfrm>
           <a:prstGeom prst="ellipse">
             <a:avLst/>
           </a:prstGeom>
           <a:solidFill>
-            <a:srgbClr val="005CA0"/>
+            <a:srgbClr val="CAD8E8"/>
           </a:solidFill>
           <a:ln>
             <a:noFill/>
@@ -6538,6 +8362,49 @@
       </p:sp>
       <p:sp>
         <p:nvSpPr>
+          <p:cNvPr id="10" name="Rectangle 9"/>
+          <p:cNvSpPr/>
+          <p:nvPr/>
+        </p:nvSpPr>
+        <p:spPr>
+          <a:xfrm>
+            <a:off x="0" y="0"/>
+            <a:ext cx="12191695" cy="54864"/>
+          </a:xfrm>
+          <a:prstGeom prst="rect">
+            <a:avLst/>
+          </a:prstGeom>
+          <a:solidFill>
+            <a:srgbClr val="0B5394"/>
+          </a:solidFill>
+          <a:ln>
+            <a:noFill/>
+          </a:ln>
+        </p:spPr>
+        <p:style>
+          <a:lnRef idx="1">
+            <a:schemeClr val="accent1"/>
+          </a:lnRef>
+          <a:fillRef idx="3">
+            <a:schemeClr val="accent1"/>
+          </a:fillRef>
+          <a:effectRef idx="2">
+            <a:schemeClr val="accent1"/>
+          </a:effectRef>
+          <a:fontRef idx="minor">
+            <a:schemeClr val="lt1"/>
+          </a:fontRef>
+        </p:style>
+        <p:txBody>
+          <a:bodyPr rtlCol="0" anchor="ctr"/>
+          <a:lstStyle/>
+          <a:p>
+            <a:pPr algn="ctr"/>
+          </a:p>
+        </p:txBody>
+      </p:sp>
+      <p:sp>
+        <p:nvSpPr>
           <p:cNvPr id="9" name="Rectangle 8"/>
           <p:cNvSpPr/>
           <p:nvPr/>
@@ -6545,13 +8412,13 @@
         <p:spPr>
           <a:xfrm>
             <a:off x="0" y="0"/>
-            <a:ext cx="12191695" cy="256032"/>
+            <a:ext cx="256032" cy="6858000"/>
           </a:xfrm>
           <a:prstGeom prst="rect">
             <a:avLst/>
           </a:prstGeom>
           <a:solidFill>
-            <a:srgbClr val="005CA0"/>
+            <a:srgbClr val="0B5394"/>
           </a:solidFill>
           <a:ln>
             <a:noFill/>
@@ -6599,6 +8466,7 @@
                 <a:solidFill>
                   <a:srgbClr val="00467F"/>
                 </a:solidFill>
+                <a:latin typeface="Calibri"/>
               </a:rPr>
               <a:t>Selecting the Most Appropriate Method</a:t>
             </a:r>
@@ -6627,10 +8495,11 @@
           <a:p>
             <a:pPr/>
             <a:r>
-              <a:rPr sz="2200" b="0">
-                <a:solidFill>
-                  <a:srgbClr val="282828"/>
-                </a:solidFill>
+              <a:rPr sz="2200" b="1">
+                <a:solidFill>
+                  <a:srgbClr val="0F3154"/>
+                </a:solidFill>
+                <a:latin typeface="Calibri"/>
               </a:rPr>
               <a:t>Choose the method that best reflects the transaction and data quality</a:t>
             </a:r>
@@ -6638,10 +8507,11 @@
           <a:p>
             <a:pPr/>
             <a:r>
-              <a:rPr sz="2200" b="0">
-                <a:solidFill>
-                  <a:srgbClr val="282828"/>
-                </a:solidFill>
+              <a:rPr sz="2200" b="1">
+                <a:solidFill>
+                  <a:srgbClr val="0F3154"/>
+                </a:solidFill>
+                <a:latin typeface="Calibri"/>
               </a:rPr>
               <a:t>Traditional transaction methods preferred when reliable comparables exist</a:t>
             </a:r>
@@ -6649,10 +8519,11 @@
           <a:p>
             <a:pPr/>
             <a:r>
-              <a:rPr sz="2200" b="0">
-                <a:solidFill>
-                  <a:srgbClr val="282828"/>
-                </a:solidFill>
+              <a:rPr sz="2200" b="1">
+                <a:solidFill>
+                  <a:srgbClr val="0F3154"/>
+                </a:solidFill>
+                <a:latin typeface="Calibri"/>
               </a:rPr>
               <a:t>Consider degree of comparability and availability of data</a:t>
             </a:r>
@@ -6660,10 +8531,11 @@
           <a:p>
             <a:pPr/>
             <a:r>
-              <a:rPr sz="2200" b="0">
-                <a:solidFill>
-                  <a:srgbClr val="282828"/>
-                </a:solidFill>
+              <a:rPr sz="2200" b="1">
+                <a:solidFill>
+                  <a:srgbClr val="0F3154"/>
+                </a:solidFill>
+                <a:latin typeface="Calibri"/>
               </a:rPr>
               <a:t>Apply a consistent approach over time</a:t>
             </a:r>
@@ -6671,10 +8543,11 @@
           <a:p>
             <a:pPr/>
             <a:r>
-              <a:rPr sz="2200" b="0">
-                <a:solidFill>
-                  <a:srgbClr val="282828"/>
-                </a:solidFill>
+              <a:rPr sz="2200" b="1">
+                <a:solidFill>
+                  <a:srgbClr val="0F3154"/>
+                </a:solidFill>
+                <a:latin typeface="Calibri"/>
               </a:rPr>
               <a:t>Document the rationale for selection</a:t>
             </a:r>
@@ -6727,6 +8600,7 @@
                 <a:solidFill>
                   <a:srgbClr val="00467F"/>
                 </a:solidFill>
+                <a:latin typeface="Calibri"/>
               </a:rPr>
               <a:t>Transaction type</a:t>
             </a:r>
@@ -6779,6 +8653,7 @@
                 <a:solidFill>
                   <a:srgbClr val="00467F"/>
                 </a:solidFill>
+                <a:latin typeface="Calibri"/>
               </a:rPr>
               <a:t>Data quality</a:t>
             </a:r>
@@ -6831,6 +8706,7 @@
                 <a:solidFill>
                   <a:srgbClr val="00467F"/>
                 </a:solidFill>
+                <a:latin typeface="Calibri"/>
               </a:rPr>
               <a:t>Best method</a:t>
             </a:r>
@@ -6907,6 +8783,118 @@
           </a:fontRef>
         </p:style>
       </p:cxnSp>
+      <p:sp>
+        <p:nvSpPr>
+          <p:cNvPr id="13" name="Rectangle 12"/>
+          <p:cNvSpPr/>
+          <p:nvPr/>
+        </p:nvSpPr>
+        <p:spPr>
+          <a:xfrm>
+            <a:off x="256032" y="6382512"/>
+            <a:ext cx="11935663" cy="18288"/>
+          </a:xfrm>
+          <a:prstGeom prst="rect">
+            <a:avLst/>
+          </a:prstGeom>
+          <a:solidFill>
+            <a:srgbClr val="CAD8E8"/>
+          </a:solidFill>
+          <a:ln>
+            <a:noFill/>
+          </a:ln>
+        </p:spPr>
+        <p:style>
+          <a:lnRef idx="1">
+            <a:schemeClr val="accent1"/>
+          </a:lnRef>
+          <a:fillRef idx="3">
+            <a:schemeClr val="accent1"/>
+          </a:fillRef>
+          <a:effectRef idx="2">
+            <a:schemeClr val="accent1"/>
+          </a:effectRef>
+          <a:fontRef idx="minor">
+            <a:schemeClr val="lt1"/>
+          </a:fontRef>
+        </p:style>
+        <p:txBody>
+          <a:bodyPr rtlCol="0" anchor="ctr"/>
+          <a:lstStyle/>
+          <a:p>
+            <a:pPr algn="ctr"/>
+          </a:p>
+        </p:txBody>
+      </p:sp>
+      <p:sp>
+        <p:nvSpPr>
+          <p:cNvPr id="14" name="TextBox 13"/>
+          <p:cNvSpPr txBox="1"/>
+          <p:nvPr/>
+        </p:nvSpPr>
+        <p:spPr>
+          <a:xfrm>
+            <a:off x="365760" y="6446520"/>
+            <a:ext cx="6095847" cy="274320"/>
+          </a:xfrm>
+          <a:prstGeom prst="rect">
+            <a:avLst/>
+          </a:prstGeom>
+          <a:noFill/>
+        </p:spPr>
+        <p:txBody>
+          <a:bodyPr wrap="none">
+            <a:spAutoFit/>
+          </a:bodyPr>
+          <a:lstStyle/>
+          <a:p>
+            <a:r>
+              <a:rPr sz="900">
+                <a:solidFill>
+                  <a:srgbClr val="5B6B7C"/>
+                </a:solidFill>
+                <a:latin typeface="Calibri"/>
+              </a:rPr>
+              <a:t>Transfer Pricing Methods</a:t>
+            </a:r>
+          </a:p>
+        </p:txBody>
+      </p:sp>
+      <p:sp>
+        <p:nvSpPr>
+          <p:cNvPr id="15" name="TextBox 14"/>
+          <p:cNvSpPr txBox="1"/>
+          <p:nvPr/>
+        </p:nvSpPr>
+        <p:spPr>
+          <a:xfrm>
+            <a:off x="11185855" y="6446520"/>
+            <a:ext cx="731520" cy="274320"/>
+          </a:xfrm>
+          <a:prstGeom prst="rect">
+            <a:avLst/>
+          </a:prstGeom>
+          <a:noFill/>
+        </p:spPr>
+        <p:txBody>
+          <a:bodyPr wrap="none">
+            <a:spAutoFit/>
+          </a:bodyPr>
+          <a:lstStyle/>
+          <a:p>
+            <a:pPr algn="r"/>
+            <a:r>
+              <a:rPr sz="900">
+                <a:solidFill>
+                  <a:srgbClr val="5B6B7C"/>
+                </a:solidFill>
+                <a:latin typeface="Calibri"/>
+              </a:rPr>
+              <a:t>7</a:t>
+            </a:r>
+          </a:p>
+        </p:txBody>
+      </p:sp>
     </p:spTree>
   </p:cSld>
   <p:clrMapOvr>
@@ -6921,7 +8909,7 @@
     <p:bg>
       <p:bgPr>
         <a:solidFill>
-          <a:srgbClr val="F5F8FC"/>
+          <a:srgbClr val="F8FAFC"/>
         </a:solidFill>
         <a:effectLst/>
       </p:bgPr>
@@ -6935,20 +8923,20 @@
       <p:grpSpPr/>
       <p:sp>
         <p:nvSpPr>
-          <p:cNvPr id="6" name="Oval 5"/>
+          <p:cNvPr id="7" name="Oval 6"/>
           <p:cNvSpPr/>
           <p:nvPr/>
         </p:nvSpPr>
         <p:spPr>
           <a:xfrm>
-            <a:off x="-1280160" y="4572000"/>
-            <a:ext cx="2926080" cy="2926080"/>
+            <a:off x="-1097280" y="4846320"/>
+            <a:ext cx="2743200" cy="2743200"/>
           </a:xfrm>
           <a:prstGeom prst="ellipse">
             <a:avLst/>
           </a:prstGeom>
           <a:solidFill>
-            <a:srgbClr val="8CAAC8"/>
+            <a:srgbClr val="CAD8E8"/>
           </a:solidFill>
           <a:ln>
             <a:noFill/>
@@ -6978,20 +8966,20 @@
       </p:sp>
       <p:sp>
         <p:nvSpPr>
-          <p:cNvPr id="5" name="Oval 4"/>
+          <p:cNvPr id="6" name="Oval 5"/>
           <p:cNvSpPr/>
           <p:nvPr/>
         </p:nvSpPr>
         <p:spPr>
           <a:xfrm>
-            <a:off x="9722815" y="-822960"/>
-            <a:ext cx="3291840" cy="3291840"/>
+            <a:off x="9631375" y="-914400"/>
+            <a:ext cx="2926080" cy="2926080"/>
           </a:xfrm>
           <a:prstGeom prst="ellipse">
             <a:avLst/>
           </a:prstGeom>
           <a:solidFill>
-            <a:srgbClr val="005CA0"/>
+            <a:srgbClr val="CAD8E8"/>
           </a:solidFill>
           <a:ln>
             <a:noFill/>
@@ -7021,6 +9009,49 @@
       </p:sp>
       <p:sp>
         <p:nvSpPr>
+          <p:cNvPr id="5" name="Rectangle 4"/>
+          <p:cNvSpPr/>
+          <p:nvPr/>
+        </p:nvSpPr>
+        <p:spPr>
+          <a:xfrm>
+            <a:off x="0" y="0"/>
+            <a:ext cx="12191695" cy="54864"/>
+          </a:xfrm>
+          <a:prstGeom prst="rect">
+            <a:avLst/>
+          </a:prstGeom>
+          <a:solidFill>
+            <a:srgbClr val="0B5394"/>
+          </a:solidFill>
+          <a:ln>
+            <a:noFill/>
+          </a:ln>
+        </p:spPr>
+        <p:style>
+          <a:lnRef idx="1">
+            <a:schemeClr val="accent1"/>
+          </a:lnRef>
+          <a:fillRef idx="3">
+            <a:schemeClr val="accent1"/>
+          </a:fillRef>
+          <a:effectRef idx="2">
+            <a:schemeClr val="accent1"/>
+          </a:effectRef>
+          <a:fontRef idx="minor">
+            <a:schemeClr val="lt1"/>
+          </a:fontRef>
+        </p:style>
+        <p:txBody>
+          <a:bodyPr rtlCol="0" anchor="ctr"/>
+          <a:lstStyle/>
+          <a:p>
+            <a:pPr algn="ctr"/>
+          </a:p>
+        </p:txBody>
+      </p:sp>
+      <p:sp>
+        <p:nvSpPr>
           <p:cNvPr id="4" name="Rectangle 3"/>
           <p:cNvSpPr/>
           <p:nvPr/>
@@ -7028,13 +9059,13 @@
         <p:spPr>
           <a:xfrm>
             <a:off x="0" y="0"/>
-            <a:ext cx="12191695" cy="256032"/>
+            <a:ext cx="256032" cy="6858000"/>
           </a:xfrm>
           <a:prstGeom prst="rect">
             <a:avLst/>
           </a:prstGeom>
           <a:solidFill>
-            <a:srgbClr val="005CA0"/>
+            <a:srgbClr val="0B5394"/>
           </a:solidFill>
           <a:ln>
             <a:noFill/>
@@ -7080,8 +9111,9 @@
             <a:r>
               <a:rPr sz="3200" b="1">
                 <a:solidFill>
-                  <a:srgbClr val="00467F"/>
-                </a:solidFill>
+                  <a:srgbClr val="0F3154"/>
+                </a:solidFill>
+                <a:latin typeface="Calibri"/>
               </a:rPr>
               <a:t>Comparable Uncontrolled Price (CUP) Method</a:t>
             </a:r>
@@ -7109,6 +9141,7 @@
                 <a:solidFill>
                   <a:srgbClr val="282828"/>
                 </a:solidFill>
+                <a:latin typeface="Calibri"/>
               </a:rPr>
               <a:t>Compares controlled price to price in comparable independent transactions</a:t>
             </a:r>
@@ -7120,6 +9153,7 @@
                 <a:solidFill>
                   <a:srgbClr val="282828"/>
                 </a:solidFill>
+                <a:latin typeface="Calibri"/>
               </a:rPr>
               <a:t>Most direct and reliable method when high-quality comparables exist</a:t>
             </a:r>
@@ -7131,6 +9165,7 @@
                 <a:solidFill>
                   <a:srgbClr val="282828"/>
                 </a:solidFill>
+                <a:latin typeface="Calibri"/>
               </a:rPr>
               <a:t>Commonly used for commodities, financial transactions, and licenses</a:t>
             </a:r>
@@ -7142,8 +9177,121 @@
                 <a:solidFill>
                   <a:srgbClr val="282828"/>
                 </a:solidFill>
+                <a:latin typeface="Calibri"/>
               </a:rPr>
               <a:t>Requires close product and contractual comparability</a:t>
+            </a:r>
+          </a:p>
+        </p:txBody>
+      </p:sp>
+      <p:sp>
+        <p:nvSpPr>
+          <p:cNvPr id="8" name="Rectangle 7"/>
+          <p:cNvSpPr/>
+          <p:nvPr/>
+        </p:nvSpPr>
+        <p:spPr>
+          <a:xfrm>
+            <a:off x="256032" y="6382512"/>
+            <a:ext cx="11935663" cy="18288"/>
+          </a:xfrm>
+          <a:prstGeom prst="rect">
+            <a:avLst/>
+          </a:prstGeom>
+          <a:solidFill>
+            <a:srgbClr val="CAD8E8"/>
+          </a:solidFill>
+          <a:ln>
+            <a:noFill/>
+          </a:ln>
+        </p:spPr>
+        <p:style>
+          <a:lnRef idx="1">
+            <a:schemeClr val="accent1"/>
+          </a:lnRef>
+          <a:fillRef idx="3">
+            <a:schemeClr val="accent1"/>
+          </a:fillRef>
+          <a:effectRef idx="2">
+            <a:schemeClr val="accent1"/>
+          </a:effectRef>
+          <a:fontRef idx="minor">
+            <a:schemeClr val="lt1"/>
+          </a:fontRef>
+        </p:style>
+        <p:txBody>
+          <a:bodyPr rtlCol="0" anchor="ctr"/>
+          <a:lstStyle/>
+          <a:p>
+            <a:pPr algn="ctr"/>
+          </a:p>
+        </p:txBody>
+      </p:sp>
+      <p:sp>
+        <p:nvSpPr>
+          <p:cNvPr id="9" name="TextBox 8"/>
+          <p:cNvSpPr txBox="1"/>
+          <p:nvPr/>
+        </p:nvSpPr>
+        <p:spPr>
+          <a:xfrm>
+            <a:off x="365760" y="6446520"/>
+            <a:ext cx="6095847" cy="274320"/>
+          </a:xfrm>
+          <a:prstGeom prst="rect">
+            <a:avLst/>
+          </a:prstGeom>
+          <a:noFill/>
+        </p:spPr>
+        <p:txBody>
+          <a:bodyPr wrap="none">
+            <a:spAutoFit/>
+          </a:bodyPr>
+          <a:lstStyle/>
+          <a:p>
+            <a:r>
+              <a:rPr sz="900">
+                <a:solidFill>
+                  <a:srgbClr val="5B6B7C"/>
+                </a:solidFill>
+                <a:latin typeface="Calibri"/>
+              </a:rPr>
+              <a:t>Transfer Pricing Methods</a:t>
+            </a:r>
+          </a:p>
+        </p:txBody>
+      </p:sp>
+      <p:sp>
+        <p:nvSpPr>
+          <p:cNvPr id="10" name="TextBox 9"/>
+          <p:cNvSpPr txBox="1"/>
+          <p:nvPr/>
+        </p:nvSpPr>
+        <p:spPr>
+          <a:xfrm>
+            <a:off x="11185855" y="6446520"/>
+            <a:ext cx="731520" cy="274320"/>
+          </a:xfrm>
+          <a:prstGeom prst="rect">
+            <a:avLst/>
+          </a:prstGeom>
+          <a:noFill/>
+        </p:spPr>
+        <p:txBody>
+          <a:bodyPr wrap="none">
+            <a:spAutoFit/>
+          </a:bodyPr>
+          <a:lstStyle/>
+          <a:p>
+            <a:pPr algn="r"/>
+            <a:r>
+              <a:rPr sz="900">
+                <a:solidFill>
+                  <a:srgbClr val="5B6B7C"/>
+                </a:solidFill>
+                <a:latin typeface="Calibri"/>
+              </a:rPr>
+              <a:t>8</a:t>
             </a:r>
           </a:p>
         </p:txBody>
@@ -7162,7 +9310,7 @@
     <p:bg>
       <p:bgPr>
         <a:solidFill>
-          <a:srgbClr val="F5F8FC"/>
+          <a:srgbClr val="F8FAFC"/>
         </a:solidFill>
         <a:effectLst/>
       </p:bgPr>
@@ -7176,20 +9324,20 @@
       <p:grpSpPr/>
       <p:sp>
         <p:nvSpPr>
-          <p:cNvPr id="6" name="Oval 5"/>
+          <p:cNvPr id="7" name="Oval 6"/>
           <p:cNvSpPr/>
           <p:nvPr/>
         </p:nvSpPr>
         <p:spPr>
           <a:xfrm>
-            <a:off x="-1280160" y="4572000"/>
-            <a:ext cx="2926080" cy="2926080"/>
+            <a:off x="-1097280" y="4846320"/>
+            <a:ext cx="2743200" cy="2743200"/>
           </a:xfrm>
           <a:prstGeom prst="ellipse">
             <a:avLst/>
           </a:prstGeom>
           <a:solidFill>
-            <a:srgbClr val="8CAAC8"/>
+            <a:srgbClr val="CAD8E8"/>
           </a:solidFill>
           <a:ln>
             <a:noFill/>
@@ -7219,20 +9367,20 @@
       </p:sp>
       <p:sp>
         <p:nvSpPr>
-          <p:cNvPr id="5" name="Oval 4"/>
+          <p:cNvPr id="6" name="Oval 5"/>
           <p:cNvSpPr/>
           <p:nvPr/>
         </p:nvSpPr>
         <p:spPr>
           <a:xfrm>
-            <a:off x="9722815" y="-822960"/>
-            <a:ext cx="3291840" cy="3291840"/>
+            <a:off x="9631375" y="-914400"/>
+            <a:ext cx="2926080" cy="2926080"/>
           </a:xfrm>
           <a:prstGeom prst="ellipse">
             <a:avLst/>
           </a:prstGeom>
           <a:solidFill>
-            <a:srgbClr val="005CA0"/>
+            <a:srgbClr val="CAD8E8"/>
           </a:solidFill>
           <a:ln>
             <a:noFill/>
@@ -7262,6 +9410,49 @@
       </p:sp>
       <p:sp>
         <p:nvSpPr>
+          <p:cNvPr id="5" name="Rectangle 4"/>
+          <p:cNvSpPr/>
+          <p:nvPr/>
+        </p:nvSpPr>
+        <p:spPr>
+          <a:xfrm>
+            <a:off x="0" y="0"/>
+            <a:ext cx="12191695" cy="54864"/>
+          </a:xfrm>
+          <a:prstGeom prst="rect">
+            <a:avLst/>
+          </a:prstGeom>
+          <a:solidFill>
+            <a:srgbClr val="0B5394"/>
+          </a:solidFill>
+          <a:ln>
+            <a:noFill/>
+          </a:ln>
+        </p:spPr>
+        <p:style>
+          <a:lnRef idx="1">
+            <a:schemeClr val="accent1"/>
+          </a:lnRef>
+          <a:fillRef idx="3">
+            <a:schemeClr val="accent1"/>
+          </a:fillRef>
+          <a:effectRef idx="2">
+            <a:schemeClr val="accent1"/>
+          </a:effectRef>
+          <a:fontRef idx="minor">
+            <a:schemeClr val="lt1"/>
+          </a:fontRef>
+        </p:style>
+        <p:txBody>
+          <a:bodyPr rtlCol="0" anchor="ctr"/>
+          <a:lstStyle/>
+          <a:p>
+            <a:pPr algn="ctr"/>
+          </a:p>
+        </p:txBody>
+      </p:sp>
+      <p:sp>
+        <p:nvSpPr>
           <p:cNvPr id="4" name="Rectangle 3"/>
           <p:cNvSpPr/>
           <p:nvPr/>
@@ -7269,13 +9460,13 @@
         <p:spPr>
           <a:xfrm>
             <a:off x="0" y="0"/>
-            <a:ext cx="12191695" cy="256032"/>
+            <a:ext cx="256032" cy="6858000"/>
           </a:xfrm>
           <a:prstGeom prst="rect">
             <a:avLst/>
           </a:prstGeom>
           <a:solidFill>
-            <a:srgbClr val="005CA0"/>
+            <a:srgbClr val="0B5394"/>
           </a:solidFill>
           <a:ln>
             <a:noFill/>
@@ -7321,8 +9512,9 @@
             <a:r>
               <a:rPr sz="3200" b="1">
                 <a:solidFill>
-                  <a:srgbClr val="00467F"/>
-                </a:solidFill>
+                  <a:srgbClr val="0F3154"/>
+                </a:solidFill>
+                <a:latin typeface="Calibri"/>
               </a:rPr>
               <a:t>Resale Price Method</a:t>
             </a:r>
@@ -7350,6 +9542,7 @@
                 <a:solidFill>
                   <a:srgbClr val="282828"/>
                 </a:solidFill>
+                <a:latin typeface="Calibri"/>
               </a:rPr>
               <a:t>Starts with resale price to independent customers</a:t>
             </a:r>
@@ -7361,6 +9554,7 @@
                 <a:solidFill>
                   <a:srgbClr val="282828"/>
                 </a:solidFill>
+                <a:latin typeface="Calibri"/>
               </a:rPr>
               <a:t>Subtracts an arm’s length gross margin</a:t>
             </a:r>
@@ -7372,6 +9566,7 @@
                 <a:solidFill>
                   <a:srgbClr val="282828"/>
                 </a:solidFill>
+                <a:latin typeface="Calibri"/>
               </a:rPr>
               <a:t>Used for routine distributors without significant value-added</a:t>
             </a:r>
@@ -7383,8 +9578,121 @@
                 <a:solidFill>
                   <a:srgbClr val="282828"/>
                 </a:solidFill>
+                <a:latin typeface="Calibri"/>
               </a:rPr>
               <a:t>Adjust for functions, risks, and market differences</a:t>
+            </a:r>
+          </a:p>
+        </p:txBody>
+      </p:sp>
+      <p:sp>
+        <p:nvSpPr>
+          <p:cNvPr id="8" name="Rectangle 7"/>
+          <p:cNvSpPr/>
+          <p:nvPr/>
+        </p:nvSpPr>
+        <p:spPr>
+          <a:xfrm>
+            <a:off x="256032" y="6382512"/>
+            <a:ext cx="11935663" cy="18288"/>
+          </a:xfrm>
+          <a:prstGeom prst="rect">
+            <a:avLst/>
+          </a:prstGeom>
+          <a:solidFill>
+            <a:srgbClr val="CAD8E8"/>
+          </a:solidFill>
+          <a:ln>
+            <a:noFill/>
+          </a:ln>
+        </p:spPr>
+        <p:style>
+          <a:lnRef idx="1">
+            <a:schemeClr val="accent1"/>
+          </a:lnRef>
+          <a:fillRef idx="3">
+            <a:schemeClr val="accent1"/>
+          </a:fillRef>
+          <a:effectRef idx="2">
+            <a:schemeClr val="accent1"/>
+          </a:effectRef>
+          <a:fontRef idx="minor">
+            <a:schemeClr val="lt1"/>
+          </a:fontRef>
+        </p:style>
+        <p:txBody>
+          <a:bodyPr rtlCol="0" anchor="ctr"/>
+          <a:lstStyle/>
+          <a:p>
+            <a:pPr algn="ctr"/>
+          </a:p>
+        </p:txBody>
+      </p:sp>
+      <p:sp>
+        <p:nvSpPr>
+          <p:cNvPr id="9" name="TextBox 8"/>
+          <p:cNvSpPr txBox="1"/>
+          <p:nvPr/>
+        </p:nvSpPr>
+        <p:spPr>
+          <a:xfrm>
+            <a:off x="365760" y="6446520"/>
+            <a:ext cx="6095847" cy="274320"/>
+          </a:xfrm>
+          <a:prstGeom prst="rect">
+            <a:avLst/>
+          </a:prstGeom>
+          <a:noFill/>
+        </p:spPr>
+        <p:txBody>
+          <a:bodyPr wrap="none">
+            <a:spAutoFit/>
+          </a:bodyPr>
+          <a:lstStyle/>
+          <a:p>
+            <a:r>
+              <a:rPr sz="900">
+                <a:solidFill>
+                  <a:srgbClr val="5B6B7C"/>
+                </a:solidFill>
+                <a:latin typeface="Calibri"/>
+              </a:rPr>
+              <a:t>Transfer Pricing Methods</a:t>
+            </a:r>
+          </a:p>
+        </p:txBody>
+      </p:sp>
+      <p:sp>
+        <p:nvSpPr>
+          <p:cNvPr id="10" name="TextBox 9"/>
+          <p:cNvSpPr txBox="1"/>
+          <p:nvPr/>
+        </p:nvSpPr>
+        <p:spPr>
+          <a:xfrm>
+            <a:off x="11185855" y="6446520"/>
+            <a:ext cx="731520" cy="274320"/>
+          </a:xfrm>
+          <a:prstGeom prst="rect">
+            <a:avLst/>
+          </a:prstGeom>
+          <a:noFill/>
+        </p:spPr>
+        <p:txBody>
+          <a:bodyPr wrap="none">
+            <a:spAutoFit/>
+          </a:bodyPr>
+          <a:lstStyle/>
+          <a:p>
+            <a:pPr algn="r"/>
+            <a:r>
+              <a:rPr sz="900">
+                <a:solidFill>
+                  <a:srgbClr val="5B6B7C"/>
+                </a:solidFill>
+                <a:latin typeface="Calibri"/>
+              </a:rPr>
+              <a:t>9</a:t>
             </a:r>
           </a:p>
         </p:txBody>

</xml_diff>